<commit_message>
Innenraum an Referenzbild angepasst: Skizze, Prompts, Folientexte; glamouroese KI-Innenbilder entfernt
Co-Authored-By: Claude Sonnet 5.5 <noreply@anthropic.com>
Claude-Session: https://claude.ai/code/session_01HJGZfxHv7bzYyqdLwg8aFJ
</commit_message>
<xml_diff>
--- a/praesentation/Neue-Mitte-Werlte_Baufeld3_6-Wohnungen_Gastro-EG.pptx
+++ b/praesentation/Neue-Mitte-Werlte_Baufeld3_6-Wohnungen_Gastro-EG.pptx
@@ -4865,7 +4865,7 @@
         <p:spPr>
           <a:xfrm>
             <a:off x="548640" y="1325880"/>
-            <a:ext cx="5408676" cy="2080260"/>
+            <a:ext cx="5408676" cy="3353379"/>
           </a:xfrm>
           <a:prstGeom prst="rect">
             <a:avLst/>
@@ -4889,55 +4889,7 @@
         <p:spPr>
           <a:xfrm>
             <a:off x="6231636" y="1325880"/>
-            <a:ext cx="5408676" cy="2080260"/>
-          </a:xfrm>
-          <a:prstGeom prst="rect">
-            <a:avLst/>
-          </a:prstGeom>
-        </p:spPr>
-      </p:pic>
-      <p:pic>
-        <p:nvPicPr>
-          <p:cNvPr id="7" name="Image 2" descr="Visualisierung 3">    </p:cNvPr>
-          <p:cNvPicPr>
-            <a:picLocks noChangeAspect="1"/>
-          </p:cNvPicPr>
-          <p:nvPr/>
-        </p:nvPicPr>
-        <p:blipFill>
-          <a:blip r:embed="rId3"/>
-          <a:stretch>
-            <a:fillRect/>
-          </a:stretch>
-        </p:blipFill>
-        <p:spPr>
-          <a:xfrm>
-            <a:off x="548640" y="3680460"/>
-            <a:ext cx="5408676" cy="2080260"/>
-          </a:xfrm>
-          <a:prstGeom prst="rect">
-            <a:avLst/>
-          </a:prstGeom>
-        </p:spPr>
-      </p:pic>
-      <p:pic>
-        <p:nvPicPr>
-          <p:cNvPr id="8" name="Image 3" descr="Visualisierung 4">    </p:cNvPr>
-          <p:cNvPicPr>
-            <a:picLocks noChangeAspect="1"/>
-          </p:cNvPicPr>
-          <p:nvPr/>
-        </p:nvPicPr>
-        <p:blipFill>
-          <a:blip r:embed="rId4"/>
-          <a:stretch>
-            <a:fillRect/>
-          </a:stretch>
-        </p:blipFill>
-        <p:spPr>
-          <a:xfrm>
-            <a:off x="6231636" y="3680460"/>
-            <a:ext cx="5408676" cy="2080260"/>
+            <a:ext cx="5408676" cy="3353379"/>
           </a:xfrm>
           <a:prstGeom prst="rect">
             <a:avLst/>
@@ -4946,7 +4898,7 @@
       </p:pic>
       <p:sp>
         <p:nvSpPr>
-          <p:cNvPr id="9" name="Text 2"/>
+          <p:cNvPr id="7" name="Text 2"/>
           <p:cNvSpPr txBox="1"/>
           <p:nvPr/>
         </p:nvSpPr>
@@ -36673,7 +36625,7 @@
                 <a:ea typeface="Calibri" pitchFamily="34" charset="-122"/>
                 <a:cs typeface="Calibri" pitchFamily="34" charset="-120"/>
               </a:rPr>
-              <a:t>KI-Visualisierung</a:t>
+              <a:t>Referenz für Stimmung</a:t>
             </a:r>
             <a:endParaRPr lang="en-US" sz="1200" dirty="0"/>
           </a:p>
@@ -36829,7 +36781,7 @@
                 <a:ea typeface="Calibri" pitchFamily="34" charset="-122"/>
                 <a:cs typeface="Calibri" pitchFamily="34" charset="-120"/>
               </a:rPr>
-              <a:t>10 Barhocker, Lounge, beleuchtete Backbar</a:t>
+              <a:t>10 Barhocker, Polsterbänke, beleuchtete Backbar</a:t>
             </a:r>
             <a:endParaRPr lang="en-US" sz="1300" dirty="0"/>
           </a:p>
@@ -36907,7 +36859,7 @@
                 <a:ea typeface="Calibri" pitchFamily="34" charset="-122"/>
                 <a:cs typeface="Calibri" pitchFamily="34" charset="-120"/>
               </a:rPr>
-              <a:t>Dunkelgrün, Terrazzo, Eiche, Messing, Stahl</a:t>
+              <a:t>Olivgrün, Cognac-Samt, Bordeaux, Eiche, schwarzer Stahl</a:t>
             </a:r>
             <a:endParaRPr lang="en-US" sz="1300" dirty="0"/>
           </a:p>

</xml_diff>

<commit_message>
Neue KI-Bilder (Holz-Penthouse mit Terrasse, Innenraum im Referenzstil) in die Praesentation eingebaut
Co-Authored-By: Claude Sonnet 5.5 <noreply@anthropic.com>
Claude-Session: https://claude.ai/code/session_01HJGZfxHv7bzYyqdLwg8aFJ
</commit_message>
<xml_diff>
--- a/praesentation/Neue-Mitte-Werlte_Baufeld3_6-Wohnungen_Gastro-EG.pptx
+++ b/praesentation/Neue-Mitte-Werlte_Baufeld3_6-Wohnungen_Gastro-EG.pptx
@@ -4865,7 +4865,7 @@
         <p:spPr>
           <a:xfrm>
             <a:off x="548640" y="1325880"/>
-            <a:ext cx="5408676" cy="3353379"/>
+            <a:ext cx="3514344" cy="2080260"/>
           </a:xfrm>
           <a:prstGeom prst="rect">
             <a:avLst/>
@@ -4888,8 +4888,80 @@
         </p:blipFill>
         <p:spPr>
           <a:xfrm>
-            <a:off x="6231636" y="1325880"/>
-            <a:ext cx="5408676" cy="3353379"/>
+            <a:off x="4337304" y="1325880"/>
+            <a:ext cx="3514344" cy="2080260"/>
+          </a:xfrm>
+          <a:prstGeom prst="rect">
+            <a:avLst/>
+          </a:prstGeom>
+        </p:spPr>
+      </p:pic>
+      <p:pic>
+        <p:nvPicPr>
+          <p:cNvPr id="7" name="Image 2" descr="Visualisierung 3">    </p:cNvPr>
+          <p:cNvPicPr>
+            <a:picLocks noChangeAspect="1"/>
+          </p:cNvPicPr>
+          <p:nvPr/>
+        </p:nvPicPr>
+        <p:blipFill>
+          <a:blip r:embed="rId3"/>
+          <a:stretch>
+            <a:fillRect/>
+          </a:stretch>
+        </p:blipFill>
+        <p:spPr>
+          <a:xfrm>
+            <a:off x="8125968" y="1325880"/>
+            <a:ext cx="3514344" cy="2080260"/>
+          </a:xfrm>
+          <a:prstGeom prst="rect">
+            <a:avLst/>
+          </a:prstGeom>
+        </p:spPr>
+      </p:pic>
+      <p:pic>
+        <p:nvPicPr>
+          <p:cNvPr id="8" name="Image 3" descr="Visualisierung 4">    </p:cNvPr>
+          <p:cNvPicPr>
+            <a:picLocks noChangeAspect="1"/>
+          </p:cNvPicPr>
+          <p:nvPr/>
+        </p:nvPicPr>
+        <p:blipFill>
+          <a:blip r:embed="rId4"/>
+          <a:stretch>
+            <a:fillRect/>
+          </a:stretch>
+        </p:blipFill>
+        <p:spPr>
+          <a:xfrm>
+            <a:off x="548640" y="3680460"/>
+            <a:ext cx="3514344" cy="2080260"/>
+          </a:xfrm>
+          <a:prstGeom prst="rect">
+            <a:avLst/>
+          </a:prstGeom>
+        </p:spPr>
+      </p:pic>
+      <p:pic>
+        <p:nvPicPr>
+          <p:cNvPr id="9" name="Image 4" descr="Visualisierung 5">    </p:cNvPr>
+          <p:cNvPicPr>
+            <a:picLocks noChangeAspect="1"/>
+          </p:cNvPicPr>
+          <p:nvPr/>
+        </p:nvPicPr>
+        <p:blipFill>
+          <a:blip r:embed="rId5"/>
+          <a:stretch>
+            <a:fillRect/>
+          </a:stretch>
+        </p:blipFill>
+        <p:spPr>
+          <a:xfrm>
+            <a:off x="4337304" y="3680460"/>
+            <a:ext cx="3514344" cy="2080260"/>
           </a:xfrm>
           <a:prstGeom prst="rect">
             <a:avLst/>
@@ -4898,7 +4970,7 @@
       </p:pic>
       <p:sp>
         <p:nvSpPr>
-          <p:cNvPr id="7" name="Text 2"/>
+          <p:cNvPr id="10" name="Text 2"/>
           <p:cNvSpPr txBox="1"/>
           <p:nvPr/>
         </p:nvSpPr>
@@ -36625,7 +36697,7 @@
                 <a:ea typeface="Calibri" pitchFamily="34" charset="-122"/>
                 <a:cs typeface="Calibri" pitchFamily="34" charset="-120"/>
               </a:rPr>
-              <a:t>Referenz für Stimmung</a:t>
+              <a:t>KI-Visualisierung</a:t>
             </a:r>
             <a:endParaRPr lang="en-US" sz="1200" dirty="0"/>
           </a:p>

</xml_diff>

<commit_message>
Variante C: 540 m2, 3 Vollgeschosse plus Holz-Penthouse (Folie, Excel, Modell)
Co-Authored-By: Claude Sonnet 5.5 <noreply@anthropic.com>
Claude-Session: https://claude.ai/code/session_01HJGZfxHv7bzYyqdLwg8aFJ
</commit_message>
<xml_diff>
--- a/praesentation/Neue-Mitte-Werlte_Baufeld3_6-Wohnungen_Gastro-EG.pptx
+++ b/praesentation/Neue-Mitte-Werlte_Baufeld3_6-Wohnungen_Gastro-EG.pptx
@@ -3442,7 +3442,7 @@
           <a:p>
             <a:r>
               <a:rPr lang="en-US" dirty="0"/>
-              <a:t>Nur mit Ausnahme der Stadt: Baufenster ca. 400–460 m² geschätzt, im Plan stehen zwei Vollgeschosse, GRZ 0,6 erlaubt max. 576 m².</a:t>
+              <a:t>Nur mit Ausnahme der Stadt: Baufenster ca. 400–460 m² geschätzt, im Plan stehen zwei Vollgeschosse und 12 m Höhe, GRZ 0,6 erlaubt max. 576 m².</a:t>
             </a:r>
             <a:endParaRPr lang="en-US" dirty="0"/>
           </a:p>
@@ -32121,7 +32121,7 @@
                 <a:ea typeface="Georgia" pitchFamily="34" charset="-122"/>
                 <a:cs typeface="Georgia" pitchFamily="34" charset="-120"/>
               </a:rPr>
-              <a:t>Variante B: 540 m² Grundfläche</a:t>
+              <a:t>Varianten B und C: 540 m² Grundfläche</a:t>
             </a:r>
             <a:endParaRPr lang="en-US" sz="3000" dirty="0"/>
           </a:p>
@@ -32165,7 +32165,7 @@
       </p:sp>
       <p:graphicFrame>
         <p:nvGraphicFramePr>
-          <p:cNvPr id="28" name="Tabelle Variante B"/>
+          <p:cNvPr id="28" name="Tabelle Varianten B und C"/>
           <p:cNvGraphicFramePr>
             <a:graphicFrameLocks noGrp="1"/>
           </p:cNvGraphicFramePr>
@@ -32179,16 +32179,17 @@
         </p:nvGraphicFramePr>
         <p:xfrm>
           <a:off x="548640" y="1280160"/>
-          <a:ext cx="7680960" cy="914400"/>
+          <a:ext cx="8229600" cy="914400"/>
         </p:xfrm>
         <a:graphic>
           <a:graphicData uri="http://schemas.openxmlformats.org/drawingml/2006/table">
             <a:tbl>
               <a:tblPr/>
               <a:tblGrid>
-                <a:gridCol w="3840480"/>
-                <a:gridCol w="1920240"/>
-                <a:gridCol w="1920240"/>
+                <a:gridCol w="3566160"/>
+                <a:gridCol w="1554480"/>
+                <a:gridCol w="1554480"/>
+                <a:gridCol w="1554480"/>
               </a:tblGrid>
               <a:tr h="384048">
                 <a:tc>
@@ -32265,7 +32266,7 @@
                           <a:ea typeface="Arial" pitchFamily="34" charset="-122"/>
                           <a:cs typeface="Arial" pitchFamily="34" charset="-120"/>
                         </a:rPr>
-                        <a:t>A: 340 m² (jetzt)</a:t>
+                        <a:t>A: 340 m², 2+Staffel</a:t>
                       </a:r>
                       <a:endParaRPr lang="en-US" sz="1250" dirty="0">
                         <a:latin typeface="Arial" charset="0"/>
@@ -32333,7 +32334,75 @@
                           <a:ea typeface="Arial" pitchFamily="34" charset="-122"/>
                           <a:cs typeface="Arial" pitchFamily="34" charset="-120"/>
                         </a:rPr>
-                        <a:t>B: 540 m²</a:t>
+                        <a:t>B: 540 m², 2+Staffel</a:t>
+                      </a:r>
+                      <a:endParaRPr lang="en-US" sz="1250" dirty="0">
+                        <a:latin typeface="Arial" charset="0"/>
+                        <a:ea typeface="Arial" charset="0"/>
+                        <a:cs typeface="Arial" charset="0"/>
+                      </a:endParaRPr>
+                    </a:p>
+                  </a:txBody>
+                  <a:tcPr marL="91440" marR="91440" marT="45720" marB="45720">
+                    <a:lnL w="12700" cap="flat" cmpd="sng" algn="ctr">
+                      <a:solidFill>
+                        <a:srgbClr val="FFFFFF"/>
+                      </a:solidFill>
+                      <a:prstDash val="solid"/>
+                      <a:round/>
+                      <a:headEnd type="none" w="med" len="med"/>
+                      <a:tailEnd type="none" w="med" len="med"/>
+                    </a:lnL>
+                    <a:lnR w="12700" cap="flat" cmpd="sng" algn="ctr">
+                      <a:solidFill>
+                        <a:srgbClr val="FFFFFF"/>
+                      </a:solidFill>
+                      <a:prstDash val="solid"/>
+                      <a:round/>
+                      <a:headEnd type="none" w="med" len="med"/>
+                      <a:tailEnd type="none" w="med" len="med"/>
+                    </a:lnR>
+                    <a:lnT w="12700" cap="flat" cmpd="sng" algn="ctr">
+                      <a:solidFill>
+                        <a:srgbClr val="FFFFFF"/>
+                      </a:solidFill>
+                      <a:prstDash val="solid"/>
+                      <a:round/>
+                      <a:headEnd type="none" w="med" len="med"/>
+                      <a:tailEnd type="none" w="med" len="med"/>
+                    </a:lnT>
+                    <a:lnB w="12700" cap="flat" cmpd="sng" algn="ctr">
+                      <a:solidFill>
+                        <a:srgbClr val="FFFFFF"/>
+                      </a:solidFill>
+                      <a:prstDash val="solid"/>
+                      <a:round/>
+                      <a:headEnd type="none" w="med" len="med"/>
+                      <a:tailEnd type="none" w="med" len="med"/>
+                    </a:lnB>
+                    <a:solidFill>
+                      <a:schemeClr val="accent2"/>
+                    </a:solidFill>
+                  </a:tcPr>
+                </a:tc>
+                <a:tc>
+                  <a:txBody>
+                    <a:bodyPr/>
+                    <a:lstStyle/>
+                    <a:p>
+                      <a:pPr algn="r" indent="0" marL="0">
+                        <a:buNone/>
+                      </a:pPr>
+                      <a:r>
+                        <a:rPr lang="en-US" sz="1250" b="1" dirty="0">
+                          <a:solidFill>
+                            <a:schemeClr val="bg1"/>
+                          </a:solidFill>
+                          <a:latin typeface="Arial" pitchFamily="34" charset="0"/>
+                          <a:ea typeface="Arial" pitchFamily="34" charset="-122"/>
+                          <a:cs typeface="Arial" pitchFamily="34" charset="-120"/>
+                        </a:rPr>
+                        <a:t>C: 540 m², 3+Holz-Penthouse</a:t>
                       </a:r>
                       <a:endParaRPr lang="en-US" sz="1250" dirty="0">
                         <a:latin typeface="Arial" charset="0"/>
@@ -32581,73 +32650,6 @@
                     </a:lnB>
                   </a:tcPr>
                 </a:tc>
-              </a:tr>
-              <a:tr h="384048">
-                <a:tc>
-                  <a:txBody>
-                    <a:bodyPr/>
-                    <a:lstStyle/>
-                    <a:p>
-                      <a:pPr indent="0" marL="0">
-                        <a:buNone/>
-                      </a:pPr>
-                      <a:r>
-                        <a:rPr lang="en-US" sz="1250" dirty="0">
-                          <a:solidFill>
-                            <a:srgbClr val="000000"/>
-                          </a:solidFill>
-                          <a:latin typeface="Arial" pitchFamily="34" charset="0"/>
-                          <a:ea typeface="Arial" pitchFamily="34" charset="-122"/>
-                          <a:cs typeface="Arial" pitchFamily="34" charset="-120"/>
-                        </a:rPr>
-                        <a:t>Wohnfläche</a:t>
-                      </a:r>
-                      <a:endParaRPr lang="en-US" sz="1250" dirty="0">
-                        <a:latin typeface="Arial" charset="0"/>
-                        <a:ea typeface="Arial" charset="0"/>
-                        <a:cs typeface="Arial" charset="0"/>
-                      </a:endParaRPr>
-                    </a:p>
-                  </a:txBody>
-                  <a:tcPr marL="91440" marR="91440" marT="45720" marB="45720">
-                    <a:lnL w="12700" cap="flat" cmpd="sng" algn="ctr">
-                      <a:solidFill>
-                        <a:srgbClr val="FFFFFF"/>
-                      </a:solidFill>
-                      <a:prstDash val="solid"/>
-                      <a:round/>
-                      <a:headEnd type="none" w="med" len="med"/>
-                      <a:tailEnd type="none" w="med" len="med"/>
-                    </a:lnL>
-                    <a:lnR w="12700" cap="flat" cmpd="sng" algn="ctr">
-                      <a:solidFill>
-                        <a:srgbClr val="FFFFFF"/>
-                      </a:solidFill>
-                      <a:prstDash val="solid"/>
-                      <a:round/>
-                      <a:headEnd type="none" w="med" len="med"/>
-                      <a:tailEnd type="none" w="med" len="med"/>
-                    </a:lnR>
-                    <a:lnT w="12700" cap="flat" cmpd="sng" algn="ctr">
-                      <a:solidFill>
-                        <a:srgbClr val="FFFFFF"/>
-                      </a:solidFill>
-                      <a:prstDash val="solid"/>
-                      <a:round/>
-                      <a:headEnd type="none" w="med" len="med"/>
-                      <a:tailEnd type="none" w="med" len="med"/>
-                    </a:lnT>
-                    <a:lnB w="12700" cap="flat" cmpd="sng" algn="ctr">
-                      <a:solidFill>
-                        <a:srgbClr val="FFFFFF"/>
-                      </a:solidFill>
-                      <a:prstDash val="solid"/>
-                      <a:round/>
-                      <a:headEnd type="none" w="med" len="med"/>
-                      <a:tailEnd type="none" w="med" len="med"/>
-                    </a:lnB>
-                  </a:tcPr>
-                </a:tc>
                 <a:tc>
                   <a:txBody>
                     <a:bodyPr/>
@@ -32665,72 +32667,7 @@
                           <a:ea typeface="Arial" pitchFamily="34" charset="-122"/>
                           <a:cs typeface="Arial" pitchFamily="34" charset="-120"/>
                         </a:rPr>
-                        <a:t>ca. 423 m²</a:t>
-                      </a:r>
-                      <a:endParaRPr lang="en-US" sz="1250" dirty="0">
-                        <a:latin typeface="Arial" charset="0"/>
-                        <a:ea typeface="Arial" charset="0"/>
-                        <a:cs typeface="Arial" charset="0"/>
-                      </a:endParaRPr>
-                    </a:p>
-                  </a:txBody>
-                  <a:tcPr marL="91440" marR="91440" marT="45720" marB="45720">
-                    <a:lnL w="12700" cap="flat" cmpd="sng" algn="ctr">
-                      <a:solidFill>
-                        <a:srgbClr val="FFFFFF"/>
-                      </a:solidFill>
-                      <a:prstDash val="solid"/>
-                      <a:round/>
-                      <a:headEnd type="none" w="med" len="med"/>
-                      <a:tailEnd type="none" w="med" len="med"/>
-                    </a:lnL>
-                    <a:lnR w="12700" cap="flat" cmpd="sng" algn="ctr">
-                      <a:solidFill>
-                        <a:srgbClr val="FFFFFF"/>
-                      </a:solidFill>
-                      <a:prstDash val="solid"/>
-                      <a:round/>
-                      <a:headEnd type="none" w="med" len="med"/>
-                      <a:tailEnd type="none" w="med" len="med"/>
-                    </a:lnR>
-                    <a:lnT w="12700" cap="flat" cmpd="sng" algn="ctr">
-                      <a:solidFill>
-                        <a:srgbClr val="FFFFFF"/>
-                      </a:solidFill>
-                      <a:prstDash val="solid"/>
-                      <a:round/>
-                      <a:headEnd type="none" w="med" len="med"/>
-                      <a:tailEnd type="none" w="med" len="med"/>
-                    </a:lnT>
-                    <a:lnB w="12700" cap="flat" cmpd="sng" algn="ctr">
-                      <a:solidFill>
-                        <a:srgbClr val="FFFFFF"/>
-                      </a:solidFill>
-                      <a:prstDash val="solid"/>
-                      <a:round/>
-                      <a:headEnd type="none" w="med" len="med"/>
-                      <a:tailEnd type="none" w="med" len="med"/>
-                    </a:lnB>
-                  </a:tcPr>
-                </a:tc>
-                <a:tc>
-                  <a:txBody>
-                    <a:bodyPr/>
-                    <a:lstStyle/>
-                    <a:p>
-                      <a:pPr algn="r" indent="0" marL="0">
-                        <a:buNone/>
-                      </a:pPr>
-                      <a:r>
-                        <a:rPr lang="en-US" sz="1250" dirty="0">
-                          <a:solidFill>
-                            <a:srgbClr val="000000"/>
-                          </a:solidFill>
-                          <a:latin typeface="Arial" pitchFamily="34" charset="0"/>
-                          <a:ea typeface="Arial" pitchFamily="34" charset="-122"/>
-                          <a:cs typeface="Arial" pitchFamily="34" charset="-120"/>
-                        </a:rPr>
-                        <a:t>ca. 738 m²</a:t>
+                        <a:t>2.040 m²</a:t>
                       </a:r>
                       <a:endParaRPr lang="en-US" sz="1250" dirty="0">
                         <a:latin typeface="Arial" charset="0"/>
@@ -32797,7 +32734,7 @@
                           <a:ea typeface="Arial" pitchFamily="34" charset="-122"/>
                           <a:cs typeface="Arial" pitchFamily="34" charset="-120"/>
                         </a:rPr>
-                        <a:t>Wohnungen</a:t>
+                        <a:t>Wohnfläche / Wohnungen</a:t>
                       </a:r>
                       <a:endParaRPr lang="en-US" sz="1250" dirty="0">
                         <a:latin typeface="Arial" charset="0"/>
@@ -32862,7 +32799,7 @@
                           <a:ea typeface="Arial" pitchFamily="34" charset="-122"/>
                           <a:cs typeface="Arial" pitchFamily="34" charset="-120"/>
                         </a:rPr>
-                        <a:t>6</a:t>
+                        <a:t>423 m² / 6</a:t>
                       </a:r>
                       <a:endParaRPr lang="en-US" sz="1250" dirty="0">
                         <a:latin typeface="Arial" charset="0"/>
@@ -32927,7 +32864,72 @@
                           <a:ea typeface="Arial" pitchFamily="34" charset="-122"/>
                           <a:cs typeface="Arial" pitchFamily="34" charset="-120"/>
                         </a:rPr>
-                        <a:t>ca. 8 bis 9</a:t>
+                        <a:t>738 m² / ca. 8–9</a:t>
+                      </a:r>
+                      <a:endParaRPr lang="en-US" sz="1250" dirty="0">
+                        <a:latin typeface="Arial" charset="0"/>
+                        <a:ea typeface="Arial" charset="0"/>
+                        <a:cs typeface="Arial" charset="0"/>
+                      </a:endParaRPr>
+                    </a:p>
+                  </a:txBody>
+                  <a:tcPr marL="91440" marR="91440" marT="45720" marB="45720">
+                    <a:lnL w="12700" cap="flat" cmpd="sng" algn="ctr">
+                      <a:solidFill>
+                        <a:srgbClr val="FFFFFF"/>
+                      </a:solidFill>
+                      <a:prstDash val="solid"/>
+                      <a:round/>
+                      <a:headEnd type="none" w="med" len="med"/>
+                      <a:tailEnd type="none" w="med" len="med"/>
+                    </a:lnL>
+                    <a:lnR w="12700" cap="flat" cmpd="sng" algn="ctr">
+                      <a:solidFill>
+                        <a:srgbClr val="FFFFFF"/>
+                      </a:solidFill>
+                      <a:prstDash val="solid"/>
+                      <a:round/>
+                      <a:headEnd type="none" w="med" len="med"/>
+                      <a:tailEnd type="none" w="med" len="med"/>
+                    </a:lnR>
+                    <a:lnT w="12700" cap="flat" cmpd="sng" algn="ctr">
+                      <a:solidFill>
+                        <a:srgbClr val="FFFFFF"/>
+                      </a:solidFill>
+                      <a:prstDash val="solid"/>
+                      <a:round/>
+                      <a:headEnd type="none" w="med" len="med"/>
+                      <a:tailEnd type="none" w="med" len="med"/>
+                    </a:lnT>
+                    <a:lnB w="12700" cap="flat" cmpd="sng" algn="ctr">
+                      <a:solidFill>
+                        <a:srgbClr val="FFFFFF"/>
+                      </a:solidFill>
+                      <a:prstDash val="solid"/>
+                      <a:round/>
+                      <a:headEnd type="none" w="med" len="med"/>
+                      <a:tailEnd type="none" w="med" len="med"/>
+                    </a:lnB>
+                  </a:tcPr>
+                </a:tc>
+                <a:tc>
+                  <a:txBody>
+                    <a:bodyPr/>
+                    <a:lstStyle/>
+                    <a:p>
+                      <a:pPr algn="r" indent="0" marL="0">
+                        <a:buNone/>
+                      </a:pPr>
+                      <a:r>
+                        <a:rPr lang="en-US" sz="1250" dirty="0">
+                          <a:solidFill>
+                            <a:srgbClr val="000000"/>
+                          </a:solidFill>
+                          <a:latin typeface="Arial" pitchFamily="34" charset="0"/>
+                          <a:ea typeface="Arial" pitchFamily="34" charset="-122"/>
+                          <a:cs typeface="Arial" pitchFamily="34" charset="-120"/>
+                        </a:rPr>
+                        <a:t>1.153 m² / ca. 13</a:t>
                       </a:r>
                       <a:endParaRPr lang="en-US" sz="1250" dirty="0">
                         <a:latin typeface="Arial" charset="0"/>
@@ -32994,7 +32996,7 @@
                           <a:ea typeface="Arial" pitchFamily="34" charset="-122"/>
                           <a:cs typeface="Arial" pitchFamily="34" charset="-120"/>
                         </a:rPr>
-                        <a:t>Gastro / Büro</a:t>
+                        <a:t>Gastro / Büro im EG</a:t>
                       </a:r>
                       <a:endParaRPr lang="en-US" sz="1250" dirty="0">
                         <a:latin typeface="Arial" charset="0"/>
@@ -33060,6 +33062,71 @@
                           <a:cs typeface="Arial" pitchFamily="34" charset="-120"/>
                         </a:rPr>
                         <a:t>290 m² / –</a:t>
+                      </a:r>
+                      <a:endParaRPr lang="en-US" sz="1250" dirty="0">
+                        <a:latin typeface="Arial" charset="0"/>
+                        <a:ea typeface="Arial" charset="0"/>
+                        <a:cs typeface="Arial" charset="0"/>
+                      </a:endParaRPr>
+                    </a:p>
+                  </a:txBody>
+                  <a:tcPr marL="91440" marR="91440" marT="45720" marB="45720">
+                    <a:lnL w="12700" cap="flat" cmpd="sng" algn="ctr">
+                      <a:solidFill>
+                        <a:srgbClr val="FFFFFF"/>
+                      </a:solidFill>
+                      <a:prstDash val="solid"/>
+                      <a:round/>
+                      <a:headEnd type="none" w="med" len="med"/>
+                      <a:tailEnd type="none" w="med" len="med"/>
+                    </a:lnL>
+                    <a:lnR w="12700" cap="flat" cmpd="sng" algn="ctr">
+                      <a:solidFill>
+                        <a:srgbClr val="FFFFFF"/>
+                      </a:solidFill>
+                      <a:prstDash val="solid"/>
+                      <a:round/>
+                      <a:headEnd type="none" w="med" len="med"/>
+                      <a:tailEnd type="none" w="med" len="med"/>
+                    </a:lnR>
+                    <a:lnT w="12700" cap="flat" cmpd="sng" algn="ctr">
+                      <a:solidFill>
+                        <a:srgbClr val="FFFFFF"/>
+                      </a:solidFill>
+                      <a:prstDash val="solid"/>
+                      <a:round/>
+                      <a:headEnd type="none" w="med" len="med"/>
+                      <a:tailEnd type="none" w="med" len="med"/>
+                    </a:lnT>
+                    <a:lnB w="12700" cap="flat" cmpd="sng" algn="ctr">
+                      <a:solidFill>
+                        <a:srgbClr val="FFFFFF"/>
+                      </a:solidFill>
+                      <a:prstDash val="solid"/>
+                      <a:round/>
+                      <a:headEnd type="none" w="med" len="med"/>
+                      <a:tailEnd type="none" w="med" len="med"/>
+                    </a:lnB>
+                  </a:tcPr>
+                </a:tc>
+                <a:tc>
+                  <a:txBody>
+                    <a:bodyPr/>
+                    <a:lstStyle/>
+                    <a:p>
+                      <a:pPr algn="r" indent="0" marL="0">
+                        <a:buNone/>
+                      </a:pPr>
+                      <a:r>
+                        <a:rPr lang="en-US" sz="1250" dirty="0">
+                          <a:solidFill>
+                            <a:srgbClr val="000000"/>
+                          </a:solidFill>
+                          <a:latin typeface="Arial" pitchFamily="34" charset="0"/>
+                          <a:ea typeface="Arial" pitchFamily="34" charset="-122"/>
+                          <a:cs typeface="Arial" pitchFamily="34" charset="-120"/>
+                        </a:rPr>
+                        <a:t>290 m² / 150 m²</a:t>
                       </a:r>
                       <a:endParaRPr lang="en-US" sz="1250" dirty="0">
                         <a:latin typeface="Arial" charset="0"/>
@@ -33369,6 +33436,71 @@
                     </a:lnB>
                   </a:tcPr>
                 </a:tc>
+                <a:tc>
+                  <a:txBody>
+                    <a:bodyPr/>
+                    <a:lstStyle/>
+                    <a:p>
+                      <a:pPr algn="r" indent="0" marL="0">
+                        <a:buNone/>
+                      </a:pPr>
+                      <a:r>
+                        <a:rPr lang="en-US" sz="1250" dirty="0">
+                          <a:solidFill>
+                            <a:srgbClr val="000000"/>
+                          </a:solidFill>
+                          <a:latin typeface="Arial" pitchFamily="34" charset="0"/>
+                          <a:ea typeface="Arial" pitchFamily="34" charset="-122"/>
+                          <a:cs typeface="Arial" pitchFamily="34" charset="-120"/>
+                        </a:rPr>
+                        <a:t>5.416.356 €</a:t>
+                      </a:r>
+                      <a:endParaRPr lang="en-US" sz="1250" dirty="0">
+                        <a:latin typeface="Arial" charset="0"/>
+                        <a:ea typeface="Arial" charset="0"/>
+                        <a:cs typeface="Arial" charset="0"/>
+                      </a:endParaRPr>
+                    </a:p>
+                  </a:txBody>
+                  <a:tcPr marL="91440" marR="91440" marT="45720" marB="45720">
+                    <a:lnL w="12700" cap="flat" cmpd="sng" algn="ctr">
+                      <a:solidFill>
+                        <a:srgbClr val="FFFFFF"/>
+                      </a:solidFill>
+                      <a:prstDash val="solid"/>
+                      <a:round/>
+                      <a:headEnd type="none" w="med" len="med"/>
+                      <a:tailEnd type="none" w="med" len="med"/>
+                    </a:lnL>
+                    <a:lnR w="12700" cap="flat" cmpd="sng" algn="ctr">
+                      <a:solidFill>
+                        <a:srgbClr val="FFFFFF"/>
+                      </a:solidFill>
+                      <a:prstDash val="solid"/>
+                      <a:round/>
+                      <a:headEnd type="none" w="med" len="med"/>
+                      <a:tailEnd type="none" w="med" len="med"/>
+                    </a:lnR>
+                    <a:lnT w="12700" cap="flat" cmpd="sng" algn="ctr">
+                      <a:solidFill>
+                        <a:srgbClr val="FFFFFF"/>
+                      </a:solidFill>
+                      <a:prstDash val="solid"/>
+                      <a:round/>
+                      <a:headEnd type="none" w="med" len="med"/>
+                      <a:tailEnd type="none" w="med" len="med"/>
+                    </a:lnT>
+                    <a:lnB w="12700" cap="flat" cmpd="sng" algn="ctr">
+                      <a:solidFill>
+                        <a:srgbClr val="FFFFFF"/>
+                      </a:solidFill>
+                      <a:prstDash val="solid"/>
+                      <a:round/>
+                      <a:headEnd type="none" w="med" len="med"/>
+                      <a:tailEnd type="none" w="med" len="med"/>
+                    </a:lnB>
+                  </a:tcPr>
+                </a:tc>
               </a:tr>
               <a:tr h="384048">
                 <a:tc>
@@ -33519,6 +33651,71 @@
                           <a:cs typeface="Arial" pitchFamily="34" charset="-120"/>
                         </a:rPr>
                         <a:t>15.419 €</a:t>
+                      </a:r>
+                      <a:endParaRPr lang="en-US" sz="1250" dirty="0">
+                        <a:latin typeface="Arial" charset="0"/>
+                        <a:ea typeface="Arial" charset="0"/>
+                        <a:cs typeface="Arial" charset="0"/>
+                      </a:endParaRPr>
+                    </a:p>
+                  </a:txBody>
+                  <a:tcPr marL="91440" marR="91440" marT="45720" marB="45720">
+                    <a:lnL w="12700" cap="flat" cmpd="sng" algn="ctr">
+                      <a:solidFill>
+                        <a:srgbClr val="FFFFFF"/>
+                      </a:solidFill>
+                      <a:prstDash val="solid"/>
+                      <a:round/>
+                      <a:headEnd type="none" w="med" len="med"/>
+                      <a:tailEnd type="none" w="med" len="med"/>
+                    </a:lnL>
+                    <a:lnR w="12700" cap="flat" cmpd="sng" algn="ctr">
+                      <a:solidFill>
+                        <a:srgbClr val="FFFFFF"/>
+                      </a:solidFill>
+                      <a:prstDash val="solid"/>
+                      <a:round/>
+                      <a:headEnd type="none" w="med" len="med"/>
+                      <a:tailEnd type="none" w="med" len="med"/>
+                    </a:lnR>
+                    <a:lnT w="12700" cap="flat" cmpd="sng" algn="ctr">
+                      <a:solidFill>
+                        <a:srgbClr val="FFFFFF"/>
+                      </a:solidFill>
+                      <a:prstDash val="solid"/>
+                      <a:round/>
+                      <a:headEnd type="none" w="med" len="med"/>
+                      <a:tailEnd type="none" w="med" len="med"/>
+                    </a:lnT>
+                    <a:lnB w="12700" cap="flat" cmpd="sng" algn="ctr">
+                      <a:solidFill>
+                        <a:srgbClr val="FFFFFF"/>
+                      </a:solidFill>
+                      <a:prstDash val="solid"/>
+                      <a:round/>
+                      <a:headEnd type="none" w="med" len="med"/>
+                      <a:tailEnd type="none" w="med" len="med"/>
+                    </a:lnB>
+                  </a:tcPr>
+                </a:tc>
+                <a:tc>
+                  <a:txBody>
+                    <a:bodyPr/>
+                    <a:lstStyle/>
+                    <a:p>
+                      <a:pPr algn="r" indent="0" marL="0">
+                        <a:buNone/>
+                      </a:pPr>
+                      <a:r>
+                        <a:rPr lang="en-US" sz="1250" dirty="0">
+                          <a:solidFill>
+                            <a:srgbClr val="000000"/>
+                          </a:solidFill>
+                          <a:latin typeface="Arial" pitchFamily="34" charset="0"/>
+                          <a:ea typeface="Arial" pitchFamily="34" charset="-122"/>
+                          <a:cs typeface="Arial" pitchFamily="34" charset="-120"/>
+                        </a:rPr>
+                        <a:t>20.615 €</a:t>
                       </a:r>
                       <a:endParaRPr lang="en-US" sz="1250" dirty="0">
                         <a:latin typeface="Arial" charset="0"/>
@@ -33719,6 +33916,74 @@
                           <a:cs typeface="Arial" pitchFamily="34" charset="-120"/>
                         </a:rPr>
                         <a:t>+2.257 €</a:t>
+                      </a:r>
+                      <a:endParaRPr lang="en-US" sz="1250" dirty="0">
+                        <a:latin typeface="Arial" charset="0"/>
+                        <a:ea typeface="Arial" charset="0"/>
+                        <a:cs typeface="Arial" charset="0"/>
+                      </a:endParaRPr>
+                    </a:p>
+                  </a:txBody>
+                  <a:tcPr marL="91440" marR="91440" marT="45720" marB="45720">
+                    <a:lnL w="12700" cap="flat" cmpd="sng" algn="ctr">
+                      <a:solidFill>
+                        <a:srgbClr val="FFFFFF"/>
+                      </a:solidFill>
+                      <a:prstDash val="solid"/>
+                      <a:round/>
+                      <a:headEnd type="none" w="med" len="med"/>
+                      <a:tailEnd type="none" w="med" len="med"/>
+                    </a:lnL>
+                    <a:lnR w="12700" cap="flat" cmpd="sng" algn="ctr">
+                      <a:solidFill>
+                        <a:srgbClr val="FFFFFF"/>
+                      </a:solidFill>
+                      <a:prstDash val="solid"/>
+                      <a:round/>
+                      <a:headEnd type="none" w="med" len="med"/>
+                      <a:tailEnd type="none" w="med" len="med"/>
+                    </a:lnR>
+                    <a:lnT w="12700" cap="flat" cmpd="sng" algn="ctr">
+                      <a:solidFill>
+                        <a:srgbClr val="FFFFFF"/>
+                      </a:solidFill>
+                      <a:prstDash val="solid"/>
+                      <a:round/>
+                      <a:headEnd type="none" w="med" len="med"/>
+                      <a:tailEnd type="none" w="med" len="med"/>
+                    </a:lnT>
+                    <a:lnB w="12700" cap="flat" cmpd="sng" algn="ctr">
+                      <a:solidFill>
+                        <a:srgbClr val="FFFFFF"/>
+                      </a:solidFill>
+                      <a:prstDash val="solid"/>
+                      <a:round/>
+                      <a:headEnd type="none" w="med" len="med"/>
+                      <a:tailEnd type="none" w="med" len="med"/>
+                    </a:lnB>
+                    <a:solidFill>
+                      <a:srgbClr val="E3F1EA"/>
+                    </a:solidFill>
+                  </a:tcPr>
+                </a:tc>
+                <a:tc>
+                  <a:txBody>
+                    <a:bodyPr/>
+                    <a:lstStyle/>
+                    <a:p>
+                      <a:pPr algn="r" indent="0" marL="0">
+                        <a:buNone/>
+                      </a:pPr>
+                      <a:r>
+                        <a:rPr lang="en-US" sz="1250" b="1" dirty="0">
+                          <a:solidFill>
+                            <a:schemeClr val="accent5"/>
+                          </a:solidFill>
+                          <a:latin typeface="Arial" pitchFamily="34" charset="0"/>
+                          <a:ea typeface="Arial" pitchFamily="34" charset="-122"/>
+                          <a:cs typeface="Arial" pitchFamily="34" charset="-120"/>
+                        </a:rPr>
+                        <a:t>+1.234 €</a:t>
                       </a:r>
                       <a:endParaRPr lang="en-US" sz="1250" dirty="0">
                         <a:latin typeface="Arial" charset="0"/>
@@ -33966,6 +34231,71 @@
                     </a:lnB>
                   </a:tcPr>
                 </a:tc>
+                <a:tc>
+                  <a:txBody>
+                    <a:bodyPr/>
+                    <a:lstStyle/>
+                    <a:p>
+                      <a:pPr algn="r" indent="0" marL="0">
+                        <a:buNone/>
+                      </a:pPr>
+                      <a:r>
+                        <a:rPr lang="en-US" sz="1250" dirty="0">
+                          <a:solidFill>
+                            <a:srgbClr val="000000"/>
+                          </a:solidFill>
+                          <a:latin typeface="Arial" pitchFamily="34" charset="0"/>
+                          <a:ea typeface="Arial" pitchFamily="34" charset="-122"/>
+                          <a:cs typeface="Arial" pitchFamily="34" charset="-120"/>
+                        </a:rPr>
+                        <a:t>45.953 €</a:t>
+                      </a:r>
+                      <a:endParaRPr lang="en-US" sz="1250" dirty="0">
+                        <a:latin typeface="Arial" charset="0"/>
+                        <a:ea typeface="Arial" charset="0"/>
+                        <a:cs typeface="Arial" charset="0"/>
+                      </a:endParaRPr>
+                    </a:p>
+                  </a:txBody>
+                  <a:tcPr marL="91440" marR="91440" marT="45720" marB="45720">
+                    <a:lnL w="12700" cap="flat" cmpd="sng" algn="ctr">
+                      <a:solidFill>
+                        <a:srgbClr val="FFFFFF"/>
+                      </a:solidFill>
+                      <a:prstDash val="solid"/>
+                      <a:round/>
+                      <a:headEnd type="none" w="med" len="med"/>
+                      <a:tailEnd type="none" w="med" len="med"/>
+                    </a:lnL>
+                    <a:lnR w="12700" cap="flat" cmpd="sng" algn="ctr">
+                      <a:solidFill>
+                        <a:srgbClr val="FFFFFF"/>
+                      </a:solidFill>
+                      <a:prstDash val="solid"/>
+                      <a:round/>
+                      <a:headEnd type="none" w="med" len="med"/>
+                      <a:tailEnd type="none" w="med" len="med"/>
+                    </a:lnR>
+                    <a:lnT w="12700" cap="flat" cmpd="sng" algn="ctr">
+                      <a:solidFill>
+                        <a:srgbClr val="FFFFFF"/>
+                      </a:solidFill>
+                      <a:prstDash val="solid"/>
+                      <a:round/>
+                      <a:headEnd type="none" w="med" len="med"/>
+                      <a:tailEnd type="none" w="med" len="med"/>
+                    </a:lnT>
+                    <a:lnB w="12700" cap="flat" cmpd="sng" algn="ctr">
+                      <a:solidFill>
+                        <a:srgbClr val="FFFFFF"/>
+                      </a:solidFill>
+                      <a:prstDash val="solid"/>
+                      <a:round/>
+                      <a:headEnd type="none" w="med" len="med"/>
+                      <a:tailEnd type="none" w="med" len="med"/>
+                    </a:lnB>
+                  </a:tcPr>
+                </a:tc>
               </a:tr>
               <a:tr h="384048">
                 <a:tc>
@@ -33985,7 +34315,278 @@
                           <a:ea typeface="Arial" pitchFamily="34" charset="-122"/>
                           <a:cs typeface="Arial" pitchFamily="34" charset="-120"/>
                         </a:rPr>
-                        <a:t>Kosten je m² Wohnfläche, OG / Staffel</a:t>
+                        <a:t>Ergebnis bei 4,0 % Zins</a:t>
+                      </a:r>
+                      <a:endParaRPr lang="en-US" sz="1250" dirty="0">
+                        <a:latin typeface="Arial" charset="0"/>
+                        <a:ea typeface="Arial" charset="0"/>
+                        <a:cs typeface="Arial" charset="0"/>
+                      </a:endParaRPr>
+                    </a:p>
+                  </a:txBody>
+                  <a:tcPr marL="91440" marR="91440" marT="45720" marB="45720">
+                    <a:lnL w="12700" cap="flat" cmpd="sng" algn="ctr">
+                      <a:solidFill>
+                        <a:srgbClr val="FFFFFF"/>
+                      </a:solidFill>
+                      <a:prstDash val="solid"/>
+                      <a:round/>
+                      <a:headEnd type="none" w="med" len="med"/>
+                      <a:tailEnd type="none" w="med" len="med"/>
+                    </a:lnL>
+                    <a:lnR w="12700" cap="flat" cmpd="sng" algn="ctr">
+                      <a:solidFill>
+                        <a:srgbClr val="FFFFFF"/>
+                      </a:solidFill>
+                      <a:prstDash val="solid"/>
+                      <a:round/>
+                      <a:headEnd type="none" w="med" len="med"/>
+                      <a:tailEnd type="none" w="med" len="med"/>
+                    </a:lnR>
+                    <a:lnT w="12700" cap="flat" cmpd="sng" algn="ctr">
+                      <a:solidFill>
+                        <a:srgbClr val="FFFFFF"/>
+                      </a:solidFill>
+                      <a:prstDash val="solid"/>
+                      <a:round/>
+                      <a:headEnd type="none" w="med" len="med"/>
+                      <a:tailEnd type="none" w="med" len="med"/>
+                    </a:lnT>
+                    <a:lnB w="12700" cap="flat" cmpd="sng" algn="ctr">
+                      <a:solidFill>
+                        <a:srgbClr val="FFFFFF"/>
+                      </a:solidFill>
+                      <a:prstDash val="solid"/>
+                      <a:round/>
+                      <a:headEnd type="none" w="med" len="med"/>
+                      <a:tailEnd type="none" w="med" len="med"/>
+                    </a:lnB>
+                  </a:tcPr>
+                </a:tc>
+                <a:tc>
+                  <a:txBody>
+                    <a:bodyPr/>
+                    <a:lstStyle/>
+                    <a:p>
+                      <a:pPr algn="r" indent="0" marL="0">
+                        <a:buNone/>
+                      </a:pPr>
+                      <a:r>
+                        <a:rPr lang="en-US" sz="1250" b="1" dirty="0">
+                          <a:solidFill>
+                            <a:schemeClr val="accent5"/>
+                          </a:solidFill>
+                          <a:latin typeface="Arial" pitchFamily="34" charset="0"/>
+                          <a:ea typeface="Arial" pitchFamily="34" charset="-122"/>
+                          <a:cs typeface="Arial" pitchFamily="34" charset="-120"/>
+                        </a:rPr>
+                        <a:t>+2.068 €</a:t>
+                      </a:r>
+                      <a:endParaRPr lang="en-US" sz="1250" dirty="0">
+                        <a:latin typeface="Arial" charset="0"/>
+                        <a:ea typeface="Arial" charset="0"/>
+                        <a:cs typeface="Arial" charset="0"/>
+                      </a:endParaRPr>
+                    </a:p>
+                  </a:txBody>
+                  <a:tcPr marL="91440" marR="91440" marT="45720" marB="45720">
+                    <a:lnL w="12700" cap="flat" cmpd="sng" algn="ctr">
+                      <a:solidFill>
+                        <a:srgbClr val="FFFFFF"/>
+                      </a:solidFill>
+                      <a:prstDash val="solid"/>
+                      <a:round/>
+                      <a:headEnd type="none" w="med" len="med"/>
+                      <a:tailEnd type="none" w="med" len="med"/>
+                    </a:lnL>
+                    <a:lnR w="12700" cap="flat" cmpd="sng" algn="ctr">
+                      <a:solidFill>
+                        <a:srgbClr val="FFFFFF"/>
+                      </a:solidFill>
+                      <a:prstDash val="solid"/>
+                      <a:round/>
+                      <a:headEnd type="none" w="med" len="med"/>
+                      <a:tailEnd type="none" w="med" len="med"/>
+                    </a:lnR>
+                    <a:lnT w="12700" cap="flat" cmpd="sng" algn="ctr">
+                      <a:solidFill>
+                        <a:srgbClr val="FFFFFF"/>
+                      </a:solidFill>
+                      <a:prstDash val="solid"/>
+                      <a:round/>
+                      <a:headEnd type="none" w="med" len="med"/>
+                      <a:tailEnd type="none" w="med" len="med"/>
+                    </a:lnT>
+                    <a:lnB w="12700" cap="flat" cmpd="sng" algn="ctr">
+                      <a:solidFill>
+                        <a:srgbClr val="FFFFFF"/>
+                      </a:solidFill>
+                      <a:prstDash val="solid"/>
+                      <a:round/>
+                      <a:headEnd type="none" w="med" len="med"/>
+                      <a:tailEnd type="none" w="med" len="med"/>
+                    </a:lnB>
+                    <a:solidFill>
+                      <a:srgbClr val="E3F1EA"/>
+                    </a:solidFill>
+                  </a:tcPr>
+                </a:tc>
+                <a:tc>
+                  <a:txBody>
+                    <a:bodyPr/>
+                    <a:lstStyle/>
+                    <a:p>
+                      <a:pPr algn="r" indent="0" marL="0">
+                        <a:buNone/>
+                      </a:pPr>
+                      <a:r>
+                        <a:rPr lang="en-US" sz="1250" b="1" dirty="0">
+                          <a:solidFill>
+                            <a:schemeClr val="accent6"/>
+                          </a:solidFill>
+                          <a:latin typeface="Arial" pitchFamily="34" charset="0"/>
+                          <a:ea typeface="Arial" pitchFamily="34" charset="-122"/>
+                          <a:cs typeface="Arial" pitchFamily="34" charset="-120"/>
+                        </a:rPr>
+                        <a:t>−458 €</a:t>
+                      </a:r>
+                      <a:endParaRPr lang="en-US" sz="1250" dirty="0">
+                        <a:latin typeface="Arial" charset="0"/>
+                        <a:ea typeface="Arial" charset="0"/>
+                        <a:cs typeface="Arial" charset="0"/>
+                      </a:endParaRPr>
+                    </a:p>
+                  </a:txBody>
+                  <a:tcPr marL="91440" marR="91440" marT="45720" marB="45720">
+                    <a:lnL w="12700" cap="flat" cmpd="sng" algn="ctr">
+                      <a:solidFill>
+                        <a:srgbClr val="FFFFFF"/>
+                      </a:solidFill>
+                      <a:prstDash val="solid"/>
+                      <a:round/>
+                      <a:headEnd type="none" w="med" len="med"/>
+                      <a:tailEnd type="none" w="med" len="med"/>
+                    </a:lnL>
+                    <a:lnR w="12700" cap="flat" cmpd="sng" algn="ctr">
+                      <a:solidFill>
+                        <a:srgbClr val="FFFFFF"/>
+                      </a:solidFill>
+                      <a:prstDash val="solid"/>
+                      <a:round/>
+                      <a:headEnd type="none" w="med" len="med"/>
+                      <a:tailEnd type="none" w="med" len="med"/>
+                    </a:lnR>
+                    <a:lnT w="12700" cap="flat" cmpd="sng" algn="ctr">
+                      <a:solidFill>
+                        <a:srgbClr val="FFFFFF"/>
+                      </a:solidFill>
+                      <a:prstDash val="solid"/>
+                      <a:round/>
+                      <a:headEnd type="none" w="med" len="med"/>
+                      <a:tailEnd type="none" w="med" len="med"/>
+                    </a:lnT>
+                    <a:lnB w="12700" cap="flat" cmpd="sng" algn="ctr">
+                      <a:solidFill>
+                        <a:srgbClr val="FFFFFF"/>
+                      </a:solidFill>
+                      <a:prstDash val="solid"/>
+                      <a:round/>
+                      <a:headEnd type="none" w="med" len="med"/>
+                      <a:tailEnd type="none" w="med" len="med"/>
+                    </a:lnB>
+                    <a:solidFill>
+                      <a:srgbClr val="F8E4E2"/>
+                    </a:solidFill>
+                  </a:tcPr>
+                </a:tc>
+                <a:tc>
+                  <a:txBody>
+                    <a:bodyPr/>
+                    <a:lstStyle/>
+                    <a:p>
+                      <a:pPr algn="r" indent="0" marL="0">
+                        <a:buNone/>
+                      </a:pPr>
+                      <a:r>
+                        <a:rPr lang="en-US" sz="1250" b="1" dirty="0">
+                          <a:solidFill>
+                            <a:schemeClr val="accent6"/>
+                          </a:solidFill>
+                          <a:latin typeface="Arial" pitchFamily="34" charset="0"/>
+                          <a:ea typeface="Arial" pitchFamily="34" charset="-122"/>
+                          <a:cs typeface="Arial" pitchFamily="34" charset="-120"/>
+                        </a:rPr>
+                        <a:t>−2.394 €</a:t>
+                      </a:r>
+                      <a:endParaRPr lang="en-US" sz="1250" dirty="0">
+                        <a:latin typeface="Arial" charset="0"/>
+                        <a:ea typeface="Arial" charset="0"/>
+                        <a:cs typeface="Arial" charset="0"/>
+                      </a:endParaRPr>
+                    </a:p>
+                  </a:txBody>
+                  <a:tcPr marL="91440" marR="91440" marT="45720" marB="45720">
+                    <a:lnL w="12700" cap="flat" cmpd="sng" algn="ctr">
+                      <a:solidFill>
+                        <a:srgbClr val="FFFFFF"/>
+                      </a:solidFill>
+                      <a:prstDash val="solid"/>
+                      <a:round/>
+                      <a:headEnd type="none" w="med" len="med"/>
+                      <a:tailEnd type="none" w="med" len="med"/>
+                    </a:lnL>
+                    <a:lnR w="12700" cap="flat" cmpd="sng" algn="ctr">
+                      <a:solidFill>
+                        <a:srgbClr val="FFFFFF"/>
+                      </a:solidFill>
+                      <a:prstDash val="solid"/>
+                      <a:round/>
+                      <a:headEnd type="none" w="med" len="med"/>
+                      <a:tailEnd type="none" w="med" len="med"/>
+                    </a:lnR>
+                    <a:lnT w="12700" cap="flat" cmpd="sng" algn="ctr">
+                      <a:solidFill>
+                        <a:srgbClr val="FFFFFF"/>
+                      </a:solidFill>
+                      <a:prstDash val="solid"/>
+                      <a:round/>
+                      <a:headEnd type="none" w="med" len="med"/>
+                      <a:tailEnd type="none" w="med" len="med"/>
+                    </a:lnT>
+                    <a:lnB w="12700" cap="flat" cmpd="sng" algn="ctr">
+                      <a:solidFill>
+                        <a:srgbClr val="FFFFFF"/>
+                      </a:solidFill>
+                      <a:prstDash val="solid"/>
+                      <a:round/>
+                      <a:headEnd type="none" w="med" len="med"/>
+                      <a:tailEnd type="none" w="med" len="med"/>
+                    </a:lnB>
+                    <a:solidFill>
+                      <a:srgbClr val="F8E4E2"/>
+                    </a:solidFill>
+                  </a:tcPr>
+                </a:tc>
+              </a:tr>
+              <a:tr h="384048">
+                <a:tc>
+                  <a:txBody>
+                    <a:bodyPr/>
+                    <a:lstStyle/>
+                    <a:p>
+                      <a:pPr indent="0" marL="0">
+                        <a:buNone/>
+                      </a:pPr>
+                      <a:r>
+                        <a:rPr lang="en-US" sz="1250" dirty="0">
+                          <a:solidFill>
+                            <a:srgbClr val="000000"/>
+                          </a:solidFill>
+                          <a:latin typeface="Arial" pitchFamily="34" charset="0"/>
+                          <a:ea typeface="Arial" pitchFamily="34" charset="-122"/>
+                          <a:cs typeface="Arial" pitchFamily="34" charset="-120"/>
+                        </a:rPr>
+                        <a:t>Kosten je m² Wohnfläche, Regelgeschoss / Staffel</a:t>
                       </a:r>
                       <a:endParaRPr lang="en-US" sz="1250" dirty="0">
                         <a:latin typeface="Arial" charset="0"/>
@@ -34163,6 +34764,71 @@
                     </a:lnB>
                   </a:tcPr>
                 </a:tc>
+                <a:tc>
+                  <a:txBody>
+                    <a:bodyPr/>
+                    <a:lstStyle/>
+                    <a:p>
+                      <a:pPr algn="r" indent="0" marL="0">
+                        <a:buNone/>
+                      </a:pPr>
+                      <a:r>
+                        <a:rPr lang="en-US" sz="1250" dirty="0">
+                          <a:solidFill>
+                            <a:srgbClr val="000000"/>
+                          </a:solidFill>
+                          <a:latin typeface="Arial" pitchFamily="34" charset="0"/>
+                          <a:ea typeface="Arial" pitchFamily="34" charset="-122"/>
+                          <a:cs typeface="Arial" pitchFamily="34" charset="-120"/>
+                        </a:rPr>
+                        <a:t>3.443 € / 3.034 €</a:t>
+                      </a:r>
+                      <a:endParaRPr lang="en-US" sz="1250" dirty="0">
+                        <a:latin typeface="Arial" charset="0"/>
+                        <a:ea typeface="Arial" charset="0"/>
+                        <a:cs typeface="Arial" charset="0"/>
+                      </a:endParaRPr>
+                    </a:p>
+                  </a:txBody>
+                  <a:tcPr marL="91440" marR="91440" marT="45720" marB="45720">
+                    <a:lnL w="12700" cap="flat" cmpd="sng" algn="ctr">
+                      <a:solidFill>
+                        <a:srgbClr val="FFFFFF"/>
+                      </a:solidFill>
+                      <a:prstDash val="solid"/>
+                      <a:round/>
+                      <a:headEnd type="none" w="med" len="med"/>
+                      <a:tailEnd type="none" w="med" len="med"/>
+                    </a:lnL>
+                    <a:lnR w="12700" cap="flat" cmpd="sng" algn="ctr">
+                      <a:solidFill>
+                        <a:srgbClr val="FFFFFF"/>
+                      </a:solidFill>
+                      <a:prstDash val="solid"/>
+                      <a:round/>
+                      <a:headEnd type="none" w="med" len="med"/>
+                      <a:tailEnd type="none" w="med" len="med"/>
+                    </a:lnR>
+                    <a:lnT w="12700" cap="flat" cmpd="sng" algn="ctr">
+                      <a:solidFill>
+                        <a:srgbClr val="FFFFFF"/>
+                      </a:solidFill>
+                      <a:prstDash val="solid"/>
+                      <a:round/>
+                      <a:headEnd type="none" w="med" len="med"/>
+                      <a:tailEnd type="none" w="med" len="med"/>
+                    </a:lnT>
+                    <a:lnB w="12700" cap="flat" cmpd="sng" algn="ctr">
+                      <a:solidFill>
+                        <a:srgbClr val="FFFFFF"/>
+                      </a:solidFill>
+                      <a:prstDash val="solid"/>
+                      <a:round/>
+                      <a:headEnd type="none" w="med" len="med"/>
+                      <a:tailEnd type="none" w="med" len="med"/>
+                    </a:lnB>
+                  </a:tcPr>
+                </a:tc>
               </a:tr>
               <a:tr h="384048">
                 <a:tc>
@@ -34182,7 +34848,7 @@
                           <a:ea typeface="Arial" pitchFamily="34" charset="-122"/>
                           <a:cs typeface="Arial" pitchFamily="34" charset="-120"/>
                         </a:rPr>
-                        <a:t>85-m²-Wohnung im OG: Ergebnis (eigener Kredit)</a:t>
+                        <a:t>85-m²-Wohnung im Regelgeschoss: Ergebnis (eigener Kredit)</a:t>
                       </a:r>
                       <a:endParaRPr lang="en-US" sz="1250" dirty="0">
                         <a:latin typeface="Arial" charset="0"/>
@@ -34366,6 +35032,74 @@
                     </a:solidFill>
                   </a:tcPr>
                 </a:tc>
+                <a:tc>
+                  <a:txBody>
+                    <a:bodyPr/>
+                    <a:lstStyle/>
+                    <a:p>
+                      <a:pPr algn="r" indent="0" marL="0">
+                        <a:buNone/>
+                      </a:pPr>
+                      <a:r>
+                        <a:rPr lang="en-US" sz="1250" b="1" dirty="0">
+                          <a:solidFill>
+                            <a:schemeClr val="accent6"/>
+                          </a:solidFill>
+                          <a:latin typeface="Arial" pitchFamily="34" charset="0"/>
+                          <a:ea typeface="Arial" pitchFamily="34" charset="-122"/>
+                          <a:cs typeface="Arial" pitchFamily="34" charset="-120"/>
+                        </a:rPr>
+                        <a:t>−260 €</a:t>
+                      </a:r>
+                      <a:endParaRPr lang="en-US" sz="1250" dirty="0">
+                        <a:latin typeface="Arial" charset="0"/>
+                        <a:ea typeface="Arial" charset="0"/>
+                        <a:cs typeface="Arial" charset="0"/>
+                      </a:endParaRPr>
+                    </a:p>
+                  </a:txBody>
+                  <a:tcPr marL="91440" marR="91440" marT="45720" marB="45720">
+                    <a:lnL w="12700" cap="flat" cmpd="sng" algn="ctr">
+                      <a:solidFill>
+                        <a:srgbClr val="FFFFFF"/>
+                      </a:solidFill>
+                      <a:prstDash val="solid"/>
+                      <a:round/>
+                      <a:headEnd type="none" w="med" len="med"/>
+                      <a:tailEnd type="none" w="med" len="med"/>
+                    </a:lnL>
+                    <a:lnR w="12700" cap="flat" cmpd="sng" algn="ctr">
+                      <a:solidFill>
+                        <a:srgbClr val="FFFFFF"/>
+                      </a:solidFill>
+                      <a:prstDash val="solid"/>
+                      <a:round/>
+                      <a:headEnd type="none" w="med" len="med"/>
+                      <a:tailEnd type="none" w="med" len="med"/>
+                    </a:lnR>
+                    <a:lnT w="12700" cap="flat" cmpd="sng" algn="ctr">
+                      <a:solidFill>
+                        <a:srgbClr val="FFFFFF"/>
+                      </a:solidFill>
+                      <a:prstDash val="solid"/>
+                      <a:round/>
+                      <a:headEnd type="none" w="med" len="med"/>
+                      <a:tailEnd type="none" w="med" len="med"/>
+                    </a:lnT>
+                    <a:lnB w="12700" cap="flat" cmpd="sng" algn="ctr">
+                      <a:solidFill>
+                        <a:srgbClr val="FFFFFF"/>
+                      </a:solidFill>
+                      <a:prstDash val="solid"/>
+                      <a:round/>
+                      <a:headEnd type="none" w="med" len="med"/>
+                      <a:tailEnd type="none" w="med" len="med"/>
+                    </a:lnB>
+                    <a:solidFill>
+                      <a:srgbClr val="F8E4E2"/>
+                    </a:solidFill>
+                  </a:tcPr>
+                </a:tc>
               </a:tr>
               <a:tr h="384048">
                 <a:tc>
@@ -34385,7 +35119,7 @@
                           <a:ea typeface="Arial" pitchFamily="34" charset="-122"/>
                           <a:cs typeface="Arial" pitchFamily="34" charset="-120"/>
                         </a:rPr>
-                        <a:t>Preis-Lücke je 85-m²-Wohnung im OG</a:t>
+                        <a:t>Preis-Lücke je 85-m²-Wohnung im Regelgeschoss</a:t>
                       </a:r>
                       <a:endParaRPr lang="en-US" sz="1250" dirty="0">
                         <a:latin typeface="Arial" charset="0"/>
@@ -34563,6 +35297,71 @@
                     </a:lnB>
                   </a:tcPr>
                 </a:tc>
+                <a:tc>
+                  <a:txBody>
+                    <a:bodyPr/>
+                    <a:lstStyle/>
+                    <a:p>
+                      <a:pPr algn="r" indent="0" marL="0">
+                        <a:buNone/>
+                      </a:pPr>
+                      <a:r>
+                        <a:rPr lang="en-US" sz="1250" dirty="0">
+                          <a:solidFill>
+                            <a:srgbClr val="000000"/>
+                          </a:solidFill>
+                          <a:latin typeface="Arial" pitchFamily="34" charset="0"/>
+                          <a:ea typeface="Arial" pitchFamily="34" charset="-122"/>
+                          <a:cs typeface="Arial" pitchFamily="34" charset="-120"/>
+                        </a:rPr>
+                        <a:t>81.422 €</a:t>
+                      </a:r>
+                      <a:endParaRPr lang="en-US" sz="1250" dirty="0">
+                        <a:latin typeface="Arial" charset="0"/>
+                        <a:ea typeface="Arial" charset="0"/>
+                        <a:cs typeface="Arial" charset="0"/>
+                      </a:endParaRPr>
+                    </a:p>
+                  </a:txBody>
+                  <a:tcPr marL="91440" marR="91440" marT="45720" marB="45720">
+                    <a:lnL w="12700" cap="flat" cmpd="sng" algn="ctr">
+                      <a:solidFill>
+                        <a:srgbClr val="FFFFFF"/>
+                      </a:solidFill>
+                      <a:prstDash val="solid"/>
+                      <a:round/>
+                      <a:headEnd type="none" w="med" len="med"/>
+                      <a:tailEnd type="none" w="med" len="med"/>
+                    </a:lnL>
+                    <a:lnR w="12700" cap="flat" cmpd="sng" algn="ctr">
+                      <a:solidFill>
+                        <a:srgbClr val="FFFFFF"/>
+                      </a:solidFill>
+                      <a:prstDash val="solid"/>
+                      <a:round/>
+                      <a:headEnd type="none" w="med" len="med"/>
+                      <a:tailEnd type="none" w="med" len="med"/>
+                    </a:lnR>
+                    <a:lnT w="12700" cap="flat" cmpd="sng" algn="ctr">
+                      <a:solidFill>
+                        <a:srgbClr val="FFFFFF"/>
+                      </a:solidFill>
+                      <a:prstDash val="solid"/>
+                      <a:round/>
+                      <a:headEnd type="none" w="med" len="med"/>
+                      <a:tailEnd type="none" w="med" len="med"/>
+                    </a:lnT>
+                    <a:lnB w="12700" cap="flat" cmpd="sng" algn="ctr">
+                      <a:solidFill>
+                        <a:srgbClr val="FFFFFF"/>
+                      </a:solidFill>
+                      <a:prstDash val="solid"/>
+                      <a:round/>
+                      <a:headEnd type="none" w="med" len="med"/>
+                      <a:tailEnd type="none" w="med" len="med"/>
+                    </a:lnB>
+                  </a:tcPr>
+                </a:tc>
               </a:tr>
             </a:tbl>
           </a:graphicData>
@@ -34570,18 +35369,18 @@
       </p:graphicFrame>
       <p:sp>
         <p:nvSpPr>
-          <p:cNvPr id="6" name="Hinweis B"/>
+          <p:cNvPr id="6" name="Hinweis B und C"/>
           <p:cNvSpPr/>
           <p:nvPr/>
         </p:nvSpPr>
         <p:spPr>
           <a:xfrm>
-            <a:off x="8595360" y="1280160"/>
-            <a:ext cx="3044952" cy="4480560"/>
+            <a:off x="9326880" y="1280160"/>
+            <a:ext cx="2313432" cy="4572000"/>
           </a:xfrm>
           <a:prstGeom prst="roundRect">
             <a:avLst>
-              <a:gd name="adj" fmla="val 2402"/>
+              <a:gd name="adj" fmla="val 3162"/>
             </a:avLst>
           </a:prstGeom>
           <a:solidFill>
@@ -34603,8 +35402,8 @@
         </p:nvSpPr>
         <p:spPr>
           <a:xfrm>
-            <a:off x="8823960" y="1463040"/>
-            <a:ext cx="2587752" cy="4114800"/>
+            <a:off x="9509760" y="1463040"/>
+            <a:ext cx="1947672" cy="4206240"/>
           </a:xfrm>
           <a:prstGeom prst="rect">
             <a:avLst/>
@@ -34620,7 +35419,7 @@
               <a:buNone/>
             </a:pPr>
             <a:r>
-              <a:rPr lang="en-US" sz="1300" b="1" dirty="0">
+              <a:rPr lang="en-US" sz="1200" b="1" dirty="0">
                 <a:solidFill>
                   <a:schemeClr val="accent1"/>
                 </a:solidFill>
@@ -34628,16 +35427,16 @@
                 <a:ea typeface="Arial" pitchFamily="34" charset="-122"/>
                 <a:cs typeface="Arial" pitchFamily="34" charset="-120"/>
               </a:rPr>
-              <a:t>Annahmen B</a:t>
+              <a:t>Annahmen</a:t>
             </a:r>
-            <a:endParaRPr lang="en-US" sz="1300" dirty="0"/>
+            <a:endParaRPr lang="en-US" sz="1200" dirty="0"/>
           </a:p>
           <a:p>
             <a:pPr indent="0" marL="0">
               <a:buNone/>
             </a:pPr>
             <a:r>
-              <a:rPr lang="en-US" sz="1300" dirty="0">
+              <a:rPr lang="en-US" sz="1200" dirty="0">
                 <a:solidFill>
                   <a:schemeClr val="tx1"/>
                 </a:solidFill>
@@ -34645,16 +35444,16 @@
                 <a:ea typeface="Arial" pitchFamily="34" charset="-122"/>
                 <a:cs typeface="Arial" pitchFamily="34" charset="-120"/>
               </a:rPr>
-              <a:t>EG 540 m² (Gastro 290 m², Büro 150 m²), 1. OG 540 m², Staffel 420 m² in Holzbau mit 120 m² Terrasse. Büro 10 €/m², Wohnen 11,18 €/m².</a:t>
+              <a:t>EG 540 m² (Gastro 290 m², Büro 150 m²), Regelgeschosse je 540 m², Staffel 420 m² in Holzbau mit 120 m² Terrasse. Büro 10 €/m², Wohnen 11,18 €/m².</a:t>
             </a:r>
-            <a:endParaRPr lang="en-US" sz="1300" dirty="0"/>
+            <a:endParaRPr lang="en-US" sz="1200" dirty="0"/>
           </a:p>
           <a:p>
             <a:pPr indent="0" marL="0">
               <a:buNone/>
             </a:pPr>
             <a:r>
-              <a:rPr lang="en-US" sz="1300" dirty="0">
+              <a:rPr lang="en-US" sz="1200" dirty="0">
                 <a:solidFill>
                   <a:schemeClr val="tx1"/>
                 </a:solidFill>
@@ -34664,14 +35463,14 @@
               </a:rPr>
               <a:t> </a:t>
             </a:r>
-            <a:endParaRPr lang="en-US" sz="1300" dirty="0"/>
+            <a:endParaRPr lang="en-US" sz="1200" dirty="0"/>
           </a:p>
           <a:p>
             <a:pPr indent="0" marL="0">
               <a:buNone/>
             </a:pPr>
             <a:r>
-              <a:rPr lang="en-US" sz="1300" b="1" dirty="0">
+              <a:rPr lang="en-US" sz="1200" b="1" dirty="0">
                 <a:solidFill>
                   <a:schemeClr val="accent1"/>
                 </a:solidFill>
@@ -34681,14 +35480,14 @@
               </a:rPr>
               <a:t>Zu klären</a:t>
             </a:r>
-            <a:endParaRPr lang="en-US" sz="1300" dirty="0"/>
+            <a:endParaRPr lang="en-US" sz="1200" dirty="0"/>
           </a:p>
           <a:p>
             <a:pPr indent="0" marL="0">
               <a:buNone/>
             </a:pPr>
             <a:r>
-              <a:rPr lang="en-US" sz="1300" dirty="0">
+              <a:rPr lang="en-US" sz="1200" dirty="0">
                 <a:solidFill>
                   <a:schemeClr val="tx1"/>
                 </a:solidFill>
@@ -34696,9 +35495,9 @@
                 <a:ea typeface="Arial" pitchFamily="34" charset="-122"/>
                 <a:cs typeface="Arial" pitchFamily="34" charset="-120"/>
               </a:rPr>
-              <a:t>Baufenster, zwei Vollgeschosse, Höhe 12 m und deutlich mehr Stellplätze.</a:t>
+              <a:t>Baufenster, zwei Vollgeschosse, bei C drei Vollgeschosse und ca. 13 m Höhe statt 12 m, deutlich mehr Stellplätze.</a:t>
             </a:r>
-            <a:endParaRPr lang="en-US" sz="1300" dirty="0"/>
+            <a:endParaRPr lang="en-US" sz="1200" dirty="0"/>
           </a:p>
         </p:txBody>
       </p:sp>

</xml_diff>

<commit_message>
Folie: So rentiert es sich fuer jede Partei
Co-Authored-By: Claude Sonnet 5.5 <noreply@anthropic.com>
Claude-Session: https://claude.ai/code/session_01HJGZfxHv7bzYyqdLwg8aFJ
</commit_message>
<xml_diff>
--- a/praesentation/Neue-Mitte-Werlte_Baufeld3_6-Wohnungen_Gastro-EG.pptx
+++ b/praesentation/Neue-Mitte-Werlte_Baufeld3_6-Wohnungen_Gastro-EG.pptx
@@ -33,9 +33,10 @@
     <p:sldId id="281" r:id="rId27"/>
     <p:sldId id="282" r:id="rId28"/>
     <p:sldId id="283" r:id="rId29"/>
+    <p:sldId id="284" r:id="rId30"/>
   </p:sldIdLst>
   <p:notesMasterIdLst>
-    <p:notesMasterId r:id="rId30"/>
+    <p:notesMasterId r:id="rId31"/>
   </p:notesMasterIdLst>
   <p:sldSz cx="12192000" cy="6858000"/>
   <p:notesSz cx="6858000" cy="12192000"/>
@@ -2650,7 +2651,7 @@
           <a:p>
             <a:r>
               <a:rPr lang="en-US" dirty="0"/>
-              <a:t>Die Miete von 950 € je Wohnung ist eine Annahme des Bauherrn, Marktdaten für Werlte liegen darunter.</a:t>
+              <a:t>Variante A, 6 Wohnungen, jede mit eigenem Kredit ohne Eigenkapital, Miete 950 €, 50.000 € Gastro-Umsatz. Förderung, Preise und tilgungsfreie Jahre sind Ziele, keine Zusagen.</a:t>
             </a:r>
             <a:endParaRPr lang="en-US" dirty="0"/>
           </a:p>
@@ -2826,7 +2827,7 @@
           <a:p>
             <a:r>
               <a:rPr lang="en-US" dirty="0"/>
-              <a:t>Wirkungen gerechnet mit dem Modell (Plan 3,3 %, ohne Förderung als Basis).</a:t>
+              <a:t>Die Miete von 950 € je Wohnung ist eine Annahme des Bauherrn, Marktdaten für Werlte liegen darunter.</a:t>
             </a:r>
             <a:endParaRPr lang="en-US" dirty="0"/>
           </a:p>
@@ -2914,7 +2915,7 @@
           <a:p>
             <a:r>
               <a:rPr lang="en-US" dirty="0"/>
-              <a:t>Zeitplan der Stadt aus dem Konzeptheft, Bauantrag und Förderzusagen sind meine Planung.</a:t>
+              <a:t>Wirkungen gerechnet mit dem Modell (Plan 3,3 %, ohne Förderung als Basis).</a:t>
             </a:r>
             <a:endParaRPr lang="en-US" dirty="0"/>
           </a:p>
@@ -3002,7 +3003,7 @@
           <a:p>
             <a:r>
               <a:rPr lang="en-US" dirty="0"/>
-              <a:t/>
+              <a:t>Zeitplan der Stadt aus dem Konzeptheft, Bauantrag und Förderzusagen sind meine Planung.</a:t>
             </a:r>
             <a:endParaRPr lang="en-US" dirty="0"/>
           </a:p>
@@ -3090,7 +3091,7 @@
           <a:p>
             <a:r>
               <a:rPr lang="en-US" dirty="0"/>
-              <a:t>Alle Zahlen sind Planungsannahmen, keine Zusagen.</a:t>
+              <a:t/>
             </a:r>
             <a:endParaRPr lang="en-US" dirty="0"/>
           </a:p>
@@ -3178,7 +3179,7 @@
           <a:p>
             <a:r>
               <a:rPr lang="en-US" dirty="0"/>
-              <a:t>Prozentwerte sind Branchen-Richtwerte aus meiner Einschätzung, nicht aus Quellen für Werlte.</a:t>
+              <a:t>Alle Zahlen sind Planungsannahmen, keine Zusagen.</a:t>
             </a:r>
             <a:endParaRPr lang="en-US" dirty="0"/>
           </a:p>
@@ -3266,7 +3267,7 @@
           <a:p>
             <a:r>
               <a:rPr lang="en-US" dirty="0"/>
-              <a:t>Zielbudget des Bauherrn für einen einfachen Ausbau, Angebote von Küchen- und Lüftungsbauern müssen es bestätigen.</a:t>
+              <a:t>Prozentwerte sind Branchen-Richtwerte aus meiner Einschätzung, nicht aus Quellen für Werlte.</a:t>
             </a:r>
             <a:endParaRPr lang="en-US" dirty="0"/>
           </a:p>
@@ -3354,7 +3355,7 @@
           <a:p>
             <a:r>
               <a:rPr lang="en-US" dirty="0"/>
-              <a:t>Es gibt keinen amtlichen Mietspiegel für Werlte, die Portale arbeiten mit kleinen Stichproben.</a:t>
+              <a:t>Zielbudget des Bauherrn für einen einfachen Ausbau, Angebote von Küchen- und Lüftungsbauern müssen es bestätigen.</a:t>
             </a:r>
             <a:endParaRPr lang="en-US" dirty="0"/>
           </a:p>
@@ -3442,7 +3443,7 @@
           <a:p>
             <a:r>
               <a:rPr lang="en-US" dirty="0"/>
-              <a:t>Nur mit Ausnahme der Stadt: Baufenster ca. 400–460 m² geschätzt, im Plan stehen zwei Vollgeschosse und 12 m Höhe, GRZ 0,6 erlaubt max. 576 m².</a:t>
+              <a:t>Es gibt keinen amtlichen Mietspiegel für Werlte, die Portale arbeiten mit kleinen Stichproben.</a:t>
             </a:r>
             <a:endParaRPr lang="en-US" dirty="0"/>
           </a:p>
@@ -3530,6 +3531,94 @@
           <a:p>
             <a:r>
               <a:rPr lang="en-US" dirty="0"/>
+              <a:t>Nur mit Ausnahme der Stadt: Baufenster ca. 400–460 m² geschätzt, im Plan stehen zwei Vollgeschosse und 12 m Höhe, GRZ 0,6 erlaubt max. 576 m².</a:t>
+            </a:r>
+            <a:endParaRPr lang="en-US" dirty="0"/>
+          </a:p>
+        </p:txBody>
+      </p:sp>
+      <p:sp>
+        <p:nvSpPr>
+          <p:cNvPr id="4" name="Slide Number Placeholder 3"/>
+          <p:cNvSpPr>
+            <a:spLocks noGrp="1"/>
+          </p:cNvSpPr>
+          <p:nvPr>
+            <p:ph type="sldNum" sz="quarter" idx="10"/>
+          </p:nvPr>
+        </p:nvSpPr>
+        <p:spPr/>
+        <p:txBody>
+          <a:bodyPr/>
+          <a:lstStyle/>
+          <a:p>
+            <a:fld id="{F7021451-1387-4CA6-816F-3879F97B5CBC}" type="slidenum">
+              <a:rPr lang="en-US"/>
+              <a:t>28</a:t>
+            </a:fld>
+            <a:endParaRPr lang="en-US"/>
+          </a:p>
+        </p:txBody>
+      </p:sp>
+    </p:spTree>
+    <p:extLst>
+      <p:ext uri="{BB962C8B-B14F-4D97-AF65-F5344CB8AC3E}">
+        <p14:creationId xmlns:p14="http://schemas.microsoft.com/office/powerpoint/2010/main" val="1024086991"/>
+      </p:ext>
+    </p:extLst>
+  </p:cSld>
+  <p:clrMapOvr>
+    <a:masterClrMapping/>
+  </p:clrMapOvr>
+</p:notes>
+</file>
+
+<file path=ppt/notesSlides/notesSlide29.xml><?xml version="1.0" encoding="utf-8"?>
+<p:notes xmlns:a="http://schemas.openxmlformats.org/drawingml/2006/main" xmlns:r="http://schemas.openxmlformats.org/officeDocument/2006/relationships" xmlns:p="http://schemas.openxmlformats.org/presentationml/2006/main">
+  <p:cSld>
+    <p:spTree>
+      <p:nvGrpSpPr>
+        <p:cNvPr id="1" name=""/>
+        <p:cNvGrpSpPr/>
+        <p:nvPr/>
+      </p:nvGrpSpPr>
+      <p:grpSpPr>
+        <a:xfrm>
+          <a:off x="0" y="0"/>
+          <a:ext cx="0" cy="0"/>
+          <a:chOff x="0" y="0"/>
+          <a:chExt cx="0" cy="0"/>
+        </a:xfrm>
+      </p:grpSpPr>
+      <p:sp>
+        <p:nvSpPr>
+          <p:cNvPr id="2" name="Slide Image Placeholder 1"/>
+          <p:cNvSpPr>
+            <a:spLocks noGrp="1" noRot="1" noChangeAspect="1"/>
+          </p:cNvSpPr>
+          <p:nvPr>
+            <p:ph type="sldImg"/>
+          </p:nvPr>
+        </p:nvSpPr>
+        <p:spPr/>
+      </p:sp>
+      <p:sp>
+        <p:nvSpPr>
+          <p:cNvPr id="3" name="Notes Placeholder 2"/>
+          <p:cNvSpPr>
+            <a:spLocks noGrp="1"/>
+          </p:cNvSpPr>
+          <p:nvPr>
+            <p:ph type="body" idx="1"/>
+          </p:nvPr>
+        </p:nvSpPr>
+        <p:spPr/>
+        <p:txBody>
+          <a:bodyPr/>
+          <a:lstStyle/>
+          <a:p>
+            <a:r>
+              <a:rPr lang="en-US" dirty="0"/>
               <a:t>Bildmontage aus der KI-Visualisierung: das mittlere Geschoss wurde verdoppelt. Höhe ca. 13 m, der B-Plan erlaubt 12 m.</a:t>
             </a:r>
             <a:endParaRPr lang="en-US" dirty="0"/>
@@ -3553,7 +3642,7 @@
           <a:p>
             <a:fld id="{F7021451-1387-4CA6-816F-3879F97B5CBC}" type="slidenum">
               <a:rPr lang="en-US"/>
-              <a:t>28</a:t>
+              <a:t>29</a:t>
             </a:fld>
             <a:endParaRPr lang="en-US"/>
           </a:p>
@@ -21697,7 +21786,7 @@
                 <a:ea typeface="Georgia" pitchFamily="34" charset="-122"/>
                 <a:cs typeface="Georgia" pitchFamily="34" charset="-120"/>
               </a:rPr>
-              <a:t>Risiken und was wir dagegen tun</a:t>
+              <a:t>So rentiert es sich für jede Partei</a:t>
             </a:r>
             <a:endParaRPr lang="en-US" sz="3000" dirty="0"/>
           </a:p>
@@ -21733,26 +21822,1958 @@
                   <a:schemeClr val="accent4"/>
                 </a:solidFill>
               </a:rPr>
-              <a:t>Für die Bank</a:t>
+              <a:t>Für die Verwandten und die Bank</a:t>
             </a:r>
             <a:endParaRPr lang="en-US" sz="1000" dirty="0"/>
           </a:p>
         </p:txBody>
       </p:sp>
+      <p:graphicFrame>
+        <p:nvGraphicFramePr>
+          <p:cNvPr id="20" name="Tabelle Rentiert für alle"/>
+          <p:cNvGraphicFramePr>
+            <a:graphicFrameLocks noGrp="1"/>
+          </p:cNvGraphicFramePr>
+          <p:nvPr>
+            <p:extLst>
+              <p:ext uri="{D42A27DB-BD31-4B8C-83A1-F6EECF244321}">
+                <p14:modId xmlns:p14="http://schemas.microsoft.com/office/powerpoint/2010/main" val="1579011935"/>
+              </p:ext>
+            </p:extLst>
+          </p:nvPr>
+        </p:nvGraphicFramePr>
+        <p:xfrm>
+          <a:off x="548640" y="1280160"/>
+          <a:ext cx="7863840" cy="914400"/>
+        </p:xfrm>
+        <a:graphic>
+          <a:graphicData uri="http://schemas.openxmlformats.org/drawingml/2006/table">
+            <a:tbl>
+              <a:tblPr/>
+              <a:tblGrid>
+                <a:gridCol w="3931920"/>
+                <a:gridCol w="1280160"/>
+                <a:gridCol w="1371600"/>
+                <a:gridCol w="1280160"/>
+              </a:tblGrid>
+              <a:tr h="475488">
+                <a:tc>
+                  <a:txBody>
+                    <a:bodyPr/>
+                    <a:lstStyle/>
+                    <a:p>
+                      <a:pPr algn="l" indent="0" marL="0">
+                        <a:buNone/>
+                      </a:pPr>
+                      <a:r>
+                        <a:rPr lang="en-US" sz="1250" b="1" dirty="0">
+                          <a:solidFill>
+                            <a:schemeClr val="bg1"/>
+                          </a:solidFill>
+                          <a:latin typeface="Arial" pitchFamily="34" charset="0"/>
+                          <a:ea typeface="Arial" pitchFamily="34" charset="-122"/>
+                          <a:cs typeface="Arial" pitchFamily="34" charset="-120"/>
+                        </a:rPr>
+                        <a:t>Schritt</a:t>
+                      </a:r>
+                      <a:endParaRPr lang="en-US" sz="1250" dirty="0">
+                        <a:latin typeface="Arial" charset="0"/>
+                        <a:ea typeface="Arial" charset="0"/>
+                        <a:cs typeface="Arial" charset="0"/>
+                      </a:endParaRPr>
+                    </a:p>
+                  </a:txBody>
+                  <a:tcPr marL="91440" marR="91440" marT="45720" marB="45720">
+                    <a:lnL w="12700" cap="flat" cmpd="sng" algn="ctr">
+                      <a:solidFill>
+                        <a:srgbClr val="FFFFFF"/>
+                      </a:solidFill>
+                      <a:prstDash val="solid"/>
+                      <a:round/>
+                      <a:headEnd type="none" w="med" len="med"/>
+                      <a:tailEnd type="none" w="med" len="med"/>
+                    </a:lnL>
+                    <a:lnR w="12700" cap="flat" cmpd="sng" algn="ctr">
+                      <a:solidFill>
+                        <a:srgbClr val="FFFFFF"/>
+                      </a:solidFill>
+                      <a:prstDash val="solid"/>
+                      <a:round/>
+                      <a:headEnd type="none" w="med" len="med"/>
+                      <a:tailEnd type="none" w="med" len="med"/>
+                    </a:lnR>
+                    <a:lnT w="12700" cap="flat" cmpd="sng" algn="ctr">
+                      <a:solidFill>
+                        <a:srgbClr val="FFFFFF"/>
+                      </a:solidFill>
+                      <a:prstDash val="solid"/>
+                      <a:round/>
+                      <a:headEnd type="none" w="med" len="med"/>
+                      <a:tailEnd type="none" w="med" len="med"/>
+                    </a:lnT>
+                    <a:lnB w="12700" cap="flat" cmpd="sng" algn="ctr">
+                      <a:solidFill>
+                        <a:srgbClr val="FFFFFF"/>
+                      </a:solidFill>
+                      <a:prstDash val="solid"/>
+                      <a:round/>
+                      <a:headEnd type="none" w="med" len="med"/>
+                      <a:tailEnd type="none" w="med" len="med"/>
+                    </a:lnB>
+                    <a:solidFill>
+                      <a:schemeClr val="accent2"/>
+                    </a:solidFill>
+                  </a:tcPr>
+                </a:tc>
+                <a:tc>
+                  <a:txBody>
+                    <a:bodyPr/>
+                    <a:lstStyle/>
+                    <a:p>
+                      <a:pPr algn="r" indent="0" marL="0">
+                        <a:buNone/>
+                      </a:pPr>
+                      <a:r>
+                        <a:rPr lang="en-US" sz="1250" b="1" dirty="0">
+                          <a:solidFill>
+                            <a:schemeClr val="bg1"/>
+                          </a:solidFill>
+                          <a:latin typeface="Arial" pitchFamily="34" charset="0"/>
+                          <a:ea typeface="Arial" pitchFamily="34" charset="-122"/>
+                          <a:cs typeface="Arial" pitchFamily="34" charset="-120"/>
+                        </a:rPr>
+                        <a:t>1. OG, 85 m²</a:t>
+                      </a:r>
+                      <a:endParaRPr lang="en-US" sz="1250" dirty="0">
+                        <a:latin typeface="Arial" charset="0"/>
+                        <a:ea typeface="Arial" charset="0"/>
+                        <a:cs typeface="Arial" charset="0"/>
+                      </a:endParaRPr>
+                    </a:p>
+                  </a:txBody>
+                  <a:tcPr marL="91440" marR="91440" marT="45720" marB="45720">
+                    <a:lnL w="12700" cap="flat" cmpd="sng" algn="ctr">
+                      <a:solidFill>
+                        <a:srgbClr val="FFFFFF"/>
+                      </a:solidFill>
+                      <a:prstDash val="solid"/>
+                      <a:round/>
+                      <a:headEnd type="none" w="med" len="med"/>
+                      <a:tailEnd type="none" w="med" len="med"/>
+                    </a:lnL>
+                    <a:lnR w="12700" cap="flat" cmpd="sng" algn="ctr">
+                      <a:solidFill>
+                        <a:srgbClr val="FFFFFF"/>
+                      </a:solidFill>
+                      <a:prstDash val="solid"/>
+                      <a:round/>
+                      <a:headEnd type="none" w="med" len="med"/>
+                      <a:tailEnd type="none" w="med" len="med"/>
+                    </a:lnR>
+                    <a:lnT w="12700" cap="flat" cmpd="sng" algn="ctr">
+                      <a:solidFill>
+                        <a:srgbClr val="FFFFFF"/>
+                      </a:solidFill>
+                      <a:prstDash val="solid"/>
+                      <a:round/>
+                      <a:headEnd type="none" w="med" len="med"/>
+                      <a:tailEnd type="none" w="med" len="med"/>
+                    </a:lnT>
+                    <a:lnB w="12700" cap="flat" cmpd="sng" algn="ctr">
+                      <a:solidFill>
+                        <a:srgbClr val="FFFFFF"/>
+                      </a:solidFill>
+                      <a:prstDash val="solid"/>
+                      <a:round/>
+                      <a:headEnd type="none" w="med" len="med"/>
+                      <a:tailEnd type="none" w="med" len="med"/>
+                    </a:lnB>
+                    <a:solidFill>
+                      <a:schemeClr val="accent2"/>
+                    </a:solidFill>
+                  </a:tcPr>
+                </a:tc>
+                <a:tc>
+                  <a:txBody>
+                    <a:bodyPr/>
+                    <a:lstStyle/>
+                    <a:p>
+                      <a:pPr algn="r" indent="0" marL="0">
+                        <a:buNone/>
+                      </a:pPr>
+                      <a:r>
+                        <a:rPr lang="en-US" sz="1250" b="1" dirty="0">
+                          <a:solidFill>
+                            <a:schemeClr val="bg1"/>
+                          </a:solidFill>
+                          <a:latin typeface="Arial" pitchFamily="34" charset="0"/>
+                          <a:ea typeface="Arial" pitchFamily="34" charset="-122"/>
+                          <a:cs typeface="Arial" pitchFamily="34" charset="-120"/>
+                        </a:rPr>
+                        <a:t>Staffel, 56 m²</a:t>
+                      </a:r>
+                      <a:endParaRPr lang="en-US" sz="1250" dirty="0">
+                        <a:latin typeface="Arial" charset="0"/>
+                        <a:ea typeface="Arial" charset="0"/>
+                        <a:cs typeface="Arial" charset="0"/>
+                      </a:endParaRPr>
+                    </a:p>
+                  </a:txBody>
+                  <a:tcPr marL="91440" marR="91440" marT="45720" marB="45720">
+                    <a:lnL w="12700" cap="flat" cmpd="sng" algn="ctr">
+                      <a:solidFill>
+                        <a:srgbClr val="FFFFFF"/>
+                      </a:solidFill>
+                      <a:prstDash val="solid"/>
+                      <a:round/>
+                      <a:headEnd type="none" w="med" len="med"/>
+                      <a:tailEnd type="none" w="med" len="med"/>
+                    </a:lnL>
+                    <a:lnR w="12700" cap="flat" cmpd="sng" algn="ctr">
+                      <a:solidFill>
+                        <a:srgbClr val="FFFFFF"/>
+                      </a:solidFill>
+                      <a:prstDash val="solid"/>
+                      <a:round/>
+                      <a:headEnd type="none" w="med" len="med"/>
+                      <a:tailEnd type="none" w="med" len="med"/>
+                    </a:lnR>
+                    <a:lnT w="12700" cap="flat" cmpd="sng" algn="ctr">
+                      <a:solidFill>
+                        <a:srgbClr val="FFFFFF"/>
+                      </a:solidFill>
+                      <a:prstDash val="solid"/>
+                      <a:round/>
+                      <a:headEnd type="none" w="med" len="med"/>
+                      <a:tailEnd type="none" w="med" len="med"/>
+                    </a:lnT>
+                    <a:lnB w="12700" cap="flat" cmpd="sng" algn="ctr">
+                      <a:solidFill>
+                        <a:srgbClr val="FFFFFF"/>
+                      </a:solidFill>
+                      <a:prstDash val="solid"/>
+                      <a:round/>
+                      <a:headEnd type="none" w="med" len="med"/>
+                      <a:tailEnd type="none" w="med" len="med"/>
+                    </a:lnB>
+                    <a:solidFill>
+                      <a:schemeClr val="accent2"/>
+                    </a:solidFill>
+                  </a:tcPr>
+                </a:tc>
+                <a:tc>
+                  <a:txBody>
+                    <a:bodyPr/>
+                    <a:lstStyle/>
+                    <a:p>
+                      <a:pPr algn="r" indent="0" marL="0">
+                        <a:buNone/>
+                      </a:pPr>
+                      <a:r>
+                        <a:rPr lang="en-US" sz="1250" b="1" dirty="0">
+                          <a:solidFill>
+                            <a:schemeClr val="bg1"/>
+                          </a:solidFill>
+                          <a:latin typeface="Arial" pitchFamily="34" charset="0"/>
+                          <a:ea typeface="Arial" pitchFamily="34" charset="-122"/>
+                          <a:cs typeface="Arial" pitchFamily="34" charset="-120"/>
+                        </a:rPr>
+                        <a:t>Du: Gastro</a:t>
+                      </a:r>
+                      <a:endParaRPr lang="en-US" sz="1250" dirty="0">
+                        <a:latin typeface="Arial" charset="0"/>
+                        <a:ea typeface="Arial" charset="0"/>
+                        <a:cs typeface="Arial" charset="0"/>
+                      </a:endParaRPr>
+                    </a:p>
+                  </a:txBody>
+                  <a:tcPr marL="91440" marR="91440" marT="45720" marB="45720">
+                    <a:lnL w="12700" cap="flat" cmpd="sng" algn="ctr">
+                      <a:solidFill>
+                        <a:srgbClr val="FFFFFF"/>
+                      </a:solidFill>
+                      <a:prstDash val="solid"/>
+                      <a:round/>
+                      <a:headEnd type="none" w="med" len="med"/>
+                      <a:tailEnd type="none" w="med" len="med"/>
+                    </a:lnL>
+                    <a:lnR w="12700" cap="flat" cmpd="sng" algn="ctr">
+                      <a:solidFill>
+                        <a:srgbClr val="FFFFFF"/>
+                      </a:solidFill>
+                      <a:prstDash val="solid"/>
+                      <a:round/>
+                      <a:headEnd type="none" w="med" len="med"/>
+                      <a:tailEnd type="none" w="med" len="med"/>
+                    </a:lnR>
+                    <a:lnT w="12700" cap="flat" cmpd="sng" algn="ctr">
+                      <a:solidFill>
+                        <a:srgbClr val="FFFFFF"/>
+                      </a:solidFill>
+                      <a:prstDash val="solid"/>
+                      <a:round/>
+                      <a:headEnd type="none" w="med" len="med"/>
+                      <a:tailEnd type="none" w="med" len="med"/>
+                    </a:lnT>
+                    <a:lnB w="12700" cap="flat" cmpd="sng" algn="ctr">
+                      <a:solidFill>
+                        <a:srgbClr val="FFFFFF"/>
+                      </a:solidFill>
+                      <a:prstDash val="solid"/>
+                      <a:round/>
+                      <a:headEnd type="none" w="med" len="med"/>
+                      <a:tailEnd type="none" w="med" len="med"/>
+                    </a:lnB>
+                    <a:solidFill>
+                      <a:schemeClr val="accent2"/>
+                    </a:solidFill>
+                  </a:tcPr>
+                </a:tc>
+              </a:tr>
+              <a:tr h="475488">
+                <a:tc>
+                  <a:txBody>
+                    <a:bodyPr/>
+                    <a:lstStyle/>
+                    <a:p>
+                      <a:pPr indent="0" marL="0">
+                        <a:buNone/>
+                      </a:pPr>
+                      <a:r>
+                        <a:rPr lang="en-US" sz="1250" dirty="0">
+                          <a:solidFill>
+                            <a:srgbClr val="000000"/>
+                          </a:solidFill>
+                          <a:latin typeface="Arial" pitchFamily="34" charset="0"/>
+                          <a:ea typeface="Arial" pitchFamily="34" charset="-122"/>
+                          <a:cs typeface="Arial" pitchFamily="34" charset="-120"/>
+                        </a:rPr>
+                        <a:t>Selbstkostenpreis, 1 % Tilgung (heute)</a:t>
+                      </a:r>
+                      <a:endParaRPr lang="en-US" sz="1250" dirty="0">
+                        <a:latin typeface="Arial" charset="0"/>
+                        <a:ea typeface="Arial" charset="0"/>
+                        <a:cs typeface="Arial" charset="0"/>
+                      </a:endParaRPr>
+                    </a:p>
+                  </a:txBody>
+                  <a:tcPr marL="91440" marR="91440" marT="45720" marB="45720">
+                    <a:lnL w="12700" cap="flat" cmpd="sng" algn="ctr">
+                      <a:solidFill>
+                        <a:srgbClr val="FFFFFF"/>
+                      </a:solidFill>
+                      <a:prstDash val="solid"/>
+                      <a:round/>
+                      <a:headEnd type="none" w="med" len="med"/>
+                      <a:tailEnd type="none" w="med" len="med"/>
+                    </a:lnL>
+                    <a:lnR w="12700" cap="flat" cmpd="sng" algn="ctr">
+                      <a:solidFill>
+                        <a:srgbClr val="FFFFFF"/>
+                      </a:solidFill>
+                      <a:prstDash val="solid"/>
+                      <a:round/>
+                      <a:headEnd type="none" w="med" len="med"/>
+                      <a:tailEnd type="none" w="med" len="med"/>
+                    </a:lnR>
+                    <a:lnT w="12700" cap="flat" cmpd="sng" algn="ctr">
+                      <a:solidFill>
+                        <a:srgbClr val="FFFFFF"/>
+                      </a:solidFill>
+                      <a:prstDash val="solid"/>
+                      <a:round/>
+                      <a:headEnd type="none" w="med" len="med"/>
+                      <a:tailEnd type="none" w="med" len="med"/>
+                    </a:lnT>
+                    <a:lnB w="12700" cap="flat" cmpd="sng" algn="ctr">
+                      <a:solidFill>
+                        <a:srgbClr val="FFFFFF"/>
+                      </a:solidFill>
+                      <a:prstDash val="solid"/>
+                      <a:round/>
+                      <a:headEnd type="none" w="med" len="med"/>
+                      <a:tailEnd type="none" w="med" len="med"/>
+                    </a:lnB>
+                  </a:tcPr>
+                </a:tc>
+                <a:tc>
+                  <a:txBody>
+                    <a:bodyPr/>
+                    <a:lstStyle/>
+                    <a:p>
+                      <a:pPr algn="r" indent="0" marL="0">
+                        <a:buNone/>
+                      </a:pPr>
+                      <a:r>
+                        <a:rPr lang="en-US" sz="1250" b="1" dirty="0">
+                          <a:solidFill>
+                            <a:schemeClr val="accent6"/>
+                          </a:solidFill>
+                          <a:latin typeface="Arial" pitchFamily="34" charset="0"/>
+                          <a:ea typeface="Arial" pitchFamily="34" charset="-122"/>
+                          <a:cs typeface="Arial" pitchFamily="34" charset="-120"/>
+                        </a:rPr>
+                        <a:t>−347 €</a:t>
+                      </a:r>
+                      <a:endParaRPr lang="en-US" sz="1250" dirty="0">
+                        <a:latin typeface="Arial" charset="0"/>
+                        <a:ea typeface="Arial" charset="0"/>
+                        <a:cs typeface="Arial" charset="0"/>
+                      </a:endParaRPr>
+                    </a:p>
+                  </a:txBody>
+                  <a:tcPr marL="91440" marR="91440" marT="45720" marB="45720">
+                    <a:lnL w="12700" cap="flat" cmpd="sng" algn="ctr">
+                      <a:solidFill>
+                        <a:srgbClr val="FFFFFF"/>
+                      </a:solidFill>
+                      <a:prstDash val="solid"/>
+                      <a:round/>
+                      <a:headEnd type="none" w="med" len="med"/>
+                      <a:tailEnd type="none" w="med" len="med"/>
+                    </a:lnL>
+                    <a:lnR w="12700" cap="flat" cmpd="sng" algn="ctr">
+                      <a:solidFill>
+                        <a:srgbClr val="FFFFFF"/>
+                      </a:solidFill>
+                      <a:prstDash val="solid"/>
+                      <a:round/>
+                      <a:headEnd type="none" w="med" len="med"/>
+                      <a:tailEnd type="none" w="med" len="med"/>
+                    </a:lnR>
+                    <a:lnT w="12700" cap="flat" cmpd="sng" algn="ctr">
+                      <a:solidFill>
+                        <a:srgbClr val="FFFFFF"/>
+                      </a:solidFill>
+                      <a:prstDash val="solid"/>
+                      <a:round/>
+                      <a:headEnd type="none" w="med" len="med"/>
+                      <a:tailEnd type="none" w="med" len="med"/>
+                    </a:lnT>
+                    <a:lnB w="12700" cap="flat" cmpd="sng" algn="ctr">
+                      <a:solidFill>
+                        <a:srgbClr val="FFFFFF"/>
+                      </a:solidFill>
+                      <a:prstDash val="solid"/>
+                      <a:round/>
+                      <a:headEnd type="none" w="med" len="med"/>
+                      <a:tailEnd type="none" w="med" len="med"/>
+                    </a:lnB>
+                    <a:solidFill>
+                      <a:srgbClr val="F8E4E2"/>
+                    </a:solidFill>
+                  </a:tcPr>
+                </a:tc>
+                <a:tc>
+                  <a:txBody>
+                    <a:bodyPr/>
+                    <a:lstStyle/>
+                    <a:p>
+                      <a:pPr algn="r" indent="0" marL="0">
+                        <a:buNone/>
+                      </a:pPr>
+                      <a:r>
+                        <a:rPr lang="en-US" sz="1250" b="1" dirty="0">
+                          <a:solidFill>
+                            <a:schemeClr val="accent5"/>
+                          </a:solidFill>
+                          <a:latin typeface="Arial" pitchFamily="34" charset="0"/>
+                          <a:ea typeface="Arial" pitchFamily="34" charset="-122"/>
+                          <a:cs typeface="Arial" pitchFamily="34" charset="-120"/>
+                        </a:rPr>
+                        <a:t>+58 €</a:t>
+                      </a:r>
+                      <a:endParaRPr lang="en-US" sz="1250" dirty="0">
+                        <a:latin typeface="Arial" charset="0"/>
+                        <a:ea typeface="Arial" charset="0"/>
+                        <a:cs typeface="Arial" charset="0"/>
+                      </a:endParaRPr>
+                    </a:p>
+                  </a:txBody>
+                  <a:tcPr marL="91440" marR="91440" marT="45720" marB="45720">
+                    <a:lnL w="12700" cap="flat" cmpd="sng" algn="ctr">
+                      <a:solidFill>
+                        <a:srgbClr val="FFFFFF"/>
+                      </a:solidFill>
+                      <a:prstDash val="solid"/>
+                      <a:round/>
+                      <a:headEnd type="none" w="med" len="med"/>
+                      <a:tailEnd type="none" w="med" len="med"/>
+                    </a:lnL>
+                    <a:lnR w="12700" cap="flat" cmpd="sng" algn="ctr">
+                      <a:solidFill>
+                        <a:srgbClr val="FFFFFF"/>
+                      </a:solidFill>
+                      <a:prstDash val="solid"/>
+                      <a:round/>
+                      <a:headEnd type="none" w="med" len="med"/>
+                      <a:tailEnd type="none" w="med" len="med"/>
+                    </a:lnR>
+                    <a:lnT w="12700" cap="flat" cmpd="sng" algn="ctr">
+                      <a:solidFill>
+                        <a:srgbClr val="FFFFFF"/>
+                      </a:solidFill>
+                      <a:prstDash val="solid"/>
+                      <a:round/>
+                      <a:headEnd type="none" w="med" len="med"/>
+                      <a:tailEnd type="none" w="med" len="med"/>
+                    </a:lnT>
+                    <a:lnB w="12700" cap="flat" cmpd="sng" algn="ctr">
+                      <a:solidFill>
+                        <a:srgbClr val="FFFFFF"/>
+                      </a:solidFill>
+                      <a:prstDash val="solid"/>
+                      <a:round/>
+                      <a:headEnd type="none" w="med" len="med"/>
+                      <a:tailEnd type="none" w="med" len="med"/>
+                    </a:lnB>
+                    <a:solidFill>
+                      <a:srgbClr val="E3F1EA"/>
+                    </a:solidFill>
+                  </a:tcPr>
+                </a:tc>
+                <a:tc>
+                  <a:txBody>
+                    <a:bodyPr/>
+                    <a:lstStyle/>
+                    <a:p>
+                      <a:pPr algn="r" indent="0" marL="0">
+                        <a:buNone/>
+                      </a:pPr>
+                      <a:r>
+                        <a:rPr lang="en-US" sz="1250" b="1" dirty="0">
+                          <a:solidFill>
+                            <a:schemeClr val="accent5"/>
+                          </a:solidFill>
+                          <a:latin typeface="Arial" pitchFamily="34" charset="0"/>
+                          <a:ea typeface="Arial" pitchFamily="34" charset="-122"/>
+                          <a:cs typeface="Arial" pitchFamily="34" charset="-120"/>
+                        </a:rPr>
+                        <a:t>+5.074 €</a:t>
+                      </a:r>
+                      <a:endParaRPr lang="en-US" sz="1250" dirty="0">
+                        <a:latin typeface="Arial" charset="0"/>
+                        <a:ea typeface="Arial" charset="0"/>
+                        <a:cs typeface="Arial" charset="0"/>
+                      </a:endParaRPr>
+                    </a:p>
+                  </a:txBody>
+                  <a:tcPr marL="91440" marR="91440" marT="45720" marB="45720">
+                    <a:lnL w="12700" cap="flat" cmpd="sng" algn="ctr">
+                      <a:solidFill>
+                        <a:srgbClr val="FFFFFF"/>
+                      </a:solidFill>
+                      <a:prstDash val="solid"/>
+                      <a:round/>
+                      <a:headEnd type="none" w="med" len="med"/>
+                      <a:tailEnd type="none" w="med" len="med"/>
+                    </a:lnL>
+                    <a:lnR w="12700" cap="flat" cmpd="sng" algn="ctr">
+                      <a:solidFill>
+                        <a:srgbClr val="FFFFFF"/>
+                      </a:solidFill>
+                      <a:prstDash val="solid"/>
+                      <a:round/>
+                      <a:headEnd type="none" w="med" len="med"/>
+                      <a:tailEnd type="none" w="med" len="med"/>
+                    </a:lnR>
+                    <a:lnT w="12700" cap="flat" cmpd="sng" algn="ctr">
+                      <a:solidFill>
+                        <a:srgbClr val="FFFFFF"/>
+                      </a:solidFill>
+                      <a:prstDash val="solid"/>
+                      <a:round/>
+                      <a:headEnd type="none" w="med" len="med"/>
+                      <a:tailEnd type="none" w="med" len="med"/>
+                    </a:lnT>
+                    <a:lnB w="12700" cap="flat" cmpd="sng" algn="ctr">
+                      <a:solidFill>
+                        <a:srgbClr val="FFFFFF"/>
+                      </a:solidFill>
+                      <a:prstDash val="solid"/>
+                      <a:round/>
+                      <a:headEnd type="none" w="med" len="med"/>
+                      <a:tailEnd type="none" w="med" len="med"/>
+                    </a:lnB>
+                    <a:solidFill>
+                      <a:srgbClr val="E3F1EA"/>
+                    </a:solidFill>
+                  </a:tcPr>
+                </a:tc>
+              </a:tr>
+              <a:tr h="475488">
+                <a:tc>
+                  <a:txBody>
+                    <a:bodyPr/>
+                    <a:lstStyle/>
+                    <a:p>
+                      <a:pPr indent="0" marL="0">
+                        <a:buNone/>
+                      </a:pPr>
+                      <a:r>
+                        <a:rPr lang="en-US" sz="1250" dirty="0">
+                          <a:solidFill>
+                            <a:srgbClr val="000000"/>
+                          </a:solidFill>
+                          <a:latin typeface="Arial" pitchFamily="34" charset="0"/>
+                          <a:ea typeface="Arial" pitchFamily="34" charset="-122"/>
+                          <a:cs typeface="Arial" pitchFamily="34" charset="-120"/>
+                        </a:rPr>
+                        <a:t>+ 15 % Förderung</a:t>
+                      </a:r>
+                      <a:endParaRPr lang="en-US" sz="1250" dirty="0">
+                        <a:latin typeface="Arial" charset="0"/>
+                        <a:ea typeface="Arial" charset="0"/>
+                        <a:cs typeface="Arial" charset="0"/>
+                      </a:endParaRPr>
+                    </a:p>
+                  </a:txBody>
+                  <a:tcPr marL="91440" marR="91440" marT="45720" marB="45720">
+                    <a:lnL w="12700" cap="flat" cmpd="sng" algn="ctr">
+                      <a:solidFill>
+                        <a:srgbClr val="FFFFFF"/>
+                      </a:solidFill>
+                      <a:prstDash val="solid"/>
+                      <a:round/>
+                      <a:headEnd type="none" w="med" len="med"/>
+                      <a:tailEnd type="none" w="med" len="med"/>
+                    </a:lnL>
+                    <a:lnR w="12700" cap="flat" cmpd="sng" algn="ctr">
+                      <a:solidFill>
+                        <a:srgbClr val="FFFFFF"/>
+                      </a:solidFill>
+                      <a:prstDash val="solid"/>
+                      <a:round/>
+                      <a:headEnd type="none" w="med" len="med"/>
+                      <a:tailEnd type="none" w="med" len="med"/>
+                    </a:lnR>
+                    <a:lnT w="12700" cap="flat" cmpd="sng" algn="ctr">
+                      <a:solidFill>
+                        <a:srgbClr val="FFFFFF"/>
+                      </a:solidFill>
+                      <a:prstDash val="solid"/>
+                      <a:round/>
+                      <a:headEnd type="none" w="med" len="med"/>
+                      <a:tailEnd type="none" w="med" len="med"/>
+                    </a:lnT>
+                    <a:lnB w="12700" cap="flat" cmpd="sng" algn="ctr">
+                      <a:solidFill>
+                        <a:srgbClr val="FFFFFF"/>
+                      </a:solidFill>
+                      <a:prstDash val="solid"/>
+                      <a:round/>
+                      <a:headEnd type="none" w="med" len="med"/>
+                      <a:tailEnd type="none" w="med" len="med"/>
+                    </a:lnB>
+                  </a:tcPr>
+                </a:tc>
+                <a:tc>
+                  <a:txBody>
+                    <a:bodyPr/>
+                    <a:lstStyle/>
+                    <a:p>
+                      <a:pPr algn="r" indent="0" marL="0">
+                        <a:buNone/>
+                      </a:pPr>
+                      <a:r>
+                        <a:rPr lang="en-US" sz="1250" b="1" dirty="0">
+                          <a:solidFill>
+                            <a:schemeClr val="accent6"/>
+                          </a:solidFill>
+                          <a:latin typeface="Arial" pitchFamily="34" charset="0"/>
+                          <a:ea typeface="Arial" pitchFamily="34" charset="-122"/>
+                          <a:cs typeface="Arial" pitchFamily="34" charset="-120"/>
+                        </a:rPr>
+                        <a:t>−166 €</a:t>
+                      </a:r>
+                      <a:endParaRPr lang="en-US" sz="1250" dirty="0">
+                        <a:latin typeface="Arial" charset="0"/>
+                        <a:ea typeface="Arial" charset="0"/>
+                        <a:cs typeface="Arial" charset="0"/>
+                      </a:endParaRPr>
+                    </a:p>
+                  </a:txBody>
+                  <a:tcPr marL="91440" marR="91440" marT="45720" marB="45720">
+                    <a:lnL w="12700" cap="flat" cmpd="sng" algn="ctr">
+                      <a:solidFill>
+                        <a:srgbClr val="FFFFFF"/>
+                      </a:solidFill>
+                      <a:prstDash val="solid"/>
+                      <a:round/>
+                      <a:headEnd type="none" w="med" len="med"/>
+                      <a:tailEnd type="none" w="med" len="med"/>
+                    </a:lnL>
+                    <a:lnR w="12700" cap="flat" cmpd="sng" algn="ctr">
+                      <a:solidFill>
+                        <a:srgbClr val="FFFFFF"/>
+                      </a:solidFill>
+                      <a:prstDash val="solid"/>
+                      <a:round/>
+                      <a:headEnd type="none" w="med" len="med"/>
+                      <a:tailEnd type="none" w="med" len="med"/>
+                    </a:lnR>
+                    <a:lnT w="12700" cap="flat" cmpd="sng" algn="ctr">
+                      <a:solidFill>
+                        <a:srgbClr val="FFFFFF"/>
+                      </a:solidFill>
+                      <a:prstDash val="solid"/>
+                      <a:round/>
+                      <a:headEnd type="none" w="med" len="med"/>
+                      <a:tailEnd type="none" w="med" len="med"/>
+                    </a:lnT>
+                    <a:lnB w="12700" cap="flat" cmpd="sng" algn="ctr">
+                      <a:solidFill>
+                        <a:srgbClr val="FFFFFF"/>
+                      </a:solidFill>
+                      <a:prstDash val="solid"/>
+                      <a:round/>
+                      <a:headEnd type="none" w="med" len="med"/>
+                      <a:tailEnd type="none" w="med" len="med"/>
+                    </a:lnB>
+                    <a:solidFill>
+                      <a:srgbClr val="F8E4E2"/>
+                    </a:solidFill>
+                  </a:tcPr>
+                </a:tc>
+                <a:tc>
+                  <a:txBody>
+                    <a:bodyPr/>
+                    <a:lstStyle/>
+                    <a:p>
+                      <a:pPr algn="r" indent="0" marL="0">
+                        <a:buNone/>
+                      </a:pPr>
+                      <a:r>
+                        <a:rPr lang="en-US" sz="1250" b="1" dirty="0">
+                          <a:solidFill>
+                            <a:schemeClr val="accent5"/>
+                          </a:solidFill>
+                          <a:latin typeface="Arial" pitchFamily="34" charset="0"/>
+                          <a:ea typeface="Arial" pitchFamily="34" charset="-122"/>
+                          <a:cs typeface="Arial" pitchFamily="34" charset="-120"/>
+                        </a:rPr>
+                        <a:t>+178 €</a:t>
+                      </a:r>
+                      <a:endParaRPr lang="en-US" sz="1250" dirty="0">
+                        <a:latin typeface="Arial" charset="0"/>
+                        <a:ea typeface="Arial" charset="0"/>
+                        <a:cs typeface="Arial" charset="0"/>
+                      </a:endParaRPr>
+                    </a:p>
+                  </a:txBody>
+                  <a:tcPr marL="91440" marR="91440" marT="45720" marB="45720">
+                    <a:lnL w="12700" cap="flat" cmpd="sng" algn="ctr">
+                      <a:solidFill>
+                        <a:srgbClr val="FFFFFF"/>
+                      </a:solidFill>
+                      <a:prstDash val="solid"/>
+                      <a:round/>
+                      <a:headEnd type="none" w="med" len="med"/>
+                      <a:tailEnd type="none" w="med" len="med"/>
+                    </a:lnL>
+                    <a:lnR w="12700" cap="flat" cmpd="sng" algn="ctr">
+                      <a:solidFill>
+                        <a:srgbClr val="FFFFFF"/>
+                      </a:solidFill>
+                      <a:prstDash val="solid"/>
+                      <a:round/>
+                      <a:headEnd type="none" w="med" len="med"/>
+                      <a:tailEnd type="none" w="med" len="med"/>
+                    </a:lnR>
+                    <a:lnT w="12700" cap="flat" cmpd="sng" algn="ctr">
+                      <a:solidFill>
+                        <a:srgbClr val="FFFFFF"/>
+                      </a:solidFill>
+                      <a:prstDash val="solid"/>
+                      <a:round/>
+                      <a:headEnd type="none" w="med" len="med"/>
+                      <a:tailEnd type="none" w="med" len="med"/>
+                    </a:lnT>
+                    <a:lnB w="12700" cap="flat" cmpd="sng" algn="ctr">
+                      <a:solidFill>
+                        <a:srgbClr val="FFFFFF"/>
+                      </a:solidFill>
+                      <a:prstDash val="solid"/>
+                      <a:round/>
+                      <a:headEnd type="none" w="med" len="med"/>
+                      <a:tailEnd type="none" w="med" len="med"/>
+                    </a:lnB>
+                    <a:solidFill>
+                      <a:srgbClr val="E3F1EA"/>
+                    </a:solidFill>
+                  </a:tcPr>
+                </a:tc>
+                <a:tc>
+                  <a:txBody>
+                    <a:bodyPr/>
+                    <a:lstStyle/>
+                    <a:p>
+                      <a:pPr algn="r" indent="0" marL="0">
+                        <a:buNone/>
+                      </a:pPr>
+                      <a:r>
+                        <a:rPr lang="en-US" sz="1250" b="1" dirty="0">
+                          <a:solidFill>
+                            <a:schemeClr val="accent5"/>
+                          </a:solidFill>
+                          <a:latin typeface="Arial" pitchFamily="34" charset="0"/>
+                          <a:ea typeface="Arial" pitchFamily="34" charset="-122"/>
+                          <a:cs typeface="Arial" pitchFamily="34" charset="-120"/>
+                        </a:rPr>
+                        <a:t>+5.700 €</a:t>
+                      </a:r>
+                      <a:endParaRPr lang="en-US" sz="1250" dirty="0">
+                        <a:latin typeface="Arial" charset="0"/>
+                        <a:ea typeface="Arial" charset="0"/>
+                        <a:cs typeface="Arial" charset="0"/>
+                      </a:endParaRPr>
+                    </a:p>
+                  </a:txBody>
+                  <a:tcPr marL="91440" marR="91440" marT="45720" marB="45720">
+                    <a:lnL w="12700" cap="flat" cmpd="sng" algn="ctr">
+                      <a:solidFill>
+                        <a:srgbClr val="FFFFFF"/>
+                      </a:solidFill>
+                      <a:prstDash val="solid"/>
+                      <a:round/>
+                      <a:headEnd type="none" w="med" len="med"/>
+                      <a:tailEnd type="none" w="med" len="med"/>
+                    </a:lnL>
+                    <a:lnR w="12700" cap="flat" cmpd="sng" algn="ctr">
+                      <a:solidFill>
+                        <a:srgbClr val="FFFFFF"/>
+                      </a:solidFill>
+                      <a:prstDash val="solid"/>
+                      <a:round/>
+                      <a:headEnd type="none" w="med" len="med"/>
+                      <a:tailEnd type="none" w="med" len="med"/>
+                    </a:lnR>
+                    <a:lnT w="12700" cap="flat" cmpd="sng" algn="ctr">
+                      <a:solidFill>
+                        <a:srgbClr val="FFFFFF"/>
+                      </a:solidFill>
+                      <a:prstDash val="solid"/>
+                      <a:round/>
+                      <a:headEnd type="none" w="med" len="med"/>
+                      <a:tailEnd type="none" w="med" len="med"/>
+                    </a:lnT>
+                    <a:lnB w="12700" cap="flat" cmpd="sng" algn="ctr">
+                      <a:solidFill>
+                        <a:srgbClr val="FFFFFF"/>
+                      </a:solidFill>
+                      <a:prstDash val="solid"/>
+                      <a:round/>
+                      <a:headEnd type="none" w="med" len="med"/>
+                      <a:tailEnd type="none" w="med" len="med"/>
+                    </a:lnB>
+                    <a:solidFill>
+                      <a:srgbClr val="E3F1EA"/>
+                    </a:solidFill>
+                  </a:tcPr>
+                </a:tc>
+              </a:tr>
+              <a:tr h="475488">
+                <a:tc>
+                  <a:txBody>
+                    <a:bodyPr/>
+                    <a:lstStyle/>
+                    <a:p>
+                      <a:pPr indent="0" marL="0">
+                        <a:buNone/>
+                      </a:pPr>
+                      <a:r>
+                        <a:rPr lang="en-US" sz="1250" dirty="0">
+                          <a:solidFill>
+                            <a:srgbClr val="000000"/>
+                          </a:solidFill>
+                          <a:latin typeface="Arial" pitchFamily="34" charset="0"/>
+                          <a:ea typeface="Arial" pitchFamily="34" charset="-122"/>
+                          <a:cs typeface="Arial" pitchFamily="34" charset="-120"/>
+                        </a:rPr>
+                        <a:t>+ Tilgung 0 % (nur Zinsen) in den ersten Jahren</a:t>
+                      </a:r>
+                      <a:endParaRPr lang="en-US" sz="1250" dirty="0">
+                        <a:latin typeface="Arial" charset="0"/>
+                        <a:ea typeface="Arial" charset="0"/>
+                        <a:cs typeface="Arial" charset="0"/>
+                      </a:endParaRPr>
+                    </a:p>
+                  </a:txBody>
+                  <a:tcPr marL="91440" marR="91440" marT="45720" marB="45720">
+                    <a:lnL w="12700" cap="flat" cmpd="sng" algn="ctr">
+                      <a:solidFill>
+                        <a:srgbClr val="FFFFFF"/>
+                      </a:solidFill>
+                      <a:prstDash val="solid"/>
+                      <a:round/>
+                      <a:headEnd type="none" w="med" len="med"/>
+                      <a:tailEnd type="none" w="med" len="med"/>
+                    </a:lnL>
+                    <a:lnR w="12700" cap="flat" cmpd="sng" algn="ctr">
+                      <a:solidFill>
+                        <a:srgbClr val="FFFFFF"/>
+                      </a:solidFill>
+                      <a:prstDash val="solid"/>
+                      <a:round/>
+                      <a:headEnd type="none" w="med" len="med"/>
+                      <a:tailEnd type="none" w="med" len="med"/>
+                    </a:lnR>
+                    <a:lnT w="12700" cap="flat" cmpd="sng" algn="ctr">
+                      <a:solidFill>
+                        <a:srgbClr val="FFFFFF"/>
+                      </a:solidFill>
+                      <a:prstDash val="solid"/>
+                      <a:round/>
+                      <a:headEnd type="none" w="med" len="med"/>
+                      <a:tailEnd type="none" w="med" len="med"/>
+                    </a:lnT>
+                    <a:lnB w="12700" cap="flat" cmpd="sng" algn="ctr">
+                      <a:solidFill>
+                        <a:srgbClr val="FFFFFF"/>
+                      </a:solidFill>
+                      <a:prstDash val="solid"/>
+                      <a:round/>
+                      <a:headEnd type="none" w="med" len="med"/>
+                      <a:tailEnd type="none" w="med" len="med"/>
+                    </a:lnB>
+                  </a:tcPr>
+                </a:tc>
+                <a:tc>
+                  <a:txBody>
+                    <a:bodyPr/>
+                    <a:lstStyle/>
+                    <a:p>
+                      <a:pPr algn="r" indent="0" marL="0">
+                        <a:buNone/>
+                      </a:pPr>
+                      <a:r>
+                        <a:rPr lang="en-US" sz="1250" b="1" dirty="0">
+                          <a:solidFill>
+                            <a:schemeClr val="accent5"/>
+                          </a:solidFill>
+                          <a:latin typeface="Arial" pitchFamily="34" charset="0"/>
+                          <a:ea typeface="Arial" pitchFamily="34" charset="-122"/>
+                          <a:cs typeface="Arial" pitchFamily="34" charset="-120"/>
+                        </a:rPr>
+                        <a:t>+71 €</a:t>
+                      </a:r>
+                      <a:endParaRPr lang="en-US" sz="1250" dirty="0">
+                        <a:latin typeface="Arial" charset="0"/>
+                        <a:ea typeface="Arial" charset="0"/>
+                        <a:cs typeface="Arial" charset="0"/>
+                      </a:endParaRPr>
+                    </a:p>
+                  </a:txBody>
+                  <a:tcPr marL="91440" marR="91440" marT="45720" marB="45720">
+                    <a:lnL w="12700" cap="flat" cmpd="sng" algn="ctr">
+                      <a:solidFill>
+                        <a:srgbClr val="FFFFFF"/>
+                      </a:solidFill>
+                      <a:prstDash val="solid"/>
+                      <a:round/>
+                      <a:headEnd type="none" w="med" len="med"/>
+                      <a:tailEnd type="none" w="med" len="med"/>
+                    </a:lnL>
+                    <a:lnR w="12700" cap="flat" cmpd="sng" algn="ctr">
+                      <a:solidFill>
+                        <a:srgbClr val="FFFFFF"/>
+                      </a:solidFill>
+                      <a:prstDash val="solid"/>
+                      <a:round/>
+                      <a:headEnd type="none" w="med" len="med"/>
+                      <a:tailEnd type="none" w="med" len="med"/>
+                    </a:lnR>
+                    <a:lnT w="12700" cap="flat" cmpd="sng" algn="ctr">
+                      <a:solidFill>
+                        <a:srgbClr val="FFFFFF"/>
+                      </a:solidFill>
+                      <a:prstDash val="solid"/>
+                      <a:round/>
+                      <a:headEnd type="none" w="med" len="med"/>
+                      <a:tailEnd type="none" w="med" len="med"/>
+                    </a:lnT>
+                    <a:lnB w="12700" cap="flat" cmpd="sng" algn="ctr">
+                      <a:solidFill>
+                        <a:srgbClr val="FFFFFF"/>
+                      </a:solidFill>
+                      <a:prstDash val="solid"/>
+                      <a:round/>
+                      <a:headEnd type="none" w="med" len="med"/>
+                      <a:tailEnd type="none" w="med" len="med"/>
+                    </a:lnB>
+                    <a:solidFill>
+                      <a:srgbClr val="E3F1EA"/>
+                    </a:solidFill>
+                  </a:tcPr>
+                </a:tc>
+                <a:tc>
+                  <a:txBody>
+                    <a:bodyPr/>
+                    <a:lstStyle/>
+                    <a:p>
+                      <a:pPr algn="r" indent="0" marL="0">
+                        <a:buNone/>
+                      </a:pPr>
+                      <a:r>
+                        <a:rPr lang="en-US" sz="1250" b="1" dirty="0">
+                          <a:solidFill>
+                            <a:schemeClr val="accent5"/>
+                          </a:solidFill>
+                          <a:latin typeface="Arial" pitchFamily="34" charset="0"/>
+                          <a:ea typeface="Arial" pitchFamily="34" charset="-122"/>
+                          <a:cs typeface="Arial" pitchFamily="34" charset="-120"/>
+                        </a:rPr>
+                        <a:t>+335 €</a:t>
+                      </a:r>
+                      <a:endParaRPr lang="en-US" sz="1250" dirty="0">
+                        <a:latin typeface="Arial" charset="0"/>
+                        <a:ea typeface="Arial" charset="0"/>
+                        <a:cs typeface="Arial" charset="0"/>
+                      </a:endParaRPr>
+                    </a:p>
+                  </a:txBody>
+                  <a:tcPr marL="91440" marR="91440" marT="45720" marB="45720">
+                    <a:lnL w="12700" cap="flat" cmpd="sng" algn="ctr">
+                      <a:solidFill>
+                        <a:srgbClr val="FFFFFF"/>
+                      </a:solidFill>
+                      <a:prstDash val="solid"/>
+                      <a:round/>
+                      <a:headEnd type="none" w="med" len="med"/>
+                      <a:tailEnd type="none" w="med" len="med"/>
+                    </a:lnL>
+                    <a:lnR w="12700" cap="flat" cmpd="sng" algn="ctr">
+                      <a:solidFill>
+                        <a:srgbClr val="FFFFFF"/>
+                      </a:solidFill>
+                      <a:prstDash val="solid"/>
+                      <a:round/>
+                      <a:headEnd type="none" w="med" len="med"/>
+                      <a:tailEnd type="none" w="med" len="med"/>
+                    </a:lnR>
+                    <a:lnT w="12700" cap="flat" cmpd="sng" algn="ctr">
+                      <a:solidFill>
+                        <a:srgbClr val="FFFFFF"/>
+                      </a:solidFill>
+                      <a:prstDash val="solid"/>
+                      <a:round/>
+                      <a:headEnd type="none" w="med" len="med"/>
+                      <a:tailEnd type="none" w="med" len="med"/>
+                    </a:lnT>
+                    <a:lnB w="12700" cap="flat" cmpd="sng" algn="ctr">
+                      <a:solidFill>
+                        <a:srgbClr val="FFFFFF"/>
+                      </a:solidFill>
+                      <a:prstDash val="solid"/>
+                      <a:round/>
+                      <a:headEnd type="none" w="med" len="med"/>
+                      <a:tailEnd type="none" w="med" len="med"/>
+                    </a:lnB>
+                    <a:solidFill>
+                      <a:srgbClr val="E3F1EA"/>
+                    </a:solidFill>
+                  </a:tcPr>
+                </a:tc>
+                <a:tc>
+                  <a:txBody>
+                    <a:bodyPr/>
+                    <a:lstStyle/>
+                    <a:p>
+                      <a:pPr algn="r" indent="0" marL="0">
+                        <a:buNone/>
+                      </a:pPr>
+                      <a:r>
+                        <a:rPr lang="en-US" sz="1250" b="1" dirty="0">
+                          <a:solidFill>
+                            <a:schemeClr val="accent5"/>
+                          </a:solidFill>
+                          <a:latin typeface="Arial" pitchFamily="34" charset="0"/>
+                          <a:ea typeface="Arial" pitchFamily="34" charset="-122"/>
+                          <a:cs typeface="Arial" pitchFamily="34" charset="-120"/>
+                        </a:rPr>
+                        <a:t>+6.526 €</a:t>
+                      </a:r>
+                      <a:endParaRPr lang="en-US" sz="1250" dirty="0">
+                        <a:latin typeface="Arial" charset="0"/>
+                        <a:ea typeface="Arial" charset="0"/>
+                        <a:cs typeface="Arial" charset="0"/>
+                      </a:endParaRPr>
+                    </a:p>
+                  </a:txBody>
+                  <a:tcPr marL="91440" marR="91440" marT="45720" marB="45720">
+                    <a:lnL w="12700" cap="flat" cmpd="sng" algn="ctr">
+                      <a:solidFill>
+                        <a:srgbClr val="FFFFFF"/>
+                      </a:solidFill>
+                      <a:prstDash val="solid"/>
+                      <a:round/>
+                      <a:headEnd type="none" w="med" len="med"/>
+                      <a:tailEnd type="none" w="med" len="med"/>
+                    </a:lnL>
+                    <a:lnR w="12700" cap="flat" cmpd="sng" algn="ctr">
+                      <a:solidFill>
+                        <a:srgbClr val="FFFFFF"/>
+                      </a:solidFill>
+                      <a:prstDash val="solid"/>
+                      <a:round/>
+                      <a:headEnd type="none" w="med" len="med"/>
+                      <a:tailEnd type="none" w="med" len="med"/>
+                    </a:lnR>
+                    <a:lnT w="12700" cap="flat" cmpd="sng" algn="ctr">
+                      <a:solidFill>
+                        <a:srgbClr val="FFFFFF"/>
+                      </a:solidFill>
+                      <a:prstDash val="solid"/>
+                      <a:round/>
+                      <a:headEnd type="none" w="med" len="med"/>
+                      <a:tailEnd type="none" w="med" len="med"/>
+                    </a:lnT>
+                    <a:lnB w="12700" cap="flat" cmpd="sng" algn="ctr">
+                      <a:solidFill>
+                        <a:srgbClr val="FFFFFF"/>
+                      </a:solidFill>
+                      <a:prstDash val="solid"/>
+                      <a:round/>
+                      <a:headEnd type="none" w="med" len="med"/>
+                      <a:tailEnd type="none" w="med" len="med"/>
+                    </a:lnB>
+                    <a:solidFill>
+                      <a:srgbClr val="E3F1EA"/>
+                    </a:solidFill>
+                  </a:tcPr>
+                </a:tc>
+              </a:tr>
+              <a:tr h="475488">
+                <a:tc>
+                  <a:txBody>
+                    <a:bodyPr/>
+                    <a:lstStyle/>
+                    <a:p>
+                      <a:pPr indent="0" marL="0">
+                        <a:buNone/>
+                      </a:pPr>
+                      <a:r>
+                        <a:rPr lang="en-US" sz="1250" dirty="0">
+                          <a:solidFill>
+                            <a:srgbClr val="000000"/>
+                          </a:solidFill>
+                          <a:latin typeface="Arial" pitchFamily="34" charset="0"/>
+                          <a:ea typeface="Arial" pitchFamily="34" charset="-122"/>
+                          <a:cs typeface="Arial" pitchFamily="34" charset="-120"/>
+                        </a:rPr>
+                        <a:t>+ Baukosten 2.000 €/m² statt 2.200 €</a:t>
+                      </a:r>
+                      <a:endParaRPr lang="en-US" sz="1250" dirty="0">
+                        <a:latin typeface="Arial" charset="0"/>
+                        <a:ea typeface="Arial" charset="0"/>
+                        <a:cs typeface="Arial" charset="0"/>
+                      </a:endParaRPr>
+                    </a:p>
+                  </a:txBody>
+                  <a:tcPr marL="91440" marR="91440" marT="45720" marB="45720">
+                    <a:lnL w="12700" cap="flat" cmpd="sng" algn="ctr">
+                      <a:solidFill>
+                        <a:srgbClr val="FFFFFF"/>
+                      </a:solidFill>
+                      <a:prstDash val="solid"/>
+                      <a:round/>
+                      <a:headEnd type="none" w="med" len="med"/>
+                      <a:tailEnd type="none" w="med" len="med"/>
+                    </a:lnL>
+                    <a:lnR w="12700" cap="flat" cmpd="sng" algn="ctr">
+                      <a:solidFill>
+                        <a:srgbClr val="FFFFFF"/>
+                      </a:solidFill>
+                      <a:prstDash val="solid"/>
+                      <a:round/>
+                      <a:headEnd type="none" w="med" len="med"/>
+                      <a:tailEnd type="none" w="med" len="med"/>
+                    </a:lnR>
+                    <a:lnT w="12700" cap="flat" cmpd="sng" algn="ctr">
+                      <a:solidFill>
+                        <a:srgbClr val="FFFFFF"/>
+                      </a:solidFill>
+                      <a:prstDash val="solid"/>
+                      <a:round/>
+                      <a:headEnd type="none" w="med" len="med"/>
+                      <a:tailEnd type="none" w="med" len="med"/>
+                    </a:lnT>
+                    <a:lnB w="12700" cap="flat" cmpd="sng" algn="ctr">
+                      <a:solidFill>
+                        <a:srgbClr val="FFFFFF"/>
+                      </a:solidFill>
+                      <a:prstDash val="solid"/>
+                      <a:round/>
+                      <a:headEnd type="none" w="med" len="med"/>
+                      <a:tailEnd type="none" w="med" len="med"/>
+                    </a:lnB>
+                  </a:tcPr>
+                </a:tc>
+                <a:tc>
+                  <a:txBody>
+                    <a:bodyPr/>
+                    <a:lstStyle/>
+                    <a:p>
+                      <a:pPr algn="r" indent="0" marL="0">
+                        <a:buNone/>
+                      </a:pPr>
+                      <a:r>
+                        <a:rPr lang="en-US" sz="1250" b="1" dirty="0">
+                          <a:solidFill>
+                            <a:schemeClr val="accent5"/>
+                          </a:solidFill>
+                          <a:latin typeface="Arial" pitchFamily="34" charset="0"/>
+                          <a:ea typeface="Arial" pitchFamily="34" charset="-122"/>
+                          <a:cs typeface="Arial" pitchFamily="34" charset="-120"/>
+                        </a:rPr>
+                        <a:t>+136 €</a:t>
+                      </a:r>
+                      <a:endParaRPr lang="en-US" sz="1250" dirty="0">
+                        <a:latin typeface="Arial" charset="0"/>
+                        <a:ea typeface="Arial" charset="0"/>
+                        <a:cs typeface="Arial" charset="0"/>
+                      </a:endParaRPr>
+                    </a:p>
+                  </a:txBody>
+                  <a:tcPr marL="91440" marR="91440" marT="45720" marB="45720">
+                    <a:lnL w="12700" cap="flat" cmpd="sng" algn="ctr">
+                      <a:solidFill>
+                        <a:srgbClr val="FFFFFF"/>
+                      </a:solidFill>
+                      <a:prstDash val="solid"/>
+                      <a:round/>
+                      <a:headEnd type="none" w="med" len="med"/>
+                      <a:tailEnd type="none" w="med" len="med"/>
+                    </a:lnL>
+                    <a:lnR w="12700" cap="flat" cmpd="sng" algn="ctr">
+                      <a:solidFill>
+                        <a:srgbClr val="FFFFFF"/>
+                      </a:solidFill>
+                      <a:prstDash val="solid"/>
+                      <a:round/>
+                      <a:headEnd type="none" w="med" len="med"/>
+                      <a:tailEnd type="none" w="med" len="med"/>
+                    </a:lnR>
+                    <a:lnT w="12700" cap="flat" cmpd="sng" algn="ctr">
+                      <a:solidFill>
+                        <a:srgbClr val="FFFFFF"/>
+                      </a:solidFill>
+                      <a:prstDash val="solid"/>
+                      <a:round/>
+                      <a:headEnd type="none" w="med" len="med"/>
+                      <a:tailEnd type="none" w="med" len="med"/>
+                    </a:lnT>
+                    <a:lnB w="12700" cap="flat" cmpd="sng" algn="ctr">
+                      <a:solidFill>
+                        <a:srgbClr val="FFFFFF"/>
+                      </a:solidFill>
+                      <a:prstDash val="solid"/>
+                      <a:round/>
+                      <a:headEnd type="none" w="med" len="med"/>
+                      <a:tailEnd type="none" w="med" len="med"/>
+                    </a:lnB>
+                    <a:solidFill>
+                      <a:srgbClr val="E3F1EA"/>
+                    </a:solidFill>
+                  </a:tcPr>
+                </a:tc>
+                <a:tc>
+                  <a:txBody>
+                    <a:bodyPr/>
+                    <a:lstStyle/>
+                    <a:p>
+                      <a:pPr algn="r" indent="0" marL="0">
+                        <a:buNone/>
+                      </a:pPr>
+                      <a:r>
+                        <a:rPr lang="en-US" sz="1250" b="1" dirty="0">
+                          <a:solidFill>
+                            <a:schemeClr val="accent5"/>
+                          </a:solidFill>
+                          <a:latin typeface="Arial" pitchFamily="34" charset="0"/>
+                          <a:ea typeface="Arial" pitchFamily="34" charset="-122"/>
+                          <a:cs typeface="Arial" pitchFamily="34" charset="-120"/>
+                        </a:rPr>
+                        <a:t>+383 €</a:t>
+                      </a:r>
+                      <a:endParaRPr lang="en-US" sz="1250" dirty="0">
+                        <a:latin typeface="Arial" charset="0"/>
+                        <a:ea typeface="Arial" charset="0"/>
+                        <a:cs typeface="Arial" charset="0"/>
+                      </a:endParaRPr>
+                    </a:p>
+                  </a:txBody>
+                  <a:tcPr marL="91440" marR="91440" marT="45720" marB="45720">
+                    <a:lnL w="12700" cap="flat" cmpd="sng" algn="ctr">
+                      <a:solidFill>
+                        <a:srgbClr val="FFFFFF"/>
+                      </a:solidFill>
+                      <a:prstDash val="solid"/>
+                      <a:round/>
+                      <a:headEnd type="none" w="med" len="med"/>
+                      <a:tailEnd type="none" w="med" len="med"/>
+                    </a:lnL>
+                    <a:lnR w="12700" cap="flat" cmpd="sng" algn="ctr">
+                      <a:solidFill>
+                        <a:srgbClr val="FFFFFF"/>
+                      </a:solidFill>
+                      <a:prstDash val="solid"/>
+                      <a:round/>
+                      <a:headEnd type="none" w="med" len="med"/>
+                      <a:tailEnd type="none" w="med" len="med"/>
+                    </a:lnR>
+                    <a:lnT w="12700" cap="flat" cmpd="sng" algn="ctr">
+                      <a:solidFill>
+                        <a:srgbClr val="FFFFFF"/>
+                      </a:solidFill>
+                      <a:prstDash val="solid"/>
+                      <a:round/>
+                      <a:headEnd type="none" w="med" len="med"/>
+                      <a:tailEnd type="none" w="med" len="med"/>
+                    </a:lnT>
+                    <a:lnB w="12700" cap="flat" cmpd="sng" algn="ctr">
+                      <a:solidFill>
+                        <a:srgbClr val="FFFFFF"/>
+                      </a:solidFill>
+                      <a:prstDash val="solid"/>
+                      <a:round/>
+                      <a:headEnd type="none" w="med" len="med"/>
+                      <a:tailEnd type="none" w="med" len="med"/>
+                    </a:lnB>
+                    <a:solidFill>
+                      <a:srgbClr val="E3F1EA"/>
+                    </a:solidFill>
+                  </a:tcPr>
+                </a:tc>
+                <a:tc>
+                  <a:txBody>
+                    <a:bodyPr/>
+                    <a:lstStyle/>
+                    <a:p>
+                      <a:pPr algn="r" indent="0" marL="0">
+                        <a:buNone/>
+                      </a:pPr>
+                      <a:r>
+                        <a:rPr lang="en-US" sz="1250" b="1" dirty="0">
+                          <a:solidFill>
+                            <a:schemeClr val="accent5"/>
+                          </a:solidFill>
+                          <a:latin typeface="Arial" pitchFamily="34" charset="0"/>
+                          <a:ea typeface="Arial" pitchFamily="34" charset="-122"/>
+                          <a:cs typeface="Arial" pitchFamily="34" charset="-120"/>
+                        </a:rPr>
+                        <a:t>+6.720 €</a:t>
+                      </a:r>
+                      <a:endParaRPr lang="en-US" sz="1250" dirty="0">
+                        <a:latin typeface="Arial" charset="0"/>
+                        <a:ea typeface="Arial" charset="0"/>
+                        <a:cs typeface="Arial" charset="0"/>
+                      </a:endParaRPr>
+                    </a:p>
+                  </a:txBody>
+                  <a:tcPr marL="91440" marR="91440" marT="45720" marB="45720">
+                    <a:lnL w="12700" cap="flat" cmpd="sng" algn="ctr">
+                      <a:solidFill>
+                        <a:srgbClr val="FFFFFF"/>
+                      </a:solidFill>
+                      <a:prstDash val="solid"/>
+                      <a:round/>
+                      <a:headEnd type="none" w="med" len="med"/>
+                      <a:tailEnd type="none" w="med" len="med"/>
+                    </a:lnL>
+                    <a:lnR w="12700" cap="flat" cmpd="sng" algn="ctr">
+                      <a:solidFill>
+                        <a:srgbClr val="FFFFFF"/>
+                      </a:solidFill>
+                      <a:prstDash val="solid"/>
+                      <a:round/>
+                      <a:headEnd type="none" w="med" len="med"/>
+                      <a:tailEnd type="none" w="med" len="med"/>
+                    </a:lnR>
+                    <a:lnT w="12700" cap="flat" cmpd="sng" algn="ctr">
+                      <a:solidFill>
+                        <a:srgbClr val="FFFFFF"/>
+                      </a:solidFill>
+                      <a:prstDash val="solid"/>
+                      <a:round/>
+                      <a:headEnd type="none" w="med" len="med"/>
+                      <a:tailEnd type="none" w="med" len="med"/>
+                    </a:lnT>
+                    <a:lnB w="12700" cap="flat" cmpd="sng" algn="ctr">
+                      <a:solidFill>
+                        <a:srgbClr val="FFFFFF"/>
+                      </a:solidFill>
+                      <a:prstDash val="solid"/>
+                      <a:round/>
+                      <a:headEnd type="none" w="med" len="med"/>
+                      <a:tailEnd type="none" w="med" len="med"/>
+                    </a:lnB>
+                    <a:solidFill>
+                      <a:srgbClr val="E3F1EA"/>
+                    </a:solidFill>
+                  </a:tcPr>
+                </a:tc>
+              </a:tr>
+              <a:tr h="475488">
+                <a:tc>
+                  <a:txBody>
+                    <a:bodyPr/>
+                    <a:lstStyle/>
+                    <a:p>
+                      <a:pPr indent="0" marL="0">
+                        <a:buNone/>
+                      </a:pPr>
+                      <a:r>
+                        <a:rPr lang="en-US" sz="1250" dirty="0">
+                          <a:solidFill>
+                            <a:srgbClr val="000000"/>
+                          </a:solidFill>
+                          <a:latin typeface="Arial" pitchFamily="34" charset="0"/>
+                          <a:ea typeface="Arial" pitchFamily="34" charset="-122"/>
+                          <a:cs typeface="Arial" pitchFamily="34" charset="-120"/>
+                        </a:rPr>
+                        <a:t>Dasselbe bei 4,0 % Zins</a:t>
+                      </a:r>
+                      <a:endParaRPr lang="en-US" sz="1250" dirty="0">
+                        <a:latin typeface="Arial" charset="0"/>
+                        <a:ea typeface="Arial" charset="0"/>
+                        <a:cs typeface="Arial" charset="0"/>
+                      </a:endParaRPr>
+                    </a:p>
+                  </a:txBody>
+                  <a:tcPr marL="91440" marR="91440" marT="45720" marB="45720">
+                    <a:lnL w="12700" cap="flat" cmpd="sng" algn="ctr">
+                      <a:solidFill>
+                        <a:srgbClr val="FFFFFF"/>
+                      </a:solidFill>
+                      <a:prstDash val="solid"/>
+                      <a:round/>
+                      <a:headEnd type="none" w="med" len="med"/>
+                      <a:tailEnd type="none" w="med" len="med"/>
+                    </a:lnL>
+                    <a:lnR w="12700" cap="flat" cmpd="sng" algn="ctr">
+                      <a:solidFill>
+                        <a:srgbClr val="FFFFFF"/>
+                      </a:solidFill>
+                      <a:prstDash val="solid"/>
+                      <a:round/>
+                      <a:headEnd type="none" w="med" len="med"/>
+                      <a:tailEnd type="none" w="med" len="med"/>
+                    </a:lnR>
+                    <a:lnT w="12700" cap="flat" cmpd="sng" algn="ctr">
+                      <a:solidFill>
+                        <a:srgbClr val="FFFFFF"/>
+                      </a:solidFill>
+                      <a:prstDash val="solid"/>
+                      <a:round/>
+                      <a:headEnd type="none" w="med" len="med"/>
+                      <a:tailEnd type="none" w="med" len="med"/>
+                    </a:lnT>
+                    <a:lnB w="12700" cap="flat" cmpd="sng" algn="ctr">
+                      <a:solidFill>
+                        <a:srgbClr val="FFFFFF"/>
+                      </a:solidFill>
+                      <a:prstDash val="solid"/>
+                      <a:round/>
+                      <a:headEnd type="none" w="med" len="med"/>
+                      <a:tailEnd type="none" w="med" len="med"/>
+                    </a:lnB>
+                  </a:tcPr>
+                </a:tc>
+                <a:tc>
+                  <a:txBody>
+                    <a:bodyPr/>
+                    <a:lstStyle/>
+                    <a:p>
+                      <a:pPr algn="r" indent="0" marL="0">
+                        <a:buNone/>
+                      </a:pPr>
+                      <a:r>
+                        <a:rPr lang="en-US" sz="1250" b="1" dirty="0">
+                          <a:solidFill>
+                            <a:schemeClr val="accent6"/>
+                          </a:solidFill>
+                          <a:latin typeface="Arial" pitchFamily="34" charset="0"/>
+                          <a:ea typeface="Arial" pitchFamily="34" charset="-122"/>
+                          <a:cs typeface="Arial" pitchFamily="34" charset="-120"/>
+                        </a:rPr>
+                        <a:t>−27 €</a:t>
+                      </a:r>
+                      <a:endParaRPr lang="en-US" sz="1250" dirty="0">
+                        <a:latin typeface="Arial" charset="0"/>
+                        <a:ea typeface="Arial" charset="0"/>
+                        <a:cs typeface="Arial" charset="0"/>
+                      </a:endParaRPr>
+                    </a:p>
+                  </a:txBody>
+                  <a:tcPr marL="91440" marR="91440" marT="45720" marB="45720">
+                    <a:lnL w="12700" cap="flat" cmpd="sng" algn="ctr">
+                      <a:solidFill>
+                        <a:srgbClr val="FFFFFF"/>
+                      </a:solidFill>
+                      <a:prstDash val="solid"/>
+                      <a:round/>
+                      <a:headEnd type="none" w="med" len="med"/>
+                      <a:tailEnd type="none" w="med" len="med"/>
+                    </a:lnL>
+                    <a:lnR w="12700" cap="flat" cmpd="sng" algn="ctr">
+                      <a:solidFill>
+                        <a:srgbClr val="FFFFFF"/>
+                      </a:solidFill>
+                      <a:prstDash val="solid"/>
+                      <a:round/>
+                      <a:headEnd type="none" w="med" len="med"/>
+                      <a:tailEnd type="none" w="med" len="med"/>
+                    </a:lnR>
+                    <a:lnT w="12700" cap="flat" cmpd="sng" algn="ctr">
+                      <a:solidFill>
+                        <a:srgbClr val="FFFFFF"/>
+                      </a:solidFill>
+                      <a:prstDash val="solid"/>
+                      <a:round/>
+                      <a:headEnd type="none" w="med" len="med"/>
+                      <a:tailEnd type="none" w="med" len="med"/>
+                    </a:lnT>
+                    <a:lnB w="12700" cap="flat" cmpd="sng" algn="ctr">
+                      <a:solidFill>
+                        <a:srgbClr val="FFFFFF"/>
+                      </a:solidFill>
+                      <a:prstDash val="solid"/>
+                      <a:round/>
+                      <a:headEnd type="none" w="med" len="med"/>
+                      <a:tailEnd type="none" w="med" len="med"/>
+                    </a:lnB>
+                    <a:solidFill>
+                      <a:srgbClr val="F8E4E2"/>
+                    </a:solidFill>
+                  </a:tcPr>
+                </a:tc>
+                <a:tc>
+                  <a:txBody>
+                    <a:bodyPr/>
+                    <a:lstStyle/>
+                    <a:p>
+                      <a:pPr algn="r" indent="0" marL="0">
+                        <a:buNone/>
+                      </a:pPr>
+                      <a:r>
+                        <a:rPr lang="en-US" sz="1250" b="1" dirty="0">
+                          <a:solidFill>
+                            <a:schemeClr val="accent5"/>
+                          </a:solidFill>
+                          <a:latin typeface="Arial" pitchFamily="34" charset="0"/>
+                          <a:ea typeface="Arial" pitchFamily="34" charset="-122"/>
+                          <a:cs typeface="Arial" pitchFamily="34" charset="-120"/>
+                        </a:rPr>
+                        <a:t>+276 €</a:t>
+                      </a:r>
+                      <a:endParaRPr lang="en-US" sz="1250" dirty="0">
+                        <a:latin typeface="Arial" charset="0"/>
+                        <a:ea typeface="Arial" charset="0"/>
+                        <a:cs typeface="Arial" charset="0"/>
+                      </a:endParaRPr>
+                    </a:p>
+                  </a:txBody>
+                  <a:tcPr marL="91440" marR="91440" marT="45720" marB="45720">
+                    <a:lnL w="12700" cap="flat" cmpd="sng" algn="ctr">
+                      <a:solidFill>
+                        <a:srgbClr val="FFFFFF"/>
+                      </a:solidFill>
+                      <a:prstDash val="solid"/>
+                      <a:round/>
+                      <a:headEnd type="none" w="med" len="med"/>
+                      <a:tailEnd type="none" w="med" len="med"/>
+                    </a:lnL>
+                    <a:lnR w="12700" cap="flat" cmpd="sng" algn="ctr">
+                      <a:solidFill>
+                        <a:srgbClr val="FFFFFF"/>
+                      </a:solidFill>
+                      <a:prstDash val="solid"/>
+                      <a:round/>
+                      <a:headEnd type="none" w="med" len="med"/>
+                      <a:tailEnd type="none" w="med" len="med"/>
+                    </a:lnR>
+                    <a:lnT w="12700" cap="flat" cmpd="sng" algn="ctr">
+                      <a:solidFill>
+                        <a:srgbClr val="FFFFFF"/>
+                      </a:solidFill>
+                      <a:prstDash val="solid"/>
+                      <a:round/>
+                      <a:headEnd type="none" w="med" len="med"/>
+                      <a:tailEnd type="none" w="med" len="med"/>
+                    </a:lnT>
+                    <a:lnB w="12700" cap="flat" cmpd="sng" algn="ctr">
+                      <a:solidFill>
+                        <a:srgbClr val="FFFFFF"/>
+                      </a:solidFill>
+                      <a:prstDash val="solid"/>
+                      <a:round/>
+                      <a:headEnd type="none" w="med" len="med"/>
+                      <a:tailEnd type="none" w="med" len="med"/>
+                    </a:lnB>
+                    <a:solidFill>
+                      <a:srgbClr val="E3F1EA"/>
+                    </a:solidFill>
+                  </a:tcPr>
+                </a:tc>
+                <a:tc>
+                  <a:txBody>
+                    <a:bodyPr/>
+                    <a:lstStyle/>
+                    <a:p>
+                      <a:pPr algn="r" indent="0" marL="0">
+                        <a:buNone/>
+                      </a:pPr>
+                      <a:r>
+                        <a:rPr lang="en-US" sz="1250" b="1" dirty="0">
+                          <a:solidFill>
+                            <a:schemeClr val="accent5"/>
+                          </a:solidFill>
+                          <a:latin typeface="Arial" pitchFamily="34" charset="0"/>
+                          <a:ea typeface="Arial" pitchFamily="34" charset="-122"/>
+                          <a:cs typeface="Arial" pitchFamily="34" charset="-120"/>
+                        </a:rPr>
+                        <a:t>+6.148 €</a:t>
+                      </a:r>
+                      <a:endParaRPr lang="en-US" sz="1250" dirty="0">
+                        <a:latin typeface="Arial" charset="0"/>
+                        <a:ea typeface="Arial" charset="0"/>
+                        <a:cs typeface="Arial" charset="0"/>
+                      </a:endParaRPr>
+                    </a:p>
+                  </a:txBody>
+                  <a:tcPr marL="91440" marR="91440" marT="45720" marB="45720">
+                    <a:lnL w="12700" cap="flat" cmpd="sng" algn="ctr">
+                      <a:solidFill>
+                        <a:srgbClr val="FFFFFF"/>
+                      </a:solidFill>
+                      <a:prstDash val="solid"/>
+                      <a:round/>
+                      <a:headEnd type="none" w="med" len="med"/>
+                      <a:tailEnd type="none" w="med" len="med"/>
+                    </a:lnL>
+                    <a:lnR w="12700" cap="flat" cmpd="sng" algn="ctr">
+                      <a:solidFill>
+                        <a:srgbClr val="FFFFFF"/>
+                      </a:solidFill>
+                      <a:prstDash val="solid"/>
+                      <a:round/>
+                      <a:headEnd type="none" w="med" len="med"/>
+                      <a:tailEnd type="none" w="med" len="med"/>
+                    </a:lnR>
+                    <a:lnT w="12700" cap="flat" cmpd="sng" algn="ctr">
+                      <a:solidFill>
+                        <a:srgbClr val="FFFFFF"/>
+                      </a:solidFill>
+                      <a:prstDash val="solid"/>
+                      <a:round/>
+                      <a:headEnd type="none" w="med" len="med"/>
+                      <a:tailEnd type="none" w="med" len="med"/>
+                    </a:lnT>
+                    <a:lnB w="12700" cap="flat" cmpd="sng" algn="ctr">
+                      <a:solidFill>
+                        <a:srgbClr val="FFFFFF"/>
+                      </a:solidFill>
+                      <a:prstDash val="solid"/>
+                      <a:round/>
+                      <a:headEnd type="none" w="med" len="med"/>
+                      <a:tailEnd type="none" w="med" len="med"/>
+                    </a:lnB>
+                    <a:solidFill>
+                      <a:srgbClr val="E3F1EA"/>
+                    </a:solidFill>
+                  </a:tcPr>
+                </a:tc>
+              </a:tr>
+              <a:tr h="475488">
+                <a:tc>
+                  <a:txBody>
+                    <a:bodyPr/>
+                    <a:lstStyle/>
+                    <a:p>
+                      <a:pPr indent="0" marL="0">
+                        <a:buNone/>
+                      </a:pPr>
+                      <a:r>
+                        <a:rPr lang="en-US" sz="1250" dirty="0">
+                          <a:solidFill>
+                            <a:srgbClr val="000000"/>
+                          </a:solidFill>
+                          <a:latin typeface="Arial" pitchFamily="34" charset="0"/>
+                          <a:ea typeface="Arial" pitchFamily="34" charset="-122"/>
+                          <a:cs typeface="Arial" pitchFamily="34" charset="-120"/>
+                        </a:rPr>
+                        <a:t>Alternative: ohne Förderung, Tilgung 0 %, Baukosten 2.000 €/m²</a:t>
+                      </a:r>
+                      <a:endParaRPr lang="en-US" sz="1250" dirty="0">
+                        <a:latin typeface="Arial" charset="0"/>
+                        <a:ea typeface="Arial" charset="0"/>
+                        <a:cs typeface="Arial" charset="0"/>
+                      </a:endParaRPr>
+                    </a:p>
+                  </a:txBody>
+                  <a:tcPr marL="91440" marR="91440" marT="45720" marB="45720">
+                    <a:lnL w="12700" cap="flat" cmpd="sng" algn="ctr">
+                      <a:solidFill>
+                        <a:srgbClr val="FFFFFF"/>
+                      </a:solidFill>
+                      <a:prstDash val="solid"/>
+                      <a:round/>
+                      <a:headEnd type="none" w="med" len="med"/>
+                      <a:tailEnd type="none" w="med" len="med"/>
+                    </a:lnL>
+                    <a:lnR w="12700" cap="flat" cmpd="sng" algn="ctr">
+                      <a:solidFill>
+                        <a:srgbClr val="FFFFFF"/>
+                      </a:solidFill>
+                      <a:prstDash val="solid"/>
+                      <a:round/>
+                      <a:headEnd type="none" w="med" len="med"/>
+                      <a:tailEnd type="none" w="med" len="med"/>
+                    </a:lnR>
+                    <a:lnT w="12700" cap="flat" cmpd="sng" algn="ctr">
+                      <a:solidFill>
+                        <a:srgbClr val="FFFFFF"/>
+                      </a:solidFill>
+                      <a:prstDash val="solid"/>
+                      <a:round/>
+                      <a:headEnd type="none" w="med" len="med"/>
+                      <a:tailEnd type="none" w="med" len="med"/>
+                    </a:lnT>
+                    <a:lnB w="12700" cap="flat" cmpd="sng" algn="ctr">
+                      <a:solidFill>
+                        <a:srgbClr val="FFFFFF"/>
+                      </a:solidFill>
+                      <a:prstDash val="solid"/>
+                      <a:round/>
+                      <a:headEnd type="none" w="med" len="med"/>
+                      <a:tailEnd type="none" w="med" len="med"/>
+                    </a:lnB>
+                  </a:tcPr>
+                </a:tc>
+                <a:tc>
+                  <a:txBody>
+                    <a:bodyPr/>
+                    <a:lstStyle/>
+                    <a:p>
+                      <a:pPr algn="r" indent="0" marL="0">
+                        <a:buNone/>
+                      </a:pPr>
+                      <a:r>
+                        <a:rPr lang="en-US" sz="1250" b="1" dirty="0">
+                          <a:solidFill>
+                            <a:schemeClr val="accent5"/>
+                          </a:solidFill>
+                          <a:latin typeface="Arial" pitchFamily="34" charset="0"/>
+                          <a:ea typeface="Arial" pitchFamily="34" charset="-122"/>
+                          <a:cs typeface="Arial" pitchFamily="34" charset="-120"/>
+                        </a:rPr>
+                        <a:t>+9 €</a:t>
+                      </a:r>
+                      <a:endParaRPr lang="en-US" sz="1250" dirty="0">
+                        <a:latin typeface="Arial" charset="0"/>
+                        <a:ea typeface="Arial" charset="0"/>
+                        <a:cs typeface="Arial" charset="0"/>
+                      </a:endParaRPr>
+                    </a:p>
+                  </a:txBody>
+                  <a:tcPr marL="91440" marR="91440" marT="45720" marB="45720">
+                    <a:lnL w="12700" cap="flat" cmpd="sng" algn="ctr">
+                      <a:solidFill>
+                        <a:srgbClr val="FFFFFF"/>
+                      </a:solidFill>
+                      <a:prstDash val="solid"/>
+                      <a:round/>
+                      <a:headEnd type="none" w="med" len="med"/>
+                      <a:tailEnd type="none" w="med" len="med"/>
+                    </a:lnL>
+                    <a:lnR w="12700" cap="flat" cmpd="sng" algn="ctr">
+                      <a:solidFill>
+                        <a:srgbClr val="FFFFFF"/>
+                      </a:solidFill>
+                      <a:prstDash val="solid"/>
+                      <a:round/>
+                      <a:headEnd type="none" w="med" len="med"/>
+                      <a:tailEnd type="none" w="med" len="med"/>
+                    </a:lnR>
+                    <a:lnT w="12700" cap="flat" cmpd="sng" algn="ctr">
+                      <a:solidFill>
+                        <a:srgbClr val="FFFFFF"/>
+                      </a:solidFill>
+                      <a:prstDash val="solid"/>
+                      <a:round/>
+                      <a:headEnd type="none" w="med" len="med"/>
+                      <a:tailEnd type="none" w="med" len="med"/>
+                    </a:lnT>
+                    <a:lnB w="12700" cap="flat" cmpd="sng" algn="ctr">
+                      <a:solidFill>
+                        <a:srgbClr val="FFFFFF"/>
+                      </a:solidFill>
+                      <a:prstDash val="solid"/>
+                      <a:round/>
+                      <a:headEnd type="none" w="med" len="med"/>
+                      <a:tailEnd type="none" w="med" len="med"/>
+                    </a:lnB>
+                    <a:solidFill>
+                      <a:srgbClr val="E3F1EA"/>
+                    </a:solidFill>
+                  </a:tcPr>
+                </a:tc>
+                <a:tc>
+                  <a:txBody>
+                    <a:bodyPr/>
+                    <a:lstStyle/>
+                    <a:p>
+                      <a:pPr algn="r" indent="0" marL="0">
+                        <a:buNone/>
+                      </a:pPr>
+                      <a:r>
+                        <a:rPr lang="en-US" sz="1250" b="1" dirty="0">
+                          <a:solidFill>
+                            <a:schemeClr val="accent5"/>
+                          </a:solidFill>
+                          <a:latin typeface="Arial" pitchFamily="34" charset="0"/>
+                          <a:ea typeface="Arial" pitchFamily="34" charset="-122"/>
+                          <a:cs typeface="Arial" pitchFamily="34" charset="-120"/>
+                        </a:rPr>
+                        <a:t>+300 €</a:t>
+                      </a:r>
+                      <a:endParaRPr lang="en-US" sz="1250" dirty="0">
+                        <a:latin typeface="Arial" charset="0"/>
+                        <a:ea typeface="Arial" charset="0"/>
+                        <a:cs typeface="Arial" charset="0"/>
+                      </a:endParaRPr>
+                    </a:p>
+                  </a:txBody>
+                  <a:tcPr marL="91440" marR="91440" marT="45720" marB="45720">
+                    <a:lnL w="12700" cap="flat" cmpd="sng" algn="ctr">
+                      <a:solidFill>
+                        <a:srgbClr val="FFFFFF"/>
+                      </a:solidFill>
+                      <a:prstDash val="solid"/>
+                      <a:round/>
+                      <a:headEnd type="none" w="med" len="med"/>
+                      <a:tailEnd type="none" w="med" len="med"/>
+                    </a:lnL>
+                    <a:lnR w="12700" cap="flat" cmpd="sng" algn="ctr">
+                      <a:solidFill>
+                        <a:srgbClr val="FFFFFF"/>
+                      </a:solidFill>
+                      <a:prstDash val="solid"/>
+                      <a:round/>
+                      <a:headEnd type="none" w="med" len="med"/>
+                      <a:tailEnd type="none" w="med" len="med"/>
+                    </a:lnR>
+                    <a:lnT w="12700" cap="flat" cmpd="sng" algn="ctr">
+                      <a:solidFill>
+                        <a:srgbClr val="FFFFFF"/>
+                      </a:solidFill>
+                      <a:prstDash val="solid"/>
+                      <a:round/>
+                      <a:headEnd type="none" w="med" len="med"/>
+                      <a:tailEnd type="none" w="med" len="med"/>
+                    </a:lnT>
+                    <a:lnB w="12700" cap="flat" cmpd="sng" algn="ctr">
+                      <a:solidFill>
+                        <a:srgbClr val="FFFFFF"/>
+                      </a:solidFill>
+                      <a:prstDash val="solid"/>
+                      <a:round/>
+                      <a:headEnd type="none" w="med" len="med"/>
+                      <a:tailEnd type="none" w="med" len="med"/>
+                    </a:lnB>
+                    <a:solidFill>
+                      <a:srgbClr val="E3F1EA"/>
+                    </a:solidFill>
+                  </a:tcPr>
+                </a:tc>
+                <a:tc>
+                  <a:txBody>
+                    <a:bodyPr/>
+                    <a:lstStyle/>
+                    <a:p>
+                      <a:pPr algn="r" indent="0" marL="0">
+                        <a:buNone/>
+                      </a:pPr>
+                      <a:r>
+                        <a:rPr lang="en-US" sz="1250" b="1" dirty="0">
+                          <a:solidFill>
+                            <a:schemeClr val="accent5"/>
+                          </a:solidFill>
+                          <a:latin typeface="Arial" pitchFamily="34" charset="0"/>
+                          <a:ea typeface="Arial" pitchFamily="34" charset="-122"/>
+                          <a:cs typeface="Arial" pitchFamily="34" charset="-120"/>
+                        </a:rPr>
+                        <a:t>+6.273 €</a:t>
+                      </a:r>
+                      <a:endParaRPr lang="en-US" sz="1250" dirty="0">
+                        <a:latin typeface="Arial" charset="0"/>
+                        <a:ea typeface="Arial" charset="0"/>
+                        <a:cs typeface="Arial" charset="0"/>
+                      </a:endParaRPr>
+                    </a:p>
+                  </a:txBody>
+                  <a:tcPr marL="91440" marR="91440" marT="45720" marB="45720">
+                    <a:lnL w="12700" cap="flat" cmpd="sng" algn="ctr">
+                      <a:solidFill>
+                        <a:srgbClr val="FFFFFF"/>
+                      </a:solidFill>
+                      <a:prstDash val="solid"/>
+                      <a:round/>
+                      <a:headEnd type="none" w="med" len="med"/>
+                      <a:tailEnd type="none" w="med" len="med"/>
+                    </a:lnL>
+                    <a:lnR w="12700" cap="flat" cmpd="sng" algn="ctr">
+                      <a:solidFill>
+                        <a:srgbClr val="FFFFFF"/>
+                      </a:solidFill>
+                      <a:prstDash val="solid"/>
+                      <a:round/>
+                      <a:headEnd type="none" w="med" len="med"/>
+                      <a:tailEnd type="none" w="med" len="med"/>
+                    </a:lnR>
+                    <a:lnT w="12700" cap="flat" cmpd="sng" algn="ctr">
+                      <a:solidFill>
+                        <a:srgbClr val="FFFFFF"/>
+                      </a:solidFill>
+                      <a:prstDash val="solid"/>
+                      <a:round/>
+                      <a:headEnd type="none" w="med" len="med"/>
+                      <a:tailEnd type="none" w="med" len="med"/>
+                    </a:lnT>
+                    <a:lnB w="12700" cap="flat" cmpd="sng" algn="ctr">
+                      <a:solidFill>
+                        <a:srgbClr val="FFFFFF"/>
+                      </a:solidFill>
+                      <a:prstDash val="solid"/>
+                      <a:round/>
+                      <a:headEnd type="none" w="med" len="med"/>
+                      <a:tailEnd type="none" w="med" len="med"/>
+                    </a:lnB>
+                    <a:solidFill>
+                      <a:srgbClr val="E3F1EA"/>
+                    </a:solidFill>
+                  </a:tcPr>
+                </a:tc>
+              </a:tr>
+            </a:tbl>
+          </a:graphicData>
+        </a:graphic>
+      </p:graphicFrame>
       <p:sp>
         <p:nvSpPr>
-          <p:cNvPr id="5" name="Risiko 1"/>
+          <p:cNvPr id="6" name="Was das bedeutet"/>
           <p:cNvSpPr/>
           <p:nvPr/>
         </p:nvSpPr>
         <p:spPr>
           <a:xfrm>
-            <a:off x="548640" y="1371600"/>
-            <a:ext cx="5362956" cy="2103120"/>
+            <a:off x="8686800" y="1280160"/>
+            <a:ext cx="2953512" cy="4480560"/>
           </a:xfrm>
           <a:prstGeom prst="roundRect">
             <a:avLst>
-              <a:gd name="adj" fmla="val 3478"/>
+              <a:gd name="adj" fmla="val 2477"/>
             </a:avLst>
           </a:prstGeom>
           <a:solidFill>
@@ -21768,14 +23789,14 @@
       </p:sp>
       <p:sp>
         <p:nvSpPr>
-          <p:cNvPr id="6" name="Text 3"/>
+          <p:cNvPr id="7" name="Text 3"/>
           <p:cNvSpPr txBox="1"/>
           <p:nvPr/>
         </p:nvSpPr>
         <p:spPr>
           <a:xfrm>
-            <a:off x="777240" y="1508760"/>
-            <a:ext cx="4905756" cy="411480"/>
+            <a:off x="8915400" y="1463040"/>
+            <a:ext cx="2496312" cy="4114800"/>
           </a:xfrm>
           <a:prstGeom prst="rect">
             <a:avLst/>
@@ -21791,30 +23812,98 @@
               <a:buNone/>
             </a:pPr>
             <a:r>
-              <a:rPr lang="en-US" sz="1900" dirty="0">
+              <a:rPr lang="en-US" sz="1250" b="1" dirty="0">
                 <a:solidFill>
                   <a:schemeClr val="accent1"/>
                 </a:solidFill>
-                <a:latin typeface="Georgia" pitchFamily="34" charset="0"/>
-                <a:ea typeface="Georgia" pitchFamily="34" charset="-122"/>
-                <a:cs typeface="Georgia" pitchFamily="34" charset="-120"/>
+                <a:latin typeface="Arial" pitchFamily="34" charset="0"/>
+                <a:ea typeface="Arial" pitchFamily="34" charset="-122"/>
+                <a:cs typeface="Arial" pitchFamily="34" charset="-120"/>
               </a:rPr>
-              <a:t>Miete</a:t>
+              <a:t>Plus für alle</a:t>
             </a:r>
-            <a:endParaRPr lang="en-US" sz="1900" dirty="0"/>
+            <a:endParaRPr lang="en-US" sz="1250" dirty="0"/>
+          </a:p>
+          <a:p>
+            <a:pPr indent="0" marL="0">
+              <a:buNone/>
+            </a:pPr>
+            <a:r>
+              <a:rPr lang="en-US" sz="1250" dirty="0">
+                <a:solidFill>
+                  <a:schemeClr val="tx1"/>
+                </a:solidFill>
+                <a:latin typeface="Arial" pitchFamily="34" charset="0"/>
+                <a:ea typeface="Arial" pitchFamily="34" charset="-122"/>
+                <a:cs typeface="Arial" pitchFamily="34" charset="-120"/>
+              </a:rPr>
+              <a:t>Förderung 15 % und tilgungsfreie Jahre reichen bei 3,3 % Zins für ein Plus bei jeder Partei. Bei 4,0 % Zins fehlt dem OG trotz 2.000 €/m² noch ein kleines Stück, dann braucht es mehr Förderung oder noch günstigere Preise.</a:t>
+            </a:r>
+            <a:endParaRPr lang="en-US" sz="1250" dirty="0"/>
+          </a:p>
+          <a:p>
+            <a:pPr indent="0" marL="0">
+              <a:buNone/>
+            </a:pPr>
+            <a:r>
+              <a:rPr lang="en-US" sz="1250" dirty="0">
+                <a:solidFill>
+                  <a:schemeClr val="tx1"/>
+                </a:solidFill>
+                <a:latin typeface="Arial" pitchFamily="34" charset="0"/>
+                <a:ea typeface="Arial" pitchFamily="34" charset="-122"/>
+                <a:cs typeface="Arial" pitchFamily="34" charset="-120"/>
+              </a:rPr>
+              <a:t> </a:t>
+            </a:r>
+            <a:endParaRPr lang="en-US" sz="1250" dirty="0"/>
+          </a:p>
+          <a:p>
+            <a:pPr indent="0" marL="0">
+              <a:buNone/>
+            </a:pPr>
+            <a:r>
+              <a:rPr lang="en-US" sz="1250" b="1" dirty="0">
+                <a:solidFill>
+                  <a:schemeClr val="accent1"/>
+                </a:solidFill>
+                <a:latin typeface="Arial" pitchFamily="34" charset="0"/>
+                <a:ea typeface="Arial" pitchFamily="34" charset="-122"/>
+                <a:cs typeface="Arial" pitchFamily="34" charset="-120"/>
+              </a:rPr>
+              <a:t>Zu beachten</a:t>
+            </a:r>
+            <a:endParaRPr lang="en-US" sz="1250" dirty="0"/>
+          </a:p>
+          <a:p>
+            <a:pPr indent="0" marL="0">
+              <a:buNone/>
+            </a:pPr>
+            <a:r>
+              <a:rPr lang="en-US" sz="1250" dirty="0">
+                <a:solidFill>
+                  <a:schemeClr val="tx1"/>
+                </a:solidFill>
+                <a:latin typeface="Arial" pitchFamily="34" charset="0"/>
+                <a:ea typeface="Arial" pitchFamily="34" charset="-122"/>
+                <a:cs typeface="Arial" pitchFamily="34" charset="-120"/>
+              </a:rPr>
+              <a:t>Ohne Tilgung sinkt die Schuld nicht, der Kredit muss später abgelöst oder verlängert werden.</a:t>
+            </a:r>
+            <a:endParaRPr lang="en-US" sz="1250" dirty="0"/>
           </a:p>
         </p:txBody>
       </p:sp>
       <p:sp>
         <p:nvSpPr>
-          <p:cNvPr id="7" name="Text 4"/>
+          <p:cNvPr id="8" name="Text 4"/>
           <p:cNvSpPr txBox="1"/>
           <p:nvPr/>
         </p:nvSpPr>
         <p:spPr>
           <a:xfrm>
-            <a:off x="777240" y="2011680"/>
-            <a:ext cx="4905756" cy="1371600"/>
+            <a:off x="548640" y="5212080"/>
+            <a:ext cx="7863840" cy="640080"/>
           </a:xfrm>
           <a:prstGeom prst="rect">
             <a:avLst/>
@@ -21830,332 +23919,17 @@
               <a:buNone/>
             </a:pPr>
             <a:r>
-              <a:rPr lang="en-US" sz="1400" dirty="0">
+              <a:rPr lang="en-US" sz="1250" dirty="0">
                 <a:solidFill>
-                  <a:schemeClr val="tx1"/>
+                  <a:schemeClr val="accent4"/>
                 </a:solidFill>
                 <a:latin typeface="Arial" pitchFamily="34" charset="0"/>
                 <a:ea typeface="Arial" pitchFamily="34" charset="-122"/>
                 <a:cs typeface="Arial" pitchFamily="34" charset="-120"/>
               </a:rPr>
-              <a:t>950 € je Wohnung (ca. 12–15 €/m²) liegt über den Portalwerten für Neubau in Werlte (ca. 11 €/m²). Gegenmaßnahme: Vergleichsangebote, Vorvermietung.</a:t>
+              <a:t>Zum Vergleich: Wenn du die Lücke der drei OG-Wohnungen (1.040 € im Monat) selbst trägst, bleiben dir 4.033 € aus der Gastro.</a:t>
             </a:r>
-            <a:endParaRPr lang="en-US" sz="1400" dirty="0"/>
-          </a:p>
-        </p:txBody>
-      </p:sp>
-      <p:sp>
-        <p:nvSpPr>
-          <p:cNvPr id="8" name="Risiko 2"/>
-          <p:cNvSpPr/>
-          <p:nvPr/>
-        </p:nvSpPr>
-        <p:spPr>
-          <a:xfrm>
-            <a:off x="6277356" y="1371600"/>
-            <a:ext cx="5362956" cy="2103120"/>
-          </a:xfrm>
-          <a:prstGeom prst="roundRect">
-            <a:avLst>
-              <a:gd name="adj" fmla="val 3478"/>
-            </a:avLst>
-          </a:prstGeom>
-          <a:solidFill>
-            <a:schemeClr val="bg2"/>
-          </a:solidFill>
-          <a:ln w="12700">
-            <a:solidFill>
-              <a:schemeClr val="bg2"/>
-            </a:solidFill>
-            <a:prstDash val="solid"/>
-          </a:ln>
-        </p:spPr>
-      </p:sp>
-      <p:sp>
-        <p:nvSpPr>
-          <p:cNvPr id="9" name="Text 6"/>
-          <p:cNvSpPr txBox="1"/>
-          <p:nvPr/>
-        </p:nvSpPr>
-        <p:spPr>
-          <a:xfrm>
-            <a:off x="6505956" y="1508760"/>
-            <a:ext cx="4905756" cy="411480"/>
-          </a:xfrm>
-          <a:prstGeom prst="rect">
-            <a:avLst/>
-          </a:prstGeom>
-          <a:noFill/>
-          <a:ln/>
-        </p:spPr>
-        <p:txBody>
-          <a:bodyPr wrap="square" lIns="0" tIns="0" rIns="0" bIns="0" rtlCol="0" anchor="t"/>
-          <a:lstStyle/>
-          <a:p>
-            <a:pPr indent="0" marL="0">
-              <a:buNone/>
-            </a:pPr>
-            <a:r>
-              <a:rPr lang="en-US" sz="1900" dirty="0">
-                <a:solidFill>
-                  <a:schemeClr val="accent1"/>
-                </a:solidFill>
-                <a:latin typeface="Georgia" pitchFamily="34" charset="0"/>
-                <a:ea typeface="Georgia" pitchFamily="34" charset="-122"/>
-                <a:cs typeface="Georgia" pitchFamily="34" charset="-120"/>
-              </a:rPr>
-              <a:t>Gastro-Umsatz</a:t>
-            </a:r>
-            <a:endParaRPr lang="en-US" sz="1900" dirty="0"/>
-          </a:p>
-        </p:txBody>
-      </p:sp>
-      <p:sp>
-        <p:nvSpPr>
-          <p:cNvPr id="10" name="Text 7"/>
-          <p:cNvSpPr txBox="1"/>
-          <p:nvPr/>
-        </p:nvSpPr>
-        <p:spPr>
-          <a:xfrm>
-            <a:off x="6505956" y="2011680"/>
-            <a:ext cx="4905756" cy="1371600"/>
-          </a:xfrm>
-          <a:prstGeom prst="rect">
-            <a:avLst/>
-          </a:prstGeom>
-          <a:noFill/>
-          <a:ln/>
-        </p:spPr>
-        <p:txBody>
-          <a:bodyPr wrap="square" lIns="0" tIns="0" rIns="0" bIns="0" rtlCol="0" anchor="t"/>
-          <a:lstStyle/>
-          <a:p>
-            <a:pPr indent="0" marL="0">
-              <a:buNone/>
-            </a:pPr>
-            <a:r>
-              <a:rPr lang="en-US" sz="1400" dirty="0">
-                <a:solidFill>
-                  <a:schemeClr val="tx1"/>
-                </a:solidFill>
-                <a:latin typeface="Arial" pitchFamily="34" charset="0"/>
-                <a:ea typeface="Arial" pitchFamily="34" charset="-122"/>
-                <a:cs typeface="Arial" pitchFamily="34" charset="-120"/>
-              </a:rPr>
-              <a:t>Die Gastro braucht ab ca. 37.000 € Umsatz, bei 4 % Zins ca. 43.000 €. Gegenmaßnahme: Konzept, Pacht-Staffel, Lohn variabel.</a:t>
-            </a:r>
-            <a:endParaRPr lang="en-US" sz="1400" dirty="0"/>
-          </a:p>
-        </p:txBody>
-      </p:sp>
-      <p:sp>
-        <p:nvSpPr>
-          <p:cNvPr id="11" name="Risiko 3"/>
-          <p:cNvSpPr/>
-          <p:nvPr/>
-        </p:nvSpPr>
-        <p:spPr>
-          <a:xfrm>
-            <a:off x="548640" y="3703320"/>
-            <a:ext cx="5362956" cy="2103120"/>
-          </a:xfrm>
-          <a:prstGeom prst="roundRect">
-            <a:avLst>
-              <a:gd name="adj" fmla="val 3478"/>
-            </a:avLst>
-          </a:prstGeom>
-          <a:solidFill>
-            <a:schemeClr val="bg2"/>
-          </a:solidFill>
-          <a:ln w="12700">
-            <a:solidFill>
-              <a:schemeClr val="bg2"/>
-            </a:solidFill>
-            <a:prstDash val="solid"/>
-          </a:ln>
-        </p:spPr>
-      </p:sp>
-      <p:sp>
-        <p:nvSpPr>
-          <p:cNvPr id="12" name="Text 9"/>
-          <p:cNvSpPr txBox="1"/>
-          <p:nvPr/>
-        </p:nvSpPr>
-        <p:spPr>
-          <a:xfrm>
-            <a:off x="777240" y="3840480"/>
-            <a:ext cx="4905756" cy="411480"/>
-          </a:xfrm>
-          <a:prstGeom prst="rect">
-            <a:avLst/>
-          </a:prstGeom>
-          <a:noFill/>
-          <a:ln/>
-        </p:spPr>
-        <p:txBody>
-          <a:bodyPr wrap="square" lIns="0" tIns="0" rIns="0" bIns="0" rtlCol="0" anchor="t"/>
-          <a:lstStyle/>
-          <a:p>
-            <a:pPr indent="0" marL="0">
-              <a:buNone/>
-            </a:pPr>
-            <a:r>
-              <a:rPr lang="en-US" sz="1900" dirty="0">
-                <a:solidFill>
-                  <a:schemeClr val="accent1"/>
-                </a:solidFill>
-                <a:latin typeface="Georgia" pitchFamily="34" charset="0"/>
-                <a:ea typeface="Georgia" pitchFamily="34" charset="-122"/>
-                <a:cs typeface="Georgia" pitchFamily="34" charset="-120"/>
-              </a:rPr>
-              <a:t>Zins</a:t>
-            </a:r>
-            <a:endParaRPr lang="en-US" sz="1900" dirty="0"/>
-          </a:p>
-        </p:txBody>
-      </p:sp>
-      <p:sp>
-        <p:nvSpPr>
-          <p:cNvPr id="13" name="Text 10"/>
-          <p:cNvSpPr txBox="1"/>
-          <p:nvPr/>
-        </p:nvSpPr>
-        <p:spPr>
-          <a:xfrm>
-            <a:off x="777240" y="4343400"/>
-            <a:ext cx="4905756" cy="1371600"/>
-          </a:xfrm>
-          <a:prstGeom prst="rect">
-            <a:avLst/>
-          </a:prstGeom>
-          <a:noFill/>
-          <a:ln/>
-        </p:spPr>
-        <p:txBody>
-          <a:bodyPr wrap="square" lIns="0" tIns="0" rIns="0" bIns="0" rtlCol="0" anchor="t"/>
-          <a:lstStyle/>
-          <a:p>
-            <a:pPr indent="0" marL="0">
-              <a:buNone/>
-            </a:pPr>
-            <a:r>
-              <a:rPr lang="en-US" sz="1400" dirty="0">
-                <a:solidFill>
-                  <a:schemeClr val="tx1"/>
-                </a:solidFill>
-                <a:latin typeface="Arial" pitchFamily="34" charset="0"/>
-                <a:ea typeface="Arial" pitchFamily="34" charset="-122"/>
-                <a:cs typeface="Arial" pitchFamily="34" charset="-120"/>
-              </a:rPr>
-              <a:t>Nach 10 Jahren Zinsbindung ist der Folgezins offen. Gegenmaßnahme: Förderkredite, Forward-Darlehen, Tilgungsaussetzung.</a:t>
-            </a:r>
-            <a:endParaRPr lang="en-US" sz="1400" dirty="0"/>
-          </a:p>
-        </p:txBody>
-      </p:sp>
-      <p:sp>
-        <p:nvSpPr>
-          <p:cNvPr id="14" name="Risiko 4"/>
-          <p:cNvSpPr/>
-          <p:nvPr/>
-        </p:nvSpPr>
-        <p:spPr>
-          <a:xfrm>
-            <a:off x="6277356" y="3703320"/>
-            <a:ext cx="5362956" cy="2103120"/>
-          </a:xfrm>
-          <a:prstGeom prst="roundRect">
-            <a:avLst>
-              <a:gd name="adj" fmla="val 3478"/>
-            </a:avLst>
-          </a:prstGeom>
-          <a:solidFill>
-            <a:schemeClr val="bg2"/>
-          </a:solidFill>
-          <a:ln w="12700">
-            <a:solidFill>
-              <a:schemeClr val="bg2"/>
-            </a:solidFill>
-            <a:prstDash val="solid"/>
-          </a:ln>
-        </p:spPr>
-      </p:sp>
-      <p:sp>
-        <p:nvSpPr>
-          <p:cNvPr id="15" name="Text 12"/>
-          <p:cNvSpPr txBox="1"/>
-          <p:nvPr/>
-        </p:nvSpPr>
-        <p:spPr>
-          <a:xfrm>
-            <a:off x="6505956" y="3840480"/>
-            <a:ext cx="4905756" cy="411480"/>
-          </a:xfrm>
-          <a:prstGeom prst="rect">
-            <a:avLst/>
-          </a:prstGeom>
-          <a:noFill/>
-          <a:ln/>
-        </p:spPr>
-        <p:txBody>
-          <a:bodyPr wrap="square" lIns="0" tIns="0" rIns="0" bIns="0" rtlCol="0" anchor="t"/>
-          <a:lstStyle/>
-          <a:p>
-            <a:pPr indent="0" marL="0">
-              <a:buNone/>
-            </a:pPr>
-            <a:r>
-              <a:rPr lang="en-US" sz="1900" dirty="0">
-                <a:solidFill>
-                  <a:schemeClr val="accent1"/>
-                </a:solidFill>
-                <a:latin typeface="Georgia" pitchFamily="34" charset="0"/>
-                <a:ea typeface="Georgia" pitchFamily="34" charset="-122"/>
-                <a:cs typeface="Georgia" pitchFamily="34" charset="-120"/>
-              </a:rPr>
-              <a:t>Genehmigung</a:t>
-            </a:r>
-            <a:endParaRPr lang="en-US" sz="1900" dirty="0"/>
-          </a:p>
-        </p:txBody>
-      </p:sp>
-      <p:sp>
-        <p:nvSpPr>
-          <p:cNvPr id="16" name="Text 13"/>
-          <p:cNvSpPr txBox="1"/>
-          <p:nvPr/>
-        </p:nvSpPr>
-        <p:spPr>
-          <a:xfrm>
-            <a:off x="6505956" y="4343400"/>
-            <a:ext cx="4905756" cy="1371600"/>
-          </a:xfrm>
-          <a:prstGeom prst="rect">
-            <a:avLst/>
-          </a:prstGeom>
-          <a:noFill/>
-          <a:ln/>
-        </p:spPr>
-        <p:txBody>
-          <a:bodyPr wrap="square" lIns="0" tIns="0" rIns="0" bIns="0" rtlCol="0" anchor="t"/>
-          <a:lstStyle/>
-          <a:p>
-            <a:pPr indent="0" marL="0">
-              <a:buNone/>
-            </a:pPr>
-            <a:r>
-              <a:rPr lang="en-US" sz="1400" dirty="0">
-                <a:solidFill>
-                  <a:schemeClr val="tx1"/>
-                </a:solidFill>
-                <a:latin typeface="Arial" pitchFamily="34" charset="0"/>
-                <a:ea typeface="Arial" pitchFamily="34" charset="-122"/>
-                <a:cs typeface="Arial" pitchFamily="34" charset="-120"/>
-              </a:rPr>
-              <a:t>Staffelgeschoss und Flachdach müssen von der Stadt bestätigt werden. Gegenmaßnahme: Vorabstimmung, Plan B mit Satteldach.</a:t>
-            </a:r>
-            <a:endParaRPr lang="en-US" sz="1400" dirty="0"/>
+            <a:endParaRPr lang="en-US" sz="1250" dirty="0"/>
           </a:p>
         </p:txBody>
       </p:sp>
@@ -23862,6 +25636,573 @@
 <file path=ppt/slides/slide20.xml><?xml version="1.0" encoding="utf-8"?>
 <p:sld xmlns:a="http://schemas.openxmlformats.org/drawingml/2006/main" xmlns:r="http://schemas.openxmlformats.org/officeDocument/2006/relationships" xmlns:p="http://schemas.openxmlformats.org/presentationml/2006/main">
   <p:cSld name="Slide 20">
+    <p:spTree>
+      <p:nvGrpSpPr>
+        <p:cNvPr id="1" name=""/>
+        <p:cNvGrpSpPr/>
+        <p:nvPr/>
+      </p:nvGrpSpPr>
+      <p:grpSpPr>
+        <a:xfrm>
+          <a:off x="0" y="0"/>
+          <a:ext cx="0" cy="0"/>
+          <a:chOff x="0" y="0"/>
+          <a:chExt cx="0" cy="0"/>
+        </a:xfrm>
+      </p:grpSpPr>
+      <p:sp>
+        <p:nvSpPr>
+          <p:cNvPr id="2" name="Text 1"/>
+          <p:cNvSpPr/>
+          <p:nvPr>
+            <p:ph idx="101" type="title" hasCustomPrompt="1"/>
+          </p:nvPr>
+        </p:nvSpPr>
+        <p:spPr>
+          <a:xfrm>
+            <a:off x="548640" y="320040"/>
+            <a:ext cx="11091672" cy="822960"/>
+          </a:xfrm>
+          <a:prstGeom prst="rect">
+            <a:avLst/>
+          </a:prstGeom>
+          <a:noFill/>
+          <a:ln/>
+        </p:spPr>
+        <p:txBody>
+          <a:bodyPr wrap="square" lIns="0" tIns="0" rIns="0" bIns="0" rtlCol="0" anchor="ctr"/>
+          <a:lstStyle/>
+          <a:p>
+            <a:pPr algn="l" indent="0" marL="0">
+              <a:buNone/>
+            </a:pPr>
+            <a:r>
+              <a:rPr lang="en-US" sz="3000" dirty="0">
+                <a:solidFill>
+                  <a:schemeClr val="accent1"/>
+                </a:solidFill>
+                <a:latin typeface="Georgia" pitchFamily="34" charset="0"/>
+                <a:ea typeface="Georgia" pitchFamily="34" charset="-122"/>
+                <a:cs typeface="Georgia" pitchFamily="34" charset="-120"/>
+              </a:rPr>
+              <a:t>Risiken und was wir dagegen tun</a:t>
+            </a:r>
+            <a:endParaRPr lang="en-US" sz="3000" dirty="0"/>
+          </a:p>
+        </p:txBody>
+      </p:sp>
+      <p:sp>
+        <p:nvSpPr>
+          <p:cNvPr id="3" name="Zielgruppe"/>
+          <p:cNvSpPr txBox="1"/>
+          <p:nvPr/>
+        </p:nvSpPr>
+        <p:spPr>
+          <a:xfrm>
+            <a:off x="548640" y="6446520"/>
+            <a:ext cx="5486400" cy="274320"/>
+          </a:xfrm>
+          <a:prstGeom prst="rect">
+            <a:avLst/>
+          </a:prstGeom>
+          <a:noFill/>
+          <a:ln/>
+        </p:spPr>
+        <p:txBody>
+          <a:bodyPr wrap="square" lIns="0" tIns="0" rIns="0" bIns="0" rtlCol="0" anchor="ctr"/>
+          <a:lstStyle/>
+          <a:p>
+            <a:pPr indent="0" marL="0">
+              <a:buNone/>
+            </a:pPr>
+            <a:r>
+              <a:rPr lang="en-US" sz="1000" dirty="0">
+                <a:solidFill>
+                  <a:schemeClr val="accent4"/>
+                </a:solidFill>
+              </a:rPr>
+              <a:t>Für die Bank</a:t>
+            </a:r>
+            <a:endParaRPr lang="en-US" sz="1000" dirty="0"/>
+          </a:p>
+        </p:txBody>
+      </p:sp>
+      <p:sp>
+        <p:nvSpPr>
+          <p:cNvPr id="5" name="Risiko 1"/>
+          <p:cNvSpPr/>
+          <p:nvPr/>
+        </p:nvSpPr>
+        <p:spPr>
+          <a:xfrm>
+            <a:off x="548640" y="1371600"/>
+            <a:ext cx="5362956" cy="2103120"/>
+          </a:xfrm>
+          <a:prstGeom prst="roundRect">
+            <a:avLst>
+              <a:gd name="adj" fmla="val 3478"/>
+            </a:avLst>
+          </a:prstGeom>
+          <a:solidFill>
+            <a:schemeClr val="bg2"/>
+          </a:solidFill>
+          <a:ln w="12700">
+            <a:solidFill>
+              <a:schemeClr val="bg2"/>
+            </a:solidFill>
+            <a:prstDash val="solid"/>
+          </a:ln>
+        </p:spPr>
+      </p:sp>
+      <p:sp>
+        <p:nvSpPr>
+          <p:cNvPr id="6" name="Text 3"/>
+          <p:cNvSpPr txBox="1"/>
+          <p:nvPr/>
+        </p:nvSpPr>
+        <p:spPr>
+          <a:xfrm>
+            <a:off x="777240" y="1508760"/>
+            <a:ext cx="4905756" cy="411480"/>
+          </a:xfrm>
+          <a:prstGeom prst="rect">
+            <a:avLst/>
+          </a:prstGeom>
+          <a:noFill/>
+          <a:ln/>
+        </p:spPr>
+        <p:txBody>
+          <a:bodyPr wrap="square" lIns="0" tIns="0" rIns="0" bIns="0" rtlCol="0" anchor="t"/>
+          <a:lstStyle/>
+          <a:p>
+            <a:pPr indent="0" marL="0">
+              <a:buNone/>
+            </a:pPr>
+            <a:r>
+              <a:rPr lang="en-US" sz="1900" dirty="0">
+                <a:solidFill>
+                  <a:schemeClr val="accent1"/>
+                </a:solidFill>
+                <a:latin typeface="Georgia" pitchFamily="34" charset="0"/>
+                <a:ea typeface="Georgia" pitchFamily="34" charset="-122"/>
+                <a:cs typeface="Georgia" pitchFamily="34" charset="-120"/>
+              </a:rPr>
+              <a:t>Miete</a:t>
+            </a:r>
+            <a:endParaRPr lang="en-US" sz="1900" dirty="0"/>
+          </a:p>
+        </p:txBody>
+      </p:sp>
+      <p:sp>
+        <p:nvSpPr>
+          <p:cNvPr id="7" name="Text 4"/>
+          <p:cNvSpPr txBox="1"/>
+          <p:nvPr/>
+        </p:nvSpPr>
+        <p:spPr>
+          <a:xfrm>
+            <a:off x="777240" y="2011680"/>
+            <a:ext cx="4905756" cy="1371600"/>
+          </a:xfrm>
+          <a:prstGeom prst="rect">
+            <a:avLst/>
+          </a:prstGeom>
+          <a:noFill/>
+          <a:ln/>
+        </p:spPr>
+        <p:txBody>
+          <a:bodyPr wrap="square" lIns="0" tIns="0" rIns="0" bIns="0" rtlCol="0" anchor="t"/>
+          <a:lstStyle/>
+          <a:p>
+            <a:pPr indent="0" marL="0">
+              <a:buNone/>
+            </a:pPr>
+            <a:r>
+              <a:rPr lang="en-US" sz="1400" dirty="0">
+                <a:solidFill>
+                  <a:schemeClr val="tx1"/>
+                </a:solidFill>
+                <a:latin typeface="Arial" pitchFamily="34" charset="0"/>
+                <a:ea typeface="Arial" pitchFamily="34" charset="-122"/>
+                <a:cs typeface="Arial" pitchFamily="34" charset="-120"/>
+              </a:rPr>
+              <a:t>950 € je Wohnung (ca. 12–15 €/m²) liegt über den Portalwerten für Neubau in Werlte (ca. 11 €/m²). Gegenmaßnahme: Vergleichsangebote, Vorvermietung.</a:t>
+            </a:r>
+            <a:endParaRPr lang="en-US" sz="1400" dirty="0"/>
+          </a:p>
+        </p:txBody>
+      </p:sp>
+      <p:sp>
+        <p:nvSpPr>
+          <p:cNvPr id="8" name="Risiko 2"/>
+          <p:cNvSpPr/>
+          <p:nvPr/>
+        </p:nvSpPr>
+        <p:spPr>
+          <a:xfrm>
+            <a:off x="6277356" y="1371600"/>
+            <a:ext cx="5362956" cy="2103120"/>
+          </a:xfrm>
+          <a:prstGeom prst="roundRect">
+            <a:avLst>
+              <a:gd name="adj" fmla="val 3478"/>
+            </a:avLst>
+          </a:prstGeom>
+          <a:solidFill>
+            <a:schemeClr val="bg2"/>
+          </a:solidFill>
+          <a:ln w="12700">
+            <a:solidFill>
+              <a:schemeClr val="bg2"/>
+            </a:solidFill>
+            <a:prstDash val="solid"/>
+          </a:ln>
+        </p:spPr>
+      </p:sp>
+      <p:sp>
+        <p:nvSpPr>
+          <p:cNvPr id="9" name="Text 6"/>
+          <p:cNvSpPr txBox="1"/>
+          <p:nvPr/>
+        </p:nvSpPr>
+        <p:spPr>
+          <a:xfrm>
+            <a:off x="6505956" y="1508760"/>
+            <a:ext cx="4905756" cy="411480"/>
+          </a:xfrm>
+          <a:prstGeom prst="rect">
+            <a:avLst/>
+          </a:prstGeom>
+          <a:noFill/>
+          <a:ln/>
+        </p:spPr>
+        <p:txBody>
+          <a:bodyPr wrap="square" lIns="0" tIns="0" rIns="0" bIns="0" rtlCol="0" anchor="t"/>
+          <a:lstStyle/>
+          <a:p>
+            <a:pPr indent="0" marL="0">
+              <a:buNone/>
+            </a:pPr>
+            <a:r>
+              <a:rPr lang="en-US" sz="1900" dirty="0">
+                <a:solidFill>
+                  <a:schemeClr val="accent1"/>
+                </a:solidFill>
+                <a:latin typeface="Georgia" pitchFamily="34" charset="0"/>
+                <a:ea typeface="Georgia" pitchFamily="34" charset="-122"/>
+                <a:cs typeface="Georgia" pitchFamily="34" charset="-120"/>
+              </a:rPr>
+              <a:t>Gastro-Umsatz</a:t>
+            </a:r>
+            <a:endParaRPr lang="en-US" sz="1900" dirty="0"/>
+          </a:p>
+        </p:txBody>
+      </p:sp>
+      <p:sp>
+        <p:nvSpPr>
+          <p:cNvPr id="10" name="Text 7"/>
+          <p:cNvSpPr txBox="1"/>
+          <p:nvPr/>
+        </p:nvSpPr>
+        <p:spPr>
+          <a:xfrm>
+            <a:off x="6505956" y="2011680"/>
+            <a:ext cx="4905756" cy="1371600"/>
+          </a:xfrm>
+          <a:prstGeom prst="rect">
+            <a:avLst/>
+          </a:prstGeom>
+          <a:noFill/>
+          <a:ln/>
+        </p:spPr>
+        <p:txBody>
+          <a:bodyPr wrap="square" lIns="0" tIns="0" rIns="0" bIns="0" rtlCol="0" anchor="t"/>
+          <a:lstStyle/>
+          <a:p>
+            <a:pPr indent="0" marL="0">
+              <a:buNone/>
+            </a:pPr>
+            <a:r>
+              <a:rPr lang="en-US" sz="1400" dirty="0">
+                <a:solidFill>
+                  <a:schemeClr val="tx1"/>
+                </a:solidFill>
+                <a:latin typeface="Arial" pitchFamily="34" charset="0"/>
+                <a:ea typeface="Arial" pitchFamily="34" charset="-122"/>
+                <a:cs typeface="Arial" pitchFamily="34" charset="-120"/>
+              </a:rPr>
+              <a:t>Die Gastro braucht ab ca. 37.000 € Umsatz, bei 4 % Zins ca. 43.000 €. Gegenmaßnahme: Konzept, Pacht-Staffel, Lohn variabel.</a:t>
+            </a:r>
+            <a:endParaRPr lang="en-US" sz="1400" dirty="0"/>
+          </a:p>
+        </p:txBody>
+      </p:sp>
+      <p:sp>
+        <p:nvSpPr>
+          <p:cNvPr id="11" name="Risiko 3"/>
+          <p:cNvSpPr/>
+          <p:nvPr/>
+        </p:nvSpPr>
+        <p:spPr>
+          <a:xfrm>
+            <a:off x="548640" y="3703320"/>
+            <a:ext cx="5362956" cy="2103120"/>
+          </a:xfrm>
+          <a:prstGeom prst="roundRect">
+            <a:avLst>
+              <a:gd name="adj" fmla="val 3478"/>
+            </a:avLst>
+          </a:prstGeom>
+          <a:solidFill>
+            <a:schemeClr val="bg2"/>
+          </a:solidFill>
+          <a:ln w="12700">
+            <a:solidFill>
+              <a:schemeClr val="bg2"/>
+            </a:solidFill>
+            <a:prstDash val="solid"/>
+          </a:ln>
+        </p:spPr>
+      </p:sp>
+      <p:sp>
+        <p:nvSpPr>
+          <p:cNvPr id="12" name="Text 9"/>
+          <p:cNvSpPr txBox="1"/>
+          <p:nvPr/>
+        </p:nvSpPr>
+        <p:spPr>
+          <a:xfrm>
+            <a:off x="777240" y="3840480"/>
+            <a:ext cx="4905756" cy="411480"/>
+          </a:xfrm>
+          <a:prstGeom prst="rect">
+            <a:avLst/>
+          </a:prstGeom>
+          <a:noFill/>
+          <a:ln/>
+        </p:spPr>
+        <p:txBody>
+          <a:bodyPr wrap="square" lIns="0" tIns="0" rIns="0" bIns="0" rtlCol="0" anchor="t"/>
+          <a:lstStyle/>
+          <a:p>
+            <a:pPr indent="0" marL="0">
+              <a:buNone/>
+            </a:pPr>
+            <a:r>
+              <a:rPr lang="en-US" sz="1900" dirty="0">
+                <a:solidFill>
+                  <a:schemeClr val="accent1"/>
+                </a:solidFill>
+                <a:latin typeface="Georgia" pitchFamily="34" charset="0"/>
+                <a:ea typeface="Georgia" pitchFamily="34" charset="-122"/>
+                <a:cs typeface="Georgia" pitchFamily="34" charset="-120"/>
+              </a:rPr>
+              <a:t>Zins</a:t>
+            </a:r>
+            <a:endParaRPr lang="en-US" sz="1900" dirty="0"/>
+          </a:p>
+        </p:txBody>
+      </p:sp>
+      <p:sp>
+        <p:nvSpPr>
+          <p:cNvPr id="13" name="Text 10"/>
+          <p:cNvSpPr txBox="1"/>
+          <p:nvPr/>
+        </p:nvSpPr>
+        <p:spPr>
+          <a:xfrm>
+            <a:off x="777240" y="4343400"/>
+            <a:ext cx="4905756" cy="1371600"/>
+          </a:xfrm>
+          <a:prstGeom prst="rect">
+            <a:avLst/>
+          </a:prstGeom>
+          <a:noFill/>
+          <a:ln/>
+        </p:spPr>
+        <p:txBody>
+          <a:bodyPr wrap="square" lIns="0" tIns="0" rIns="0" bIns="0" rtlCol="0" anchor="t"/>
+          <a:lstStyle/>
+          <a:p>
+            <a:pPr indent="0" marL="0">
+              <a:buNone/>
+            </a:pPr>
+            <a:r>
+              <a:rPr lang="en-US" sz="1400" dirty="0">
+                <a:solidFill>
+                  <a:schemeClr val="tx1"/>
+                </a:solidFill>
+                <a:latin typeface="Arial" pitchFamily="34" charset="0"/>
+                <a:ea typeface="Arial" pitchFamily="34" charset="-122"/>
+                <a:cs typeface="Arial" pitchFamily="34" charset="-120"/>
+              </a:rPr>
+              <a:t>Nach 10 Jahren Zinsbindung ist der Folgezins offen. Gegenmaßnahme: Förderkredite, Forward-Darlehen, Tilgungsaussetzung.</a:t>
+            </a:r>
+            <a:endParaRPr lang="en-US" sz="1400" dirty="0"/>
+          </a:p>
+        </p:txBody>
+      </p:sp>
+      <p:sp>
+        <p:nvSpPr>
+          <p:cNvPr id="14" name="Risiko 4"/>
+          <p:cNvSpPr/>
+          <p:nvPr/>
+        </p:nvSpPr>
+        <p:spPr>
+          <a:xfrm>
+            <a:off x="6277356" y="3703320"/>
+            <a:ext cx="5362956" cy="2103120"/>
+          </a:xfrm>
+          <a:prstGeom prst="roundRect">
+            <a:avLst>
+              <a:gd name="adj" fmla="val 3478"/>
+            </a:avLst>
+          </a:prstGeom>
+          <a:solidFill>
+            <a:schemeClr val="bg2"/>
+          </a:solidFill>
+          <a:ln w="12700">
+            <a:solidFill>
+              <a:schemeClr val="bg2"/>
+            </a:solidFill>
+            <a:prstDash val="solid"/>
+          </a:ln>
+        </p:spPr>
+      </p:sp>
+      <p:sp>
+        <p:nvSpPr>
+          <p:cNvPr id="15" name="Text 12"/>
+          <p:cNvSpPr txBox="1"/>
+          <p:nvPr/>
+        </p:nvSpPr>
+        <p:spPr>
+          <a:xfrm>
+            <a:off x="6505956" y="3840480"/>
+            <a:ext cx="4905756" cy="411480"/>
+          </a:xfrm>
+          <a:prstGeom prst="rect">
+            <a:avLst/>
+          </a:prstGeom>
+          <a:noFill/>
+          <a:ln/>
+        </p:spPr>
+        <p:txBody>
+          <a:bodyPr wrap="square" lIns="0" tIns="0" rIns="0" bIns="0" rtlCol="0" anchor="t"/>
+          <a:lstStyle/>
+          <a:p>
+            <a:pPr indent="0" marL="0">
+              <a:buNone/>
+            </a:pPr>
+            <a:r>
+              <a:rPr lang="en-US" sz="1900" dirty="0">
+                <a:solidFill>
+                  <a:schemeClr val="accent1"/>
+                </a:solidFill>
+                <a:latin typeface="Georgia" pitchFamily="34" charset="0"/>
+                <a:ea typeface="Georgia" pitchFamily="34" charset="-122"/>
+                <a:cs typeface="Georgia" pitchFamily="34" charset="-120"/>
+              </a:rPr>
+              <a:t>Genehmigung</a:t>
+            </a:r>
+            <a:endParaRPr lang="en-US" sz="1900" dirty="0"/>
+          </a:p>
+        </p:txBody>
+      </p:sp>
+      <p:sp>
+        <p:nvSpPr>
+          <p:cNvPr id="16" name="Text 13"/>
+          <p:cNvSpPr txBox="1"/>
+          <p:nvPr/>
+        </p:nvSpPr>
+        <p:spPr>
+          <a:xfrm>
+            <a:off x="6505956" y="4343400"/>
+            <a:ext cx="4905756" cy="1371600"/>
+          </a:xfrm>
+          <a:prstGeom prst="rect">
+            <a:avLst/>
+          </a:prstGeom>
+          <a:noFill/>
+          <a:ln/>
+        </p:spPr>
+        <p:txBody>
+          <a:bodyPr wrap="square" lIns="0" tIns="0" rIns="0" bIns="0" rtlCol="0" anchor="t"/>
+          <a:lstStyle/>
+          <a:p>
+            <a:pPr indent="0" marL="0">
+              <a:buNone/>
+            </a:pPr>
+            <a:r>
+              <a:rPr lang="en-US" sz="1400" dirty="0">
+                <a:solidFill>
+                  <a:schemeClr val="tx1"/>
+                </a:solidFill>
+                <a:latin typeface="Arial" pitchFamily="34" charset="0"/>
+                <a:ea typeface="Arial" pitchFamily="34" charset="-122"/>
+                <a:cs typeface="Arial" pitchFamily="34" charset="-120"/>
+              </a:rPr>
+              <a:t>Staffelgeschoss und Flachdach müssen von der Stadt bestätigt werden. Gegenmaßnahme: Vorabstimmung, Plan B mit Satteldach.</a:t>
+            </a:r>
+            <a:endParaRPr lang="en-US" sz="1400" dirty="0"/>
+          </a:p>
+        </p:txBody>
+      </p:sp>
+      <p:sp>
+        <p:nvSpPr>
+          <p:cNvPr id="25" name="Slide Number Placeholder 0"/>
+          <p:cNvSpPr>
+            <a:spLocks noGrp="1"/>
+          </p:cNvSpPr>
+          <p:nvPr>
+            <p:ph type="sldNum" sz="quarter" idx="4294967295"/>
+          </p:nvPr>
+        </p:nvSpPr>
+        <p:spPr>
+          <a:xfrm>
+            <a:off x="11183112" y="6446520"/>
+            <a:ext cx="548640" cy="274320"/>
+          </a:xfrm>
+          <a:prstGeom prst="rect">
+            <a:avLst/>
+          </a:prstGeom>
+          <a:extLst>
+            <a:ext uri="{C572A759-6A51-4108-AA02-DFA0A04FC94B}">
+              <ma14:wrappingTextBoxFlag xmlns:ma14="http://schemas.microsoft.com/office/mac/drawingml/2011/main" val="0"/>
+            </a:ext>
+          </a:extLst>
+        </p:spPr>
+        <p:txBody>
+          <a:bodyPr/>
+          <a:lstStyle>
+            <a:lvl1pPr>
+              <a:defRPr sz="1000">
+                <a:solidFill>
+                  <a:schemeClr val="accent4"/>
+                </a:solidFill>
+              </a:defRPr>
+            </a:lvl1pPr>
+          </a:lstStyle>
+          <a:p>
+            <a:pPr algn="r"/>
+            <a:fld id="{F7021451-1387-4CA6-816F-3879F97B5CBC}" type="slidenum">
+              <a:rPr b="0" lang="en-US"/>
+              <a:t>20</a:t>
+            </a:fld>
+            <a:endParaRPr lang="en-US"/>
+          </a:p>
+        </p:txBody>
+      </p:sp>
+    </p:spTree>
+  </p:cSld>
+  <p:clrMapOvr>
+    <a:masterClrMapping/>
+  </p:clrMapOvr>
+</p:sld>
+</file>
+
+<file path=ppt/slides/slide21.xml><?xml version="1.0" encoding="utf-8"?>
+<p:sld xmlns:a="http://schemas.openxmlformats.org/drawingml/2006/main" xmlns:r="http://schemas.openxmlformats.org/officeDocument/2006/relationships" xmlns:p="http://schemas.openxmlformats.org/presentationml/2006/main">
+  <p:cSld name="Slide 21">
     <p:spTree>
       <p:nvGrpSpPr>
         <p:cNvPr id="1" name=""/>
@@ -24622,7 +26963,7 @@
             <a:pPr algn="r"/>
             <a:fld id="{F7021451-1387-4CA6-816F-3879F97B5CBC}" type="slidenum">
               <a:rPr b="0" lang="en-US"/>
-              <a:t>20</a:t>
+              <a:t>21</a:t>
             </a:fld>
             <a:endParaRPr lang="en-US"/>
           </a:p>
@@ -24636,9 +26977,9 @@
 </p:sld>
 </file>
 
-<file path=ppt/slides/slide21.xml><?xml version="1.0" encoding="utf-8"?>
+<file path=ppt/slides/slide22.xml><?xml version="1.0" encoding="utf-8"?>
 <p:sld xmlns:a="http://schemas.openxmlformats.org/drawingml/2006/main" xmlns:r="http://schemas.openxmlformats.org/officeDocument/2006/relationships" xmlns:p="http://schemas.openxmlformats.org/presentationml/2006/main">
-  <p:cSld name="Slide 21">
+  <p:cSld name="Slide 22">
     <p:spTree>
       <p:nvGrpSpPr>
         <p:cNvPr id="1" name=""/>
@@ -25621,7 +27962,7 @@
             <a:pPr algn="r"/>
             <a:fld id="{F7021451-1387-4CA6-816F-3879F97B5CBC}" type="slidenum">
               <a:rPr b="0" lang="en-US"/>
-              <a:t>21</a:t>
+              <a:t>22</a:t>
             </a:fld>
             <a:endParaRPr lang="en-US"/>
           </a:p>
@@ -25635,9 +27976,9 @@
 </p:sld>
 </file>
 
-<file path=ppt/slides/slide22.xml><?xml version="1.0" encoding="utf-8"?>
+<file path=ppt/slides/slide23.xml><?xml version="1.0" encoding="utf-8"?>
 <p:sld xmlns:a="http://schemas.openxmlformats.org/drawingml/2006/main" xmlns:r="http://schemas.openxmlformats.org/officeDocument/2006/relationships" xmlns:p="http://schemas.openxmlformats.org/presentationml/2006/main">
-  <p:cSld name="Slide 22">
+  <p:cSld name="Slide 23">
     <p:spTree>
       <p:nvGrpSpPr>
         <p:cNvPr id="1" name=""/>
@@ -25738,9 +28079,9 @@
 </p:sld>
 </file>
 
-<file path=ppt/slides/slide23.xml><?xml version="1.0" encoding="utf-8"?>
+<file path=ppt/slides/slide24.xml><?xml version="1.0" encoding="utf-8"?>
 <p:sld xmlns:a="http://schemas.openxmlformats.org/drawingml/2006/main" xmlns:r="http://schemas.openxmlformats.org/officeDocument/2006/relationships" xmlns:p="http://schemas.openxmlformats.org/presentationml/2006/main">
-  <p:cSld name="Slide 23">
+  <p:cSld name="Slide 24">
     <p:spTree>
       <p:nvGrpSpPr>
         <p:cNvPr id="1" name=""/>
@@ -26146,7 +28487,7 @@
             <a:pPr algn="r"/>
             <a:fld id="{F7021451-1387-4CA6-816F-3879F97B5CBC}" type="slidenum">
               <a:rPr b="0" lang="en-US"/>
-              <a:t>23</a:t>
+              <a:t>24</a:t>
             </a:fld>
             <a:endParaRPr lang="en-US"/>
           </a:p>
@@ -26160,9 +28501,9 @@
 </p:sld>
 </file>
 
-<file path=ppt/slides/slide24.xml><?xml version="1.0" encoding="utf-8"?>
+<file path=ppt/slides/slide25.xml><?xml version="1.0" encoding="utf-8"?>
 <p:sld xmlns:a="http://schemas.openxmlformats.org/drawingml/2006/main" xmlns:r="http://schemas.openxmlformats.org/officeDocument/2006/relationships" xmlns:p="http://schemas.openxmlformats.org/presentationml/2006/main">
-  <p:cSld name="Slide 24">
+  <p:cSld name="Slide 25">
     <p:spTree>
       <p:nvGrpSpPr>
         <p:cNvPr id="1" name=""/>
@@ -26256,7 +28597,7 @@
       </p:sp>
       <p:graphicFrame>
         <p:nvGraphicFramePr>
-          <p:cNvPr id="25" name="Tabelle Gastro-Kosten"/>
+          <p:cNvPr id="26" name="Tabelle Gastro-Kosten"/>
           <p:cNvGraphicFramePr>
             <a:graphicFrameLocks noGrp="1"/>
           </p:cNvGraphicFramePr>
@@ -28861,7 +31202,7 @@
             <a:pPr algn="r"/>
             <a:fld id="{F7021451-1387-4CA6-816F-3879F97B5CBC}" type="slidenum">
               <a:rPr b="0" lang="en-US"/>
-              <a:t>24</a:t>
+              <a:t>25</a:t>
             </a:fld>
             <a:endParaRPr lang="en-US"/>
           </a:p>
@@ -28875,9 +31216,9 @@
 </p:sld>
 </file>
 
-<file path=ppt/slides/slide25.xml><?xml version="1.0" encoding="utf-8"?>
+<file path=ppt/slides/slide26.xml><?xml version="1.0" encoding="utf-8"?>
 <p:sld xmlns:a="http://schemas.openxmlformats.org/drawingml/2006/main" xmlns:r="http://schemas.openxmlformats.org/officeDocument/2006/relationships" xmlns:p="http://schemas.openxmlformats.org/presentationml/2006/main">
-  <p:cSld name="Slide 25">
+  <p:cSld name="Slide 26">
     <p:spTree>
       <p:nvGrpSpPr>
         <p:cNvPr id="1" name=""/>
@@ -28971,7 +31312,7 @@
       </p:sp>
       <p:graphicFrame>
         <p:nvGraphicFramePr>
-          <p:cNvPr id="26" name="Tabelle Gastro-Ausbau"/>
+          <p:cNvPr id="27" name="Tabelle Gastro-Ausbau"/>
           <p:cNvGraphicFramePr>
             <a:graphicFrameLocks noGrp="1"/>
           </p:cNvGraphicFramePr>
@@ -30958,7 +33299,7 @@
             <a:pPr algn="r"/>
             <a:fld id="{F7021451-1387-4CA6-816F-3879F97B5CBC}" type="slidenum">
               <a:rPr b="0" lang="en-US"/>
-              <a:t>25</a:t>
+              <a:t>26</a:t>
             </a:fld>
             <a:endParaRPr lang="en-US"/>
           </a:p>
@@ -30972,9 +33313,9 @@
 </p:sld>
 </file>
 
-<file path=ppt/slides/slide26.xml><?xml version="1.0" encoding="utf-8"?>
+<file path=ppt/slides/slide27.xml><?xml version="1.0" encoding="utf-8"?>
 <p:sld xmlns:a="http://schemas.openxmlformats.org/drawingml/2006/main" xmlns:r="http://schemas.openxmlformats.org/officeDocument/2006/relationships" xmlns:p="http://schemas.openxmlformats.org/presentationml/2006/main">
-  <p:cSld name="Slide 26">
+  <p:cSld name="Slide 27">
     <p:spTree>
       <p:nvGrpSpPr>
         <p:cNvPr id="1" name=""/>
@@ -31068,7 +33409,7 @@
       </p:sp>
       <p:graphicFrame>
         <p:nvGraphicFramePr>
-          <p:cNvPr id="27" name="Tabelle Mieten"/>
+          <p:cNvPr id="28" name="Tabelle Mieten"/>
           <p:cNvGraphicFramePr>
             <a:graphicFrameLocks noGrp="1"/>
           </p:cNvGraphicFramePr>
@@ -32055,7 +34396,7 @@
             <a:pPr algn="r"/>
             <a:fld id="{F7021451-1387-4CA6-816F-3879F97B5CBC}" type="slidenum">
               <a:rPr b="0" lang="en-US"/>
-              <a:t>26</a:t>
+              <a:t>27</a:t>
             </a:fld>
             <a:endParaRPr lang="en-US"/>
           </a:p>
@@ -32069,9 +34410,9 @@
 </p:sld>
 </file>
 
-<file path=ppt/slides/slide27.xml><?xml version="1.0" encoding="utf-8"?>
+<file path=ppt/slides/slide28.xml><?xml version="1.0" encoding="utf-8"?>
 <p:sld xmlns:a="http://schemas.openxmlformats.org/drawingml/2006/main" xmlns:r="http://schemas.openxmlformats.org/officeDocument/2006/relationships" xmlns:p="http://schemas.openxmlformats.org/presentationml/2006/main">
-  <p:cSld name="Slide 27">
+  <p:cSld name="Slide 28">
     <p:spTree>
       <p:nvGrpSpPr>
         <p:cNvPr id="1" name=""/>
@@ -32165,7 +34506,7 @@
       </p:sp>
       <p:graphicFrame>
         <p:nvGraphicFramePr>
-          <p:cNvPr id="28" name="Tabelle Varianten B und C"/>
+          <p:cNvPr id="29" name="Tabelle Varianten B und C"/>
           <p:cNvGraphicFramePr>
             <a:graphicFrameLocks noGrp="1"/>
           </p:cNvGraphicFramePr>
@@ -35540,7 +37881,7 @@
             <a:pPr algn="r"/>
             <a:fld id="{F7021451-1387-4CA6-816F-3879F97B5CBC}" type="slidenum">
               <a:rPr b="0" lang="en-US"/>
-              <a:t>27</a:t>
+              <a:t>28</a:t>
             </a:fld>
             <a:endParaRPr lang="en-US"/>
           </a:p>
@@ -35554,9 +37895,9 @@
 </p:sld>
 </file>
 
-<file path=ppt/slides/slide28.xml><?xml version="1.0" encoding="utf-8"?>
+<file path=ppt/slides/slide29.xml><?xml version="1.0" encoding="utf-8"?>
 <p:sld xmlns:a="http://schemas.openxmlformats.org/drawingml/2006/main" xmlns:r="http://schemas.openxmlformats.org/officeDocument/2006/relationships" xmlns:p="http://schemas.openxmlformats.org/presentationml/2006/main">
-  <p:cSld name="Slide 28">
+  <p:cSld name="Slide 29">
     <p:spTree>
       <p:nvGrpSpPr>
         <p:cNvPr id="1" name=""/>
@@ -35712,7 +38053,7 @@
       </p:sp>
       <p:graphicFrame>
         <p:nvGraphicFramePr>
-          <p:cNvPr id="29" name="Tabelle Vergleich 3 und 4 Ebenen"/>
+          <p:cNvPr id="30" name="Tabelle Vergleich 3 und 4 Ebenen"/>
           <p:cNvGraphicFramePr>
             <a:graphicFrameLocks noGrp="1"/>
           </p:cNvGraphicFramePr>
@@ -37405,7 +39746,7 @@
             <a:pPr algn="r"/>
             <a:fld id="{F7021451-1387-4CA6-816F-3879F97B5CBC}" type="slidenum">
               <a:rPr b="0" lang="en-US"/>
-              <a:t>28</a:t>
+              <a:t>29</a:t>
             </a:fld>
             <a:endParaRPr lang="en-US"/>
           </a:p>

</xml_diff>

<commit_message>
Rechnung ohne Lohn des Bauherrn
Co-Authored-By: Claude Sonnet 5.5 <noreply@anthropic.com>
Claude-Session: https://claude.ai/code/session_01HJGZfxHv7bzYyqdLwg8aFJ
</commit_message>
<xml_diff>
--- a/praesentation/Neue-Mitte-Werlte_Baufeld3_6-Wohnungen_Gastro-EG.pptx
+++ b/praesentation/Neue-Mitte-Werlte_Baufeld3_6-Wohnungen_Gastro-EG.pptx
@@ -788,7 +788,7 @@
                     <c:v>Rate</c:v>
                   </c:pt>
                   <c:pt idx="3">
-                    <c:v>Lohn</c:v>
+                    <c:v>Rücklagen</c:v>
                   </c:pt>
                 </c:lvl>
               </c:multiLvlStrCache>
@@ -810,7 +810,7 @@
                   <c:v>-10172</c:v>
                 </c:pt>
                 <c:pt idx="3">
-                  <c:v>-6918</c:v>
+                  <c:v>-918</c:v>
                 </c:pt>
               </c:numCache>
             </c:numRef>
@@ -1064,22 +1064,22 @@
                 <c:formatCode>General</c:formatCode>
                 <c:ptCount val="6"/>
                 <c:pt idx="0">
-                  <c:v>3860</c:v>
+                  <c:v>9860</c:v>
                 </c:pt>
                 <c:pt idx="1">
-                  <c:v>4369</c:v>
+                  <c:v>10369</c:v>
                 </c:pt>
                 <c:pt idx="2">
-                  <c:v>4877</c:v>
+                  <c:v>10877</c:v>
                 </c:pt>
                 <c:pt idx="3">
-                  <c:v>5386</c:v>
+                  <c:v>11386</c:v>
                 </c:pt>
                 <c:pt idx="4">
-                  <c:v>5895</c:v>
+                  <c:v>11895</c:v>
                 </c:pt>
                 <c:pt idx="5">
-                  <c:v>6403</c:v>
+                  <c:v>12403</c:v>
                 </c:pt>
               </c:numCache>
             </c:numRef>
@@ -1190,22 +1190,22 @@
                 <c:formatCode>General</c:formatCode>
                 <c:ptCount val="6"/>
                 <c:pt idx="0">
-                  <c:v>2068</c:v>
+                  <c:v>8068</c:v>
                 </c:pt>
                 <c:pt idx="1">
-                  <c:v>2666</c:v>
+                  <c:v>8666</c:v>
                 </c:pt>
                 <c:pt idx="2">
-                  <c:v>3264</c:v>
+                  <c:v>9264</c:v>
                 </c:pt>
                 <c:pt idx="3">
-                  <c:v>3862</c:v>
+                  <c:v>9862</c:v>
                 </c:pt>
                 <c:pt idx="4">
-                  <c:v>4460</c:v>
+                  <c:v>10460</c:v>
                 </c:pt>
                 <c:pt idx="5">
-                  <c:v>5059</c:v>
+                  <c:v>11059</c:v>
                 </c:pt>
               </c:numCache>
             </c:numRef>
@@ -2387,7 +2387,7 @@
           <a:p>
             <a:r>
               <a:rPr lang="en-US" dirty="0"/>
-              <a:t>Gastro-Marge vor Pacht 30,5 % vom Umsatz (Branchen-Richtwert, nicht aus Werlte). Break-even = Ergebnis nach Lohn genau null.</a:t>
+              <a:t>Gastro-Marge vor Pacht 30,5 % vom Umsatz (Branchen-Richtwert, nicht aus Werlte). Break-even = Ergebnis (ohne Lohn des Bauherrn) genau null.</a:t>
             </a:r>
             <a:endParaRPr lang="en-US" dirty="0"/>
           </a:p>
@@ -10371,7 +10371,7 @@
                           <a:ea typeface="Arial" pitchFamily="34" charset="-122"/>
                           <a:cs typeface="Arial" pitchFamily="34" charset="-120"/>
                         </a:rPr>
-                        <a:t>Dein Lohn</a:t>
+                        <a:t>Dein Lohn (wird vorerst nicht gerechnet)</a:t>
                       </a:r>
                       <a:endParaRPr lang="en-US" sz="1250" dirty="0">
                         <a:latin typeface="Arial" charset="0"/>
@@ -10436,7 +10436,7 @@
                           <a:ea typeface="Arial" pitchFamily="34" charset="-122"/>
                           <a:cs typeface="Arial" pitchFamily="34" charset="-120"/>
                         </a:rPr>
-                        <a:t>−6.000 €</a:t>
+                        <a:t>0 €</a:t>
                       </a:r>
                       <a:endParaRPr lang="en-US" sz="1250" dirty="0">
                         <a:latin typeface="Arial" charset="0"/>
@@ -10700,7 +10700,7 @@
                           <a:ea typeface="Arial" pitchFamily="34" charset="-122"/>
                           <a:cs typeface="Arial" pitchFamily="34" charset="-120"/>
                         </a:rPr>
-                        <a:t>+3.860 €</a:t>
+                        <a:t>+9.860 €</a:t>
                       </a:r>
                       <a:endParaRPr lang="en-US" sz="1250" dirty="0">
                         <a:latin typeface="Arial" charset="0"/>
@@ -10805,7 +10805,7 @@
                 <a:ea typeface="Arial" pitchFamily="34" charset="-122"/>
                 <a:cs typeface="Arial" pitchFamily="34" charset="-120"/>
               </a:rPr>
-              <a:t>Lohn im Diagramm inkl. Rücklagen. Die ca. 3.100 € Tilgung in der Rate sind Vermögensaufbau (Schuld sinkt), kein Verlust.</a:t>
+              <a:t>Ohne Lohn des Bauherrn. Die ca. 3.100 € Tilgung in der Rate sind Vermögensaufbau (Schuld sinkt), kein Verlust.</a:t>
             </a:r>
             <a:endParaRPr lang="en-US" sz="1400" dirty="0"/>
           </a:p>
@@ -11611,7 +11611,7 @@
                           <a:ea typeface="Arial" pitchFamily="34" charset="-122"/>
                           <a:cs typeface="Arial" pitchFamily="34" charset="-120"/>
                         </a:rPr>
-                        <a:t>+3.860 €</a:t>
+                        <a:t>+9.860 €</a:t>
                       </a:r>
                       <a:endParaRPr lang="en-US" sz="1250" dirty="0">
                         <a:latin typeface="Arial" charset="0"/>
@@ -11744,7 +11744,7 @@
                           <a:ea typeface="Arial" pitchFamily="34" charset="-122"/>
                           <a:cs typeface="Arial" pitchFamily="34" charset="-120"/>
                         </a:rPr>
-                        <a:t>+2.068 €</a:t>
+                        <a:t>+8.068 €</a:t>
                       </a:r>
                       <a:endParaRPr lang="en-US" sz="1250" dirty="0">
                         <a:latin typeface="Arial" charset="0"/>
@@ -12009,7 +12009,7 @@
                           <a:ea typeface="Arial" pitchFamily="34" charset="-122"/>
                           <a:cs typeface="Arial" pitchFamily="34" charset="-120"/>
                         </a:rPr>
-                        <a:t>+4.369 €</a:t>
+                        <a:t>+10.369 €</a:t>
                       </a:r>
                       <a:endParaRPr lang="en-US" sz="1250" dirty="0">
                         <a:latin typeface="Arial" charset="0"/>
@@ -12142,7 +12142,7 @@
                           <a:ea typeface="Arial" pitchFamily="34" charset="-122"/>
                           <a:cs typeface="Arial" pitchFamily="34" charset="-120"/>
                         </a:rPr>
-                        <a:t>+2.666 €</a:t>
+                        <a:t>+8.666 €</a:t>
                       </a:r>
                       <a:endParaRPr lang="en-US" sz="1250" dirty="0">
                         <a:latin typeface="Arial" charset="0"/>
@@ -12407,7 +12407,7 @@
                           <a:ea typeface="Arial" pitchFamily="34" charset="-122"/>
                           <a:cs typeface="Arial" pitchFamily="34" charset="-120"/>
                         </a:rPr>
-                        <a:t>+4.877 €</a:t>
+                        <a:t>+10.877 €</a:t>
                       </a:r>
                       <a:endParaRPr lang="en-US" sz="1250" dirty="0">
                         <a:latin typeface="Arial" charset="0"/>
@@ -12540,7 +12540,7 @@
                           <a:ea typeface="Arial" pitchFamily="34" charset="-122"/>
                           <a:cs typeface="Arial" pitchFamily="34" charset="-120"/>
                         </a:rPr>
-                        <a:t>+3.264 €</a:t>
+                        <a:t>+9.264 €</a:t>
                       </a:r>
                       <a:endParaRPr lang="en-US" sz="1250" dirty="0">
                         <a:latin typeface="Arial" charset="0"/>
@@ -12805,7 +12805,7 @@
                           <a:ea typeface="Arial" pitchFamily="34" charset="-122"/>
                           <a:cs typeface="Arial" pitchFamily="34" charset="-120"/>
                         </a:rPr>
-                        <a:t>+5.386 €</a:t>
+                        <a:t>+11.386 €</a:t>
                       </a:r>
                       <a:endParaRPr lang="en-US" sz="1250" dirty="0">
                         <a:latin typeface="Arial" charset="0"/>
@@ -12938,7 +12938,7 @@
                           <a:ea typeface="Arial" pitchFamily="34" charset="-122"/>
                           <a:cs typeface="Arial" pitchFamily="34" charset="-120"/>
                         </a:rPr>
-                        <a:t>+3.862 €</a:t>
+                        <a:t>+9.862 €</a:t>
                       </a:r>
                       <a:endParaRPr lang="en-US" sz="1250" dirty="0">
                         <a:latin typeface="Arial" charset="0"/>
@@ -13203,7 +13203,7 @@
                           <a:ea typeface="Arial" pitchFamily="34" charset="-122"/>
                           <a:cs typeface="Arial" pitchFamily="34" charset="-120"/>
                         </a:rPr>
-                        <a:t>+5.895 €</a:t>
+                        <a:t>+11.895 €</a:t>
                       </a:r>
                       <a:endParaRPr lang="en-US" sz="1250" dirty="0">
                         <a:latin typeface="Arial" charset="0"/>
@@ -13336,7 +13336,7 @@
                           <a:ea typeface="Arial" pitchFamily="34" charset="-122"/>
                           <a:cs typeface="Arial" pitchFamily="34" charset="-120"/>
                         </a:rPr>
-                        <a:t>+4.460 €</a:t>
+                        <a:t>+10.460 €</a:t>
                       </a:r>
                       <a:endParaRPr lang="en-US" sz="1250" dirty="0">
                         <a:latin typeface="Arial" charset="0"/>
@@ -13601,7 +13601,7 @@
                           <a:ea typeface="Arial" pitchFamily="34" charset="-122"/>
                           <a:cs typeface="Arial" pitchFamily="34" charset="-120"/>
                         </a:rPr>
-                        <a:t>+6.403 €</a:t>
+                        <a:t>+12.403 €</a:t>
                       </a:r>
                       <a:endParaRPr lang="en-US" sz="1250" dirty="0">
                         <a:latin typeface="Arial" charset="0"/>
@@ -13734,7 +13734,7 @@
                           <a:ea typeface="Arial" pitchFamily="34" charset="-122"/>
                           <a:cs typeface="Arial" pitchFamily="34" charset="-120"/>
                         </a:rPr>
-                        <a:t>+5.059 €</a:t>
+                        <a:t>+11.059 €</a:t>
                       </a:r>
                       <a:endParaRPr lang="en-US" sz="1250" dirty="0">
                         <a:latin typeface="Arial" charset="0"/>
@@ -13839,7 +13839,7 @@
                 <a:ea typeface="Arial" pitchFamily="34" charset="-122"/>
                 <a:cs typeface="Arial" pitchFamily="34" charset="-120"/>
               </a:rPr>
-              <a:t>Pro 5 Prozentpunkte Förderung steigt das Ergebnis um ca. 509 € im Monat. Gastro-Umsatz 50.000 €, nach Lohn und Rücklagen.</a:t>
+              <a:t>Pro 5 Prozentpunkte Förderung steigt das Ergebnis um ca. 509 € im Monat. Gastro-Umsatz 50.000 €, nach Rücklagen, ohne Lohn.</a:t>
             </a:r>
             <a:endParaRPr lang="en-US" sz="1400" dirty="0"/>
           </a:p>
@@ -14515,7 +14515,7 @@
                           <a:ea typeface="Arial" pitchFamily="34" charset="-122"/>
                           <a:cs typeface="Arial" pitchFamily="34" charset="-120"/>
                         </a:rPr>
-                        <a:t>+810 €</a:t>
+                        <a:t>+6.810 €</a:t>
                       </a:r>
                       <a:endParaRPr lang="en-US" sz="1250" dirty="0">
                         <a:latin typeface="Arial" charset="0"/>
@@ -14583,7 +14583,7 @@
                           <a:ea typeface="Arial" pitchFamily="34" charset="-122"/>
                           <a:cs typeface="Arial" pitchFamily="34" charset="-120"/>
                         </a:rPr>
-                        <a:t>+2.335 €</a:t>
+                        <a:t>+8.335 €</a:t>
                       </a:r>
                       <a:endParaRPr lang="en-US" sz="1250" dirty="0">
                         <a:latin typeface="Arial" charset="0"/>
@@ -14651,7 +14651,7 @@
                           <a:ea typeface="Arial" pitchFamily="34" charset="-122"/>
                           <a:cs typeface="Arial" pitchFamily="34" charset="-120"/>
                         </a:rPr>
-                        <a:t>+3.860 €</a:t>
+                        <a:t>+9.860 €</a:t>
                       </a:r>
                       <a:endParaRPr lang="en-US" sz="1250" dirty="0">
                         <a:latin typeface="Arial" charset="0"/>
@@ -14719,7 +14719,7 @@
                           <a:ea typeface="Arial" pitchFamily="34" charset="-122"/>
                           <a:cs typeface="Arial" pitchFamily="34" charset="-120"/>
                         </a:rPr>
-                        <a:t>+5.385 €</a:t>
+                        <a:t>+11.385 €</a:t>
                       </a:r>
                       <a:endParaRPr lang="en-US" sz="1250" dirty="0">
                         <a:latin typeface="Arial" charset="0"/>
@@ -14787,7 +14787,7 @@
                           <a:ea typeface="Arial" pitchFamily="34" charset="-122"/>
                           <a:cs typeface="Arial" pitchFamily="34" charset="-120"/>
                         </a:rPr>
-                        <a:t>+6.910 €</a:t>
+                        <a:t>+12.910 €</a:t>
                       </a:r>
                       <a:endParaRPr lang="en-US" sz="1250" dirty="0">
                         <a:latin typeface="Arial" charset="0"/>
@@ -14922,7 +14922,7 @@
                           <a:ea typeface="Arial" pitchFamily="34" charset="-122"/>
                           <a:cs typeface="Arial" pitchFamily="34" charset="-120"/>
                         </a:rPr>
-                        <a:t>+1.827 €</a:t>
+                        <a:t>+7.827 €</a:t>
                       </a:r>
                       <a:endParaRPr lang="en-US" sz="1250" dirty="0">
                         <a:latin typeface="Arial" charset="0"/>
@@ -14990,7 +14990,7 @@
                           <a:ea typeface="Arial" pitchFamily="34" charset="-122"/>
                           <a:cs typeface="Arial" pitchFamily="34" charset="-120"/>
                         </a:rPr>
-                        <a:t>+3.352 €</a:t>
+                        <a:t>+9.352 €</a:t>
                       </a:r>
                       <a:endParaRPr lang="en-US" sz="1250" dirty="0">
                         <a:latin typeface="Arial" charset="0"/>
@@ -15058,7 +15058,7 @@
                           <a:ea typeface="Arial" pitchFamily="34" charset="-122"/>
                           <a:cs typeface="Arial" pitchFamily="34" charset="-120"/>
                         </a:rPr>
-                        <a:t>+4.877 €</a:t>
+                        <a:t>+10.877 €</a:t>
                       </a:r>
                       <a:endParaRPr lang="en-US" sz="1250" dirty="0">
                         <a:latin typeface="Arial" charset="0"/>
@@ -15126,7 +15126,7 @@
                           <a:ea typeface="Arial" pitchFamily="34" charset="-122"/>
                           <a:cs typeface="Arial" pitchFamily="34" charset="-120"/>
                         </a:rPr>
-                        <a:t>+6.402 €</a:t>
+                        <a:t>+12.402 €</a:t>
                       </a:r>
                       <a:endParaRPr lang="en-US" sz="1250" dirty="0">
                         <a:latin typeface="Arial" charset="0"/>
@@ -15194,7 +15194,7 @@
                           <a:ea typeface="Arial" pitchFamily="34" charset="-122"/>
                           <a:cs typeface="Arial" pitchFamily="34" charset="-120"/>
                         </a:rPr>
-                        <a:t>+7.927 €</a:t>
+                        <a:t>+13.927 €</a:t>
                       </a:r>
                       <a:endParaRPr lang="en-US" sz="1250" dirty="0">
                         <a:latin typeface="Arial" charset="0"/>
@@ -15329,7 +15329,7 @@
                           <a:ea typeface="Arial" pitchFamily="34" charset="-122"/>
                           <a:cs typeface="Arial" pitchFamily="34" charset="-120"/>
                         </a:rPr>
-                        <a:t>+2.336 €</a:t>
+                        <a:t>+8.336 €</a:t>
                       </a:r>
                       <a:endParaRPr lang="en-US" sz="1250" dirty="0">
                         <a:latin typeface="Arial" charset="0"/>
@@ -15397,7 +15397,7 @@
                           <a:ea typeface="Arial" pitchFamily="34" charset="-122"/>
                           <a:cs typeface="Arial" pitchFamily="34" charset="-120"/>
                         </a:rPr>
-                        <a:t>+3.861 €</a:t>
+                        <a:t>+9.861 €</a:t>
                       </a:r>
                       <a:endParaRPr lang="en-US" sz="1250" dirty="0">
                         <a:latin typeface="Arial" charset="0"/>
@@ -15465,7 +15465,7 @@
                           <a:ea typeface="Arial" pitchFamily="34" charset="-122"/>
                           <a:cs typeface="Arial" pitchFamily="34" charset="-120"/>
                         </a:rPr>
-                        <a:t>+5.386 €</a:t>
+                        <a:t>+11.386 €</a:t>
                       </a:r>
                       <a:endParaRPr lang="en-US" sz="1250" dirty="0">
                         <a:latin typeface="Arial" charset="0"/>
@@ -15533,7 +15533,7 @@
                           <a:ea typeface="Arial" pitchFamily="34" charset="-122"/>
                           <a:cs typeface="Arial" pitchFamily="34" charset="-120"/>
                         </a:rPr>
-                        <a:t>+6.911 €</a:t>
+                        <a:t>+12.911 €</a:t>
                       </a:r>
                       <a:endParaRPr lang="en-US" sz="1250" dirty="0">
                         <a:latin typeface="Arial" charset="0"/>
@@ -15601,7 +15601,7 @@
                           <a:ea typeface="Arial" pitchFamily="34" charset="-122"/>
                           <a:cs typeface="Arial" pitchFamily="34" charset="-120"/>
                         </a:rPr>
-                        <a:t>+8.436 €</a:t>
+                        <a:t>+14.436 €</a:t>
                       </a:r>
                       <a:endParaRPr lang="en-US" sz="1250" dirty="0">
                         <a:latin typeface="Arial" charset="0"/>
@@ -15736,7 +15736,7 @@
                           <a:ea typeface="Arial" pitchFamily="34" charset="-122"/>
                           <a:cs typeface="Arial" pitchFamily="34" charset="-120"/>
                         </a:rPr>
-                        <a:t>+2.845 €</a:t>
+                        <a:t>+8.845 €</a:t>
                       </a:r>
                       <a:endParaRPr lang="en-US" sz="1250" dirty="0">
                         <a:latin typeface="Arial" charset="0"/>
@@ -15804,7 +15804,7 @@
                           <a:ea typeface="Arial" pitchFamily="34" charset="-122"/>
                           <a:cs typeface="Arial" pitchFamily="34" charset="-120"/>
                         </a:rPr>
-                        <a:t>+4.370 €</a:t>
+                        <a:t>+10.370 €</a:t>
                       </a:r>
                       <a:endParaRPr lang="en-US" sz="1250" dirty="0">
                         <a:latin typeface="Arial" charset="0"/>
@@ -15872,7 +15872,7 @@
                           <a:ea typeface="Arial" pitchFamily="34" charset="-122"/>
                           <a:cs typeface="Arial" pitchFamily="34" charset="-120"/>
                         </a:rPr>
-                        <a:t>+5.895 €</a:t>
+                        <a:t>+11.895 €</a:t>
                       </a:r>
                       <a:endParaRPr lang="en-US" sz="1250" dirty="0">
                         <a:latin typeface="Arial" charset="0"/>
@@ -15940,7 +15940,7 @@
                           <a:ea typeface="Arial" pitchFamily="34" charset="-122"/>
                           <a:cs typeface="Arial" pitchFamily="34" charset="-120"/>
                         </a:rPr>
-                        <a:t>+7.420 €</a:t>
+                        <a:t>+13.420 €</a:t>
                       </a:r>
                       <a:endParaRPr lang="en-US" sz="1250" dirty="0">
                         <a:latin typeface="Arial" charset="0"/>
@@ -16008,7 +16008,7 @@
                           <a:ea typeface="Arial" pitchFamily="34" charset="-122"/>
                           <a:cs typeface="Arial" pitchFamily="34" charset="-120"/>
                         </a:rPr>
-                        <a:t>+8.945 €</a:t>
+                        <a:t>+14.945 €</a:t>
                       </a:r>
                       <a:endParaRPr lang="en-US" sz="1250" dirty="0">
                         <a:latin typeface="Arial" charset="0"/>
@@ -16097,7 +16097,7 @@
                 <a:ea typeface="Arial" pitchFamily="34" charset="-122"/>
                 <a:cs typeface="Arial" pitchFamily="34" charset="-120"/>
               </a:rPr>
-              <a:t>Break-even-Umsatz (Ergebnis nach Lohn = 0)</a:t>
+              <a:t>Break-even-Umsatz (Ergebnis = 0, ohne Lohn)</a:t>
             </a:r>
             <a:endParaRPr lang="en-US" sz="1800" dirty="0"/>
           </a:p>
@@ -16557,7 +16557,7 @@
                           <a:ea typeface="Arial" pitchFamily="34" charset="-122"/>
                           <a:cs typeface="Arial" pitchFamily="34" charset="-120"/>
                         </a:rPr>
-                        <a:t>37.344 €</a:t>
+                        <a:t>17.671 €</a:t>
                       </a:r>
                       <a:endParaRPr lang="en-US" sz="1250" dirty="0">
                         <a:latin typeface="Arial" charset="0"/>
@@ -16622,7 +16622,7 @@
                           <a:ea typeface="Arial" pitchFamily="34" charset="-122"/>
                           <a:cs typeface="Arial" pitchFamily="34" charset="-120"/>
                         </a:rPr>
-                        <a:t>34.009 €</a:t>
+                        <a:t>14.336 €</a:t>
                       </a:r>
                       <a:endParaRPr lang="en-US" sz="1250" dirty="0">
                         <a:latin typeface="Arial" charset="0"/>
@@ -16687,7 +16687,7 @@
                           <a:ea typeface="Arial" pitchFamily="34" charset="-122"/>
                           <a:cs typeface="Arial" pitchFamily="34" charset="-120"/>
                         </a:rPr>
-                        <a:t>32.341 €</a:t>
+                        <a:t>12.669 €</a:t>
                       </a:r>
                       <a:endParaRPr lang="en-US" sz="1250" dirty="0">
                         <a:latin typeface="Arial" charset="0"/>
@@ -16752,7 +16752,7 @@
                           <a:ea typeface="Arial" pitchFamily="34" charset="-122"/>
                           <a:cs typeface="Arial" pitchFamily="34" charset="-120"/>
                         </a:rPr>
-                        <a:t>30.674 €</a:t>
+                        <a:t>11.001 €</a:t>
                       </a:r>
                       <a:endParaRPr lang="en-US" sz="1250" dirty="0">
                         <a:latin typeface="Arial" charset="0"/>
@@ -16884,7 +16884,7 @@
                           <a:ea typeface="Arial" pitchFamily="34" charset="-122"/>
                           <a:cs typeface="Arial" pitchFamily="34" charset="-120"/>
                         </a:rPr>
-                        <a:t>43.221 €</a:t>
+                        <a:t>23.549 €</a:t>
                       </a:r>
                       <a:endParaRPr lang="en-US" sz="1250" dirty="0">
                         <a:latin typeface="Arial" charset="0"/>
@@ -16949,7 +16949,7 @@
                           <a:ea typeface="Arial" pitchFamily="34" charset="-122"/>
                           <a:cs typeface="Arial" pitchFamily="34" charset="-120"/>
                         </a:rPr>
-                        <a:t>39.298 €</a:t>
+                        <a:t>19.626 €</a:t>
                       </a:r>
                       <a:endParaRPr lang="en-US" sz="1250" dirty="0">
                         <a:latin typeface="Arial" charset="0"/>
@@ -17014,7 +17014,7 @@
                           <a:ea typeface="Arial" pitchFamily="34" charset="-122"/>
                           <a:cs typeface="Arial" pitchFamily="34" charset="-120"/>
                         </a:rPr>
-                        <a:t>37.337 €</a:t>
+                        <a:t>17.665 €</a:t>
                       </a:r>
                       <a:endParaRPr lang="en-US" sz="1250" dirty="0">
                         <a:latin typeface="Arial" charset="0"/>
@@ -17079,7 +17079,7 @@
                           <a:ea typeface="Arial" pitchFamily="34" charset="-122"/>
                           <a:cs typeface="Arial" pitchFamily="34" charset="-120"/>
                         </a:rPr>
-                        <a:t>35.375 €</a:t>
+                        <a:t>15.703 €</a:t>
                       </a:r>
                       <a:endParaRPr lang="en-US" sz="1250" dirty="0">
                         <a:latin typeface="Arial" charset="0"/>
@@ -17595,7 +17595,7 @@
                           <a:ea typeface="Arial" pitchFamily="34" charset="-122"/>
                           <a:cs typeface="Arial" pitchFamily="34" charset="-120"/>
                         </a:rPr>
-                        <a:t>+810 €</a:t>
+                        <a:t>+6.810 €</a:t>
                       </a:r>
                       <a:endParaRPr lang="en-US" sz="1250" dirty="0">
                         <a:latin typeface="Arial" charset="0"/>
@@ -17657,13 +17657,13 @@
                       <a:r>
                         <a:rPr lang="en-US" sz="1250" b="1" dirty="0">
                           <a:solidFill>
-                            <a:schemeClr val="accent6"/>
+                            <a:schemeClr val="accent5"/>
                           </a:solidFill>
                           <a:latin typeface="Arial" pitchFamily="34" charset="0"/>
                           <a:ea typeface="Arial" pitchFamily="34" charset="-122"/>
                           <a:cs typeface="Arial" pitchFamily="34" charset="-120"/>
                         </a:rPr>
-                        <a:t>−982 €</a:t>
+                        <a:t>+5.018 €</a:t>
                       </a:r>
                       <a:endParaRPr lang="en-US" sz="1250" dirty="0">
                         <a:latin typeface="Arial" charset="0"/>
@@ -17710,7 +17710,7 @@
                       <a:tailEnd type="none" w="med" len="med"/>
                     </a:lnB>
                     <a:solidFill>
-                      <a:srgbClr val="F8E4E2"/>
+                      <a:srgbClr val="E3F1EA"/>
                     </a:solidFill>
                   </a:tcPr>
                 </a:tc>
@@ -17798,7 +17798,7 @@
                           <a:ea typeface="Arial" pitchFamily="34" charset="-122"/>
                           <a:cs typeface="Arial" pitchFamily="34" charset="-120"/>
                         </a:rPr>
-                        <a:t>+2.336 €</a:t>
+                        <a:t>+8.336 €</a:t>
                       </a:r>
                       <a:endParaRPr lang="en-US" sz="1250" dirty="0">
                         <a:latin typeface="Arial" charset="0"/>
@@ -17866,7 +17866,7 @@
                           <a:ea typeface="Arial" pitchFamily="34" charset="-122"/>
                           <a:cs typeface="Arial" pitchFamily="34" charset="-120"/>
                         </a:rPr>
-                        <a:t>+812 €</a:t>
+                        <a:t>+6.812 €</a:t>
                       </a:r>
                       <a:endParaRPr lang="en-US" sz="1250" dirty="0">
                         <a:latin typeface="Arial" charset="0"/>
@@ -18001,7 +18001,7 @@
                           <a:ea typeface="Arial" pitchFamily="34" charset="-122"/>
                           <a:cs typeface="Arial" pitchFamily="34" charset="-120"/>
                         </a:rPr>
-                        <a:t>+3.028 €</a:t>
+                        <a:t>+9.028 €</a:t>
                       </a:r>
                       <a:endParaRPr lang="en-US" sz="1250" dirty="0">
                         <a:latin typeface="Arial" charset="0"/>
@@ -18069,7 +18069,7 @@
                           <a:ea typeface="Arial" pitchFamily="34" charset="-122"/>
                           <a:cs typeface="Arial" pitchFamily="34" charset="-120"/>
                         </a:rPr>
-                        <a:t>+1.625 €</a:t>
+                        <a:t>+7.625 €</a:t>
                       </a:r>
                       <a:endParaRPr lang="en-US" sz="1250" dirty="0">
                         <a:latin typeface="Arial" charset="0"/>
@@ -18204,7 +18204,7 @@
                           <a:ea typeface="Arial" pitchFamily="34" charset="-122"/>
                           <a:cs typeface="Arial" pitchFamily="34" charset="-120"/>
                         </a:rPr>
-                        <a:t>+3.189 €</a:t>
+                        <a:t>+9.189 €</a:t>
                       </a:r>
                       <a:endParaRPr lang="en-US" sz="1250" dirty="0">
                         <a:latin typeface="Arial" charset="0"/>
@@ -18272,7 +18272,7 @@
                           <a:ea typeface="Arial" pitchFamily="34" charset="-122"/>
                           <a:cs typeface="Arial" pitchFamily="34" charset="-120"/>
                         </a:rPr>
-                        <a:t>+1.815 €</a:t>
+                        <a:t>+7.815 €</a:t>
                       </a:r>
                       <a:endParaRPr lang="en-US" sz="1250" dirty="0">
                         <a:latin typeface="Arial" charset="0"/>
@@ -18407,7 +18407,7 @@
                           <a:ea typeface="Arial" pitchFamily="34" charset="-122"/>
                           <a:cs typeface="Arial" pitchFamily="34" charset="-120"/>
                         </a:rPr>
-                        <a:t>+4.714 €</a:t>
+                        <a:t>+10.714 €</a:t>
                       </a:r>
                       <a:endParaRPr lang="en-US" sz="1250" dirty="0">
                         <a:latin typeface="Arial" charset="0"/>
@@ -18475,7 +18475,7 @@
                           <a:ea typeface="Arial" pitchFamily="34" charset="-122"/>
                           <a:cs typeface="Arial" pitchFamily="34" charset="-120"/>
                         </a:rPr>
-                        <a:t>+3.340 €</a:t>
+                        <a:t>+9.340 €</a:t>
                       </a:r>
                       <a:endParaRPr lang="en-US" sz="1250" dirty="0">
                         <a:latin typeface="Arial" charset="0"/>
@@ -18610,7 +18610,7 @@
                           <a:ea typeface="Arial" pitchFamily="34" charset="-122"/>
                           <a:cs typeface="Arial" pitchFamily="34" charset="-120"/>
                         </a:rPr>
-                        <a:t>+6.526 €</a:t>
+                        <a:t>+12.526 €</a:t>
                       </a:r>
                       <a:endParaRPr lang="en-US" sz="1250" dirty="0">
                         <a:latin typeface="Arial" charset="0"/>
@@ -18678,210 +18678,7 @@
                           <a:ea typeface="Arial" pitchFamily="34" charset="-122"/>
                           <a:cs typeface="Arial" pitchFamily="34" charset="-120"/>
                         </a:rPr>
-                        <a:t>+5.174 €</a:t>
-                      </a:r>
-                      <a:endParaRPr lang="en-US" sz="1250" dirty="0">
-                        <a:latin typeface="Arial" charset="0"/>
-                        <a:ea typeface="Arial" charset="0"/>
-                        <a:cs typeface="Arial" charset="0"/>
-                      </a:endParaRPr>
-                    </a:p>
-                  </a:txBody>
-                  <a:tcPr marL="91440" marR="91440" marT="45720" marB="45720">
-                    <a:lnL w="12700" cap="flat" cmpd="sng" algn="ctr">
-                      <a:solidFill>
-                        <a:srgbClr val="FFFFFF"/>
-                      </a:solidFill>
-                      <a:prstDash val="solid"/>
-                      <a:round/>
-                      <a:headEnd type="none" w="med" len="med"/>
-                      <a:tailEnd type="none" w="med" len="med"/>
-                    </a:lnL>
-                    <a:lnR w="12700" cap="flat" cmpd="sng" algn="ctr">
-                      <a:solidFill>
-                        <a:srgbClr val="FFFFFF"/>
-                      </a:solidFill>
-                      <a:prstDash val="solid"/>
-                      <a:round/>
-                      <a:headEnd type="none" w="med" len="med"/>
-                      <a:tailEnd type="none" w="med" len="med"/>
-                    </a:lnR>
-                    <a:lnT w="12700" cap="flat" cmpd="sng" algn="ctr">
-                      <a:solidFill>
-                        <a:srgbClr val="FFFFFF"/>
-                      </a:solidFill>
-                      <a:prstDash val="solid"/>
-                      <a:round/>
-                      <a:headEnd type="none" w="med" len="med"/>
-                      <a:tailEnd type="none" w="med" len="med"/>
-                    </a:lnT>
-                    <a:lnB w="12700" cap="flat" cmpd="sng" algn="ctr">
-                      <a:solidFill>
-                        <a:srgbClr val="FFFFFF"/>
-                      </a:solidFill>
-                      <a:prstDash val="solid"/>
-                      <a:round/>
-                      <a:headEnd type="none" w="med" len="med"/>
-                      <a:tailEnd type="none" w="med" len="med"/>
-                    </a:lnB>
-                    <a:solidFill>
-                      <a:srgbClr val="E3F1EA"/>
-                    </a:solidFill>
-                  </a:tcPr>
-                </a:tc>
-              </a:tr>
-              <a:tr h="475488">
-                <a:tc>
-                  <a:txBody>
-                    <a:bodyPr/>
-                    <a:lstStyle/>
-                    <a:p>
-                      <a:pPr indent="0" marL="0">
-                        <a:buNone/>
-                      </a:pPr>
-                      <a:r>
-                        <a:rPr lang="en-US" sz="1250" dirty="0">
-                          <a:solidFill>
-                            <a:srgbClr val="000000"/>
-                          </a:solidFill>
-                          <a:latin typeface="Arial" pitchFamily="34" charset="0"/>
-                          <a:ea typeface="Arial" pitchFamily="34" charset="-122"/>
-                          <a:cs typeface="Arial" pitchFamily="34" charset="-120"/>
-                        </a:rPr>
-                        <a:t>+ Lohn 4.000 € statt 6.000 €</a:t>
-                      </a:r>
-                      <a:endParaRPr lang="en-US" sz="1250" dirty="0">
-                        <a:latin typeface="Arial" charset="0"/>
-                        <a:ea typeface="Arial" charset="0"/>
-                        <a:cs typeface="Arial" charset="0"/>
-                      </a:endParaRPr>
-                    </a:p>
-                  </a:txBody>
-                  <a:tcPr marL="91440" marR="91440" marT="45720" marB="45720">
-                    <a:lnL w="12700" cap="flat" cmpd="sng" algn="ctr">
-                      <a:solidFill>
-                        <a:srgbClr val="FFFFFF"/>
-                      </a:solidFill>
-                      <a:prstDash val="solid"/>
-                      <a:round/>
-                      <a:headEnd type="none" w="med" len="med"/>
-                      <a:tailEnd type="none" w="med" len="med"/>
-                    </a:lnL>
-                    <a:lnR w="12700" cap="flat" cmpd="sng" algn="ctr">
-                      <a:solidFill>
-                        <a:srgbClr val="FFFFFF"/>
-                      </a:solidFill>
-                      <a:prstDash val="solid"/>
-                      <a:round/>
-                      <a:headEnd type="none" w="med" len="med"/>
-                      <a:tailEnd type="none" w="med" len="med"/>
-                    </a:lnR>
-                    <a:lnT w="12700" cap="flat" cmpd="sng" algn="ctr">
-                      <a:solidFill>
-                        <a:srgbClr val="FFFFFF"/>
-                      </a:solidFill>
-                      <a:prstDash val="solid"/>
-                      <a:round/>
-                      <a:headEnd type="none" w="med" len="med"/>
-                      <a:tailEnd type="none" w="med" len="med"/>
-                    </a:lnT>
-                    <a:lnB w="12700" cap="flat" cmpd="sng" algn="ctr">
-                      <a:solidFill>
-                        <a:srgbClr val="FFFFFF"/>
-                      </a:solidFill>
-                      <a:prstDash val="solid"/>
-                      <a:round/>
-                      <a:headEnd type="none" w="med" len="med"/>
-                      <a:tailEnd type="none" w="med" len="med"/>
-                    </a:lnB>
-                  </a:tcPr>
-                </a:tc>
-                <a:tc>
-                  <a:txBody>
-                    <a:bodyPr/>
-                    <a:lstStyle/>
-                    <a:p>
-                      <a:pPr algn="r" indent="0" marL="0">
-                        <a:buNone/>
-                      </a:pPr>
-                      <a:r>
-                        <a:rPr lang="en-US" sz="1250" b="1" dirty="0">
-                          <a:solidFill>
-                            <a:schemeClr val="accent5"/>
-                          </a:solidFill>
-                          <a:latin typeface="Arial" pitchFamily="34" charset="0"/>
-                          <a:ea typeface="Arial" pitchFamily="34" charset="-122"/>
-                          <a:cs typeface="Arial" pitchFamily="34" charset="-120"/>
-                        </a:rPr>
-                        <a:t>+8.526 €</a:t>
-                      </a:r>
-                      <a:endParaRPr lang="en-US" sz="1250" dirty="0">
-                        <a:latin typeface="Arial" charset="0"/>
-                        <a:ea typeface="Arial" charset="0"/>
-                        <a:cs typeface="Arial" charset="0"/>
-                      </a:endParaRPr>
-                    </a:p>
-                  </a:txBody>
-                  <a:tcPr marL="91440" marR="91440" marT="45720" marB="45720">
-                    <a:lnL w="12700" cap="flat" cmpd="sng" algn="ctr">
-                      <a:solidFill>
-                        <a:srgbClr val="FFFFFF"/>
-                      </a:solidFill>
-                      <a:prstDash val="solid"/>
-                      <a:round/>
-                      <a:headEnd type="none" w="med" len="med"/>
-                      <a:tailEnd type="none" w="med" len="med"/>
-                    </a:lnL>
-                    <a:lnR w="12700" cap="flat" cmpd="sng" algn="ctr">
-                      <a:solidFill>
-                        <a:srgbClr val="FFFFFF"/>
-                      </a:solidFill>
-                      <a:prstDash val="solid"/>
-                      <a:round/>
-                      <a:headEnd type="none" w="med" len="med"/>
-                      <a:tailEnd type="none" w="med" len="med"/>
-                    </a:lnR>
-                    <a:lnT w="12700" cap="flat" cmpd="sng" algn="ctr">
-                      <a:solidFill>
-                        <a:srgbClr val="FFFFFF"/>
-                      </a:solidFill>
-                      <a:prstDash val="solid"/>
-                      <a:round/>
-                      <a:headEnd type="none" w="med" len="med"/>
-                      <a:tailEnd type="none" w="med" len="med"/>
-                    </a:lnT>
-                    <a:lnB w="12700" cap="flat" cmpd="sng" algn="ctr">
-                      <a:solidFill>
-                        <a:srgbClr val="FFFFFF"/>
-                      </a:solidFill>
-                      <a:prstDash val="solid"/>
-                      <a:round/>
-                      <a:headEnd type="none" w="med" len="med"/>
-                      <a:tailEnd type="none" w="med" len="med"/>
-                    </a:lnB>
-                    <a:solidFill>
-                      <a:srgbClr val="E3F1EA"/>
-                    </a:solidFill>
-                  </a:tcPr>
-                </a:tc>
-                <a:tc>
-                  <a:txBody>
-                    <a:bodyPr/>
-                    <a:lstStyle/>
-                    <a:p>
-                      <a:pPr algn="r" indent="0" marL="0">
-                        <a:buNone/>
-                      </a:pPr>
-                      <a:r>
-                        <a:rPr lang="en-US" sz="1250" b="1" dirty="0">
-                          <a:solidFill>
-                            <a:schemeClr val="accent5"/>
-                          </a:solidFill>
-                          <a:latin typeface="Arial" pitchFamily="34" charset="0"/>
-                          <a:ea typeface="Arial" pitchFamily="34" charset="-122"/>
-                          <a:cs typeface="Arial" pitchFamily="34" charset="-120"/>
-                        </a:rPr>
-                        <a:t>+7.174 €</a:t>
+                        <a:t>+11.174 €</a:t>
                       </a:r>
                       <a:endParaRPr lang="en-US" sz="1250" dirty="0">
                         <a:latin typeface="Arial" charset="0"/>
@@ -19014,7 +18811,7 @@
                 <a:ea typeface="Arial" pitchFamily="34" charset="-122"/>
                 <a:cs typeface="Arial" pitchFamily="34" charset="-120"/>
               </a:rPr>
-              <a:t>Schon die Ausgangslage mit 2.200 €/m² und 150.000 € Ausbau liegt im Plan nahe an Plus, Förderung und günstige Preise geben Luft.</a:t>
+              <a:t>Ohne Lohn des Bauherrn liegt schon die Ausgangslage mit 40.000 € Umsatz im Plus, Förderung und günstige Preise geben zusätzlichen Puffer.</a:t>
             </a:r>
             <a:endParaRPr lang="en-US" sz="1400" dirty="0"/>
           </a:p>
@@ -19065,7 +18862,7 @@
                 <a:ea typeface="Arial" pitchFamily="34" charset="-122"/>
                 <a:cs typeface="Arial" pitchFamily="34" charset="-120"/>
               </a:rPr>
-              <a:t>Tilgung 0 % und weniger Lohn verbessern das Konto, nicht das Haus.</a:t>
+              <a:t>Tilgung 0 % verbessert das Konto, nicht das Haus.</a:t>
             </a:r>
             <a:endParaRPr lang="en-US" sz="1400" dirty="0"/>
           </a:p>
@@ -20536,7 +20333,7 @@
                           <a:ea typeface="Arial" pitchFamily="34" charset="-122"/>
                           <a:cs typeface="Arial" pitchFamily="34" charset="-120"/>
                         </a:rPr>
-                        <a:t>9.250 €</a:t>
+                        <a:t>15.250 €</a:t>
                       </a:r>
                       <a:endParaRPr lang="en-US" sz="1250" dirty="0">
                         <a:latin typeface="Arial" charset="0"/>
@@ -20804,7 +20601,7 @@
                           <a:ea typeface="Arial" pitchFamily="34" charset="-122"/>
                           <a:cs typeface="Arial" pitchFamily="34" charset="-120"/>
                         </a:rPr>
-                        <a:t>+5.074 €</a:t>
+                        <a:t>+11.074 €</a:t>
                       </a:r>
                       <a:endParaRPr lang="en-US" sz="1250" dirty="0">
                         <a:latin typeface="Arial" charset="0"/>
@@ -21655,7 +21452,7 @@
                 <a:ea typeface="Arial" pitchFamily="34" charset="-122"/>
                 <a:cs typeface="Arial" pitchFamily="34" charset="-120"/>
               </a:rPr>
-              <a:t>Die Rechnung für den Gastro-Teil gilt bei 50.000 € Umsatz und 6.000 € Lohn, Break-even ab 33.000 €. Die Wohnungen tragen sich bei 11,18 €/m² Miete erst ab einem Preis von ca. 2.640 € je m².</a:t>
+              <a:t>Die Rechnung für den Gastro-Teil gilt bei 50.000 € Umsatz ohne Lohn des Bauherrn, Break-even ab 14.000 €. Die Wohnungen tragen sich bei 11,18 €/m² Miete erst ab einem Preis von ca. 2.640 € je m².</a:t>
             </a:r>
             <a:endParaRPr lang="en-US" sz="1250" dirty="0"/>
           </a:p>
@@ -22349,7 +22146,7 @@
                           <a:ea typeface="Arial" pitchFamily="34" charset="-122"/>
                           <a:cs typeface="Arial" pitchFamily="34" charset="-120"/>
                         </a:rPr>
-                        <a:t>+5.074 €</a:t>
+                        <a:t>+11.074 €</a:t>
                       </a:r>
                       <a:endParaRPr lang="en-US" sz="1250" dirty="0">
                         <a:latin typeface="Arial" charset="0"/>
@@ -22620,7 +22417,7 @@
                           <a:ea typeface="Arial" pitchFamily="34" charset="-122"/>
                           <a:cs typeface="Arial" pitchFamily="34" charset="-120"/>
                         </a:rPr>
-                        <a:t>+5.700 €</a:t>
+                        <a:t>+11.700 €</a:t>
                       </a:r>
                       <a:endParaRPr lang="en-US" sz="1250" dirty="0">
                         <a:latin typeface="Arial" charset="0"/>
@@ -22891,7 +22688,7 @@
                           <a:ea typeface="Arial" pitchFamily="34" charset="-122"/>
                           <a:cs typeface="Arial" pitchFamily="34" charset="-120"/>
                         </a:rPr>
-                        <a:t>+6.526 €</a:t>
+                        <a:t>+12.526 €</a:t>
                       </a:r>
                       <a:endParaRPr lang="en-US" sz="1250" dirty="0">
                         <a:latin typeface="Arial" charset="0"/>
@@ -23162,7 +22959,7 @@
                           <a:ea typeface="Arial" pitchFamily="34" charset="-122"/>
                           <a:cs typeface="Arial" pitchFamily="34" charset="-120"/>
                         </a:rPr>
-                        <a:t>+6.720 €</a:t>
+                        <a:t>+12.720 €</a:t>
                       </a:r>
                       <a:endParaRPr lang="en-US" sz="1250" dirty="0">
                         <a:latin typeface="Arial" charset="0"/>
@@ -23433,7 +23230,7 @@
                           <a:ea typeface="Arial" pitchFamily="34" charset="-122"/>
                           <a:cs typeface="Arial" pitchFamily="34" charset="-120"/>
                         </a:rPr>
-                        <a:t>+6.148 €</a:t>
+                        <a:t>+12.148 €</a:t>
                       </a:r>
                       <a:endParaRPr lang="en-US" sz="1250" dirty="0">
                         <a:latin typeface="Arial" charset="0"/>
@@ -23704,7 +23501,7 @@
                           <a:ea typeface="Arial" pitchFamily="34" charset="-122"/>
                           <a:cs typeface="Arial" pitchFamily="34" charset="-120"/>
                         </a:rPr>
-                        <a:t>+6.273 €</a:t>
+                        <a:t>+12.273 €</a:t>
                       </a:r>
                       <a:endParaRPr lang="en-US" sz="1250" dirty="0">
                         <a:latin typeface="Arial" charset="0"/>
@@ -23927,7 +23724,7 @@
                 <a:ea typeface="Arial" pitchFamily="34" charset="-122"/>
                 <a:cs typeface="Arial" pitchFamily="34" charset="-120"/>
               </a:rPr>
-              <a:t>Zum Vergleich: Wenn du die Lücke der drei OG-Wohnungen (1.040 € im Monat) selbst trägst, bleiben dir 4.033 € aus der Gastro.</a:t>
+              <a:t>Zum Vergleich: Wenn du die Lücke der drei OG-Wohnungen (1.040 € im Monat) selbst trägst, bleiben dir 10.033 € aus der Gastro.</a:t>
             </a:r>
             <a:endParaRPr lang="en-US" sz="1250" dirty="0"/>
           </a:p>
@@ -24455,7 +24252,7 @@
                 <a:ea typeface="Georgia" pitchFamily="34" charset="-122"/>
                 <a:cs typeface="Georgia" pitchFamily="34" charset="-120"/>
               </a:rPr>
-              <a:t>+3.860 €</a:t>
+              <a:t>+9.860 €</a:t>
             </a:r>
             <a:endParaRPr lang="en-US" sz="3000" dirty="0"/>
           </a:p>
@@ -24533,7 +24330,7 @@
                 <a:ea typeface="Arial" pitchFamily="34" charset="-122"/>
                 <a:cs typeface="Arial" pitchFamily="34" charset="-120"/>
               </a:rPr>
-              <a:t>Ergebnis pro Monat nach Lohn bei 50.000 € Gastro-Umsatz (Plan, 3,3 % Zins)</a:t>
+              <a:t>Ergebnis pro Monat (ohne Lohn des Bauherrn) bei 50.000 € Gastro-Umsatz (Plan, 3,3 % Zins)</a:t>
             </a:r>
             <a:endParaRPr lang="en-US" sz="1600" dirty="0"/>
           </a:p>
@@ -25131,7 +24928,7 @@
                           <a:ea typeface="Arial" pitchFamily="34" charset="-122"/>
                           <a:cs typeface="Arial" pitchFamily="34" charset="-120"/>
                         </a:rPr>
-                        <a:t>+3.860 €</a:t>
+                        <a:t>+9.860 €</a:t>
                       </a:r>
                       <a:endParaRPr lang="en-US" sz="1250" dirty="0">
                         <a:latin typeface="Arial" charset="0"/>
@@ -25199,7 +24996,7 @@
                           <a:ea typeface="Arial" pitchFamily="34" charset="-122"/>
                           <a:cs typeface="Arial" pitchFamily="34" charset="-120"/>
                         </a:rPr>
-                        <a:t>+4.369 €</a:t>
+                        <a:t>+10.369 €</a:t>
                       </a:r>
                       <a:endParaRPr lang="en-US" sz="1250" dirty="0">
                         <a:latin typeface="Arial" charset="0"/>
@@ -25267,7 +25064,7 @@
                           <a:ea typeface="Arial" pitchFamily="34" charset="-122"/>
                           <a:cs typeface="Arial" pitchFamily="34" charset="-120"/>
                         </a:rPr>
-                        <a:t>+4.877 €</a:t>
+                        <a:t>+10.877 €</a:t>
                       </a:r>
                       <a:endParaRPr lang="en-US" sz="1250" dirty="0">
                         <a:latin typeface="Arial" charset="0"/>
@@ -25335,7 +25132,7 @@
                           <a:ea typeface="Arial" pitchFamily="34" charset="-122"/>
                           <a:cs typeface="Arial" pitchFamily="34" charset="-120"/>
                         </a:rPr>
-                        <a:t>+5.386 €</a:t>
+                        <a:t>+11.386 €</a:t>
                       </a:r>
                       <a:endParaRPr lang="en-US" sz="1250" dirty="0">
                         <a:latin typeface="Arial" charset="0"/>
@@ -25403,7 +25200,7 @@
                           <a:ea typeface="Arial" pitchFamily="34" charset="-122"/>
                           <a:cs typeface="Arial" pitchFamily="34" charset="-120"/>
                         </a:rPr>
-                        <a:t>+5.895 €</a:t>
+                        <a:t>+11.895 €</a:t>
                       </a:r>
                       <a:endParaRPr lang="en-US" sz="1250" dirty="0">
                         <a:latin typeface="Arial" charset="0"/>
@@ -25471,7 +25268,7 @@
                           <a:ea typeface="Arial" pitchFamily="34" charset="-122"/>
                           <a:cs typeface="Arial" pitchFamily="34" charset="-120"/>
                         </a:rPr>
-                        <a:t>+6.403 €</a:t>
+                        <a:t>+12.403 €</a:t>
                       </a:r>
                       <a:endParaRPr lang="en-US" sz="1250" dirty="0">
                         <a:latin typeface="Arial" charset="0"/>
@@ -25574,7 +25371,7 @@
                 <a:ea typeface="Arial" pitchFamily="34" charset="-122"/>
                 <a:cs typeface="Arial" pitchFamily="34" charset="-120"/>
               </a:rPr>
-              <a:t>Break-even-Umsatz ohne Förderung ca. 37.300 € im Monat. Dazu kommt eine Anlaufphase von 12 Monaten ohne Rate (Aufschub).</a:t>
+              <a:t>Break-even-Umsatz ohne Förderung ca. 17.700 € im Monat. Dazu kommt eine Anlaufphase von 12 Monaten ohne Rate (Aufschub).</a:t>
             </a:r>
             <a:endParaRPr lang="en-US" sz="1600" dirty="0"/>
           </a:p>
@@ -25931,7 +25728,7 @@
                 <a:ea typeface="Arial" pitchFamily="34" charset="-122"/>
                 <a:cs typeface="Arial" pitchFamily="34" charset="-120"/>
               </a:rPr>
-              <a:t>Die Gastro braucht ab ca. 37.000 € Umsatz, bei 4 % Zins ca. 43.000 €. Gegenmaßnahme: Konzept, Pacht-Staffel, Lohn variabel.</a:t>
+              <a:t>Die Gastro braucht ab ca. 18.000 € Umsatz, bei 4 % Zins ca. 24.000 €. Gegenmaßnahme: Konzept, Pacht-Staffel, Lohn des Bauherrn bewusst ausgeklammert.</a:t>
             </a:r>
             <a:endParaRPr lang="en-US" sz="1400" dirty="0"/>
           </a:p>
@@ -28379,7 +28176,7 @@
                 <a:ea typeface="Arial" pitchFamily="34" charset="-122"/>
                 <a:cs typeface="Arial" pitchFamily="34" charset="-120"/>
               </a:rPr>
-              <a:t>Lohn Bessam 6.000 €, Rücklagen 10 % der Miete und Pacht</a:t>
+              <a:t>Lohn des Bauherrn wird vorerst nicht gerechnet, Rücklagen 10 % der Miete und Pacht</a:t>
             </a:r>
             <a:endParaRPr lang="en-US" sz="1500" dirty="0"/>
           </a:p>
@@ -36188,7 +35985,7 @@
                           <a:ea typeface="Arial" pitchFamily="34" charset="-122"/>
                           <a:cs typeface="Arial" pitchFamily="34" charset="-120"/>
                         </a:rPr>
-                        <a:t>+3.860 €</a:t>
+                        <a:t>+9.860 €</a:t>
                       </a:r>
                       <a:endParaRPr lang="en-US" sz="1250" dirty="0">
                         <a:latin typeface="Arial" charset="0"/>
@@ -36256,7 +36053,7 @@
                           <a:ea typeface="Arial" pitchFamily="34" charset="-122"/>
                           <a:cs typeface="Arial" pitchFamily="34" charset="-120"/>
                         </a:rPr>
-                        <a:t>+2.257 €</a:t>
+                        <a:t>+8.257 €</a:t>
                       </a:r>
                       <a:endParaRPr lang="en-US" sz="1250" dirty="0">
                         <a:latin typeface="Arial" charset="0"/>
@@ -36324,7 +36121,7 @@
                           <a:ea typeface="Arial" pitchFamily="34" charset="-122"/>
                           <a:cs typeface="Arial" pitchFamily="34" charset="-120"/>
                         </a:rPr>
-                        <a:t>+1.234 €</a:t>
+                        <a:t>+7.234 €</a:t>
                       </a:r>
                       <a:endParaRPr lang="en-US" sz="1250" dirty="0">
                         <a:latin typeface="Arial" charset="0"/>
@@ -36459,7 +36256,7 @@
                           <a:ea typeface="Arial" pitchFamily="34" charset="-122"/>
                           <a:cs typeface="Arial" pitchFamily="34" charset="-120"/>
                         </a:rPr>
-                        <a:t>37.344 €</a:t>
+                        <a:t>17.671 €</a:t>
                       </a:r>
                       <a:endParaRPr lang="en-US" sz="1250" dirty="0">
                         <a:latin typeface="Arial" charset="0"/>
@@ -36524,7 +36321,7 @@
                           <a:ea typeface="Arial" pitchFamily="34" charset="-122"/>
                           <a:cs typeface="Arial" pitchFamily="34" charset="-120"/>
                         </a:rPr>
-                        <a:t>42.601 €</a:t>
+                        <a:t>22.929 €</a:t>
                       </a:r>
                       <a:endParaRPr lang="en-US" sz="1250" dirty="0">
                         <a:latin typeface="Arial" charset="0"/>
@@ -36589,7 +36386,7 @@
                           <a:ea typeface="Arial" pitchFamily="34" charset="-122"/>
                           <a:cs typeface="Arial" pitchFamily="34" charset="-120"/>
                         </a:rPr>
-                        <a:t>45.953 €</a:t>
+                        <a:t>26.281 €</a:t>
                       </a:r>
                       <a:endParaRPr lang="en-US" sz="1250" dirty="0">
                         <a:latin typeface="Arial" charset="0"/>
@@ -36721,7 +36518,7 @@
                           <a:ea typeface="Arial" pitchFamily="34" charset="-122"/>
                           <a:cs typeface="Arial" pitchFamily="34" charset="-120"/>
                         </a:rPr>
-                        <a:t>+2.068 €</a:t>
+                        <a:t>+8.068 €</a:t>
                       </a:r>
                       <a:endParaRPr lang="en-US" sz="1250" dirty="0">
                         <a:latin typeface="Arial" charset="0"/>
@@ -36783,13 +36580,13 @@
                       <a:r>
                         <a:rPr lang="en-US" sz="1250" b="1" dirty="0">
                           <a:solidFill>
-                            <a:schemeClr val="accent6"/>
+                            <a:schemeClr val="accent5"/>
                           </a:solidFill>
                           <a:latin typeface="Arial" pitchFamily="34" charset="0"/>
                           <a:ea typeface="Arial" pitchFamily="34" charset="-122"/>
                           <a:cs typeface="Arial" pitchFamily="34" charset="-120"/>
                         </a:rPr>
-                        <a:t>−458 €</a:t>
+                        <a:t>+5.542 €</a:t>
                       </a:r>
                       <a:endParaRPr lang="en-US" sz="1250" dirty="0">
                         <a:latin typeface="Arial" charset="0"/>
@@ -36836,7 +36633,7 @@
                       <a:tailEnd type="none" w="med" len="med"/>
                     </a:lnB>
                     <a:solidFill>
-                      <a:srgbClr val="F8E4E2"/>
+                      <a:srgbClr val="E3F1EA"/>
                     </a:solidFill>
                   </a:tcPr>
                 </a:tc>
@@ -36851,13 +36648,13 @@
                       <a:r>
                         <a:rPr lang="en-US" sz="1250" b="1" dirty="0">
                           <a:solidFill>
-                            <a:schemeClr val="accent6"/>
+                            <a:schemeClr val="accent5"/>
                           </a:solidFill>
                           <a:latin typeface="Arial" pitchFamily="34" charset="0"/>
                           <a:ea typeface="Arial" pitchFamily="34" charset="-122"/>
                           <a:cs typeface="Arial" pitchFamily="34" charset="-120"/>
                         </a:rPr>
-                        <a:t>−2.394 €</a:t>
+                        <a:t>+3.606 €</a:t>
                       </a:r>
                       <a:endParaRPr lang="en-US" sz="1250" dirty="0">
                         <a:latin typeface="Arial" charset="0"/>
@@ -36904,7 +36701,7 @@
                       <a:tailEnd type="none" w="med" len="med"/>
                     </a:lnB>
                     <a:solidFill>
-                      <a:srgbClr val="F8E4E2"/>
+                      <a:srgbClr val="E3F1EA"/>
                     </a:solidFill>
                   </a:tcPr>
                 </a:tc>
@@ -39144,7 +38941,7 @@
                           <a:ea typeface="Arial" pitchFamily="34" charset="-122"/>
                           <a:cs typeface="Arial" pitchFamily="34" charset="-120"/>
                         </a:rPr>
-                        <a:t>+3.860 €</a:t>
+                        <a:t>+9.860 €</a:t>
                       </a:r>
                       <a:endParaRPr lang="en-US" sz="1250" dirty="0">
                         <a:latin typeface="Arial" charset="0"/>
@@ -39212,7 +39009,7 @@
                           <a:ea typeface="Arial" pitchFamily="34" charset="-122"/>
                           <a:cs typeface="Arial" pitchFamily="34" charset="-120"/>
                         </a:rPr>
-                        <a:t>+3.153 €</a:t>
+                        <a:t>+9.153 €</a:t>
                       </a:r>
                       <a:endParaRPr lang="en-US" sz="1250" dirty="0">
                         <a:latin typeface="Arial" charset="0"/>
@@ -39347,7 +39144,7 @@
                           <a:ea typeface="Arial" pitchFamily="34" charset="-122"/>
                           <a:cs typeface="Arial" pitchFamily="34" charset="-120"/>
                         </a:rPr>
-                        <a:t>+5.386 €</a:t>
+                        <a:t>+11.386 €</a:t>
                       </a:r>
                       <a:endParaRPr lang="en-US" sz="1250" dirty="0">
                         <a:latin typeface="Arial" charset="0"/>
@@ -39415,7 +39212,7 @@
                           <a:ea typeface="Arial" pitchFamily="34" charset="-122"/>
                           <a:cs typeface="Arial" pitchFamily="34" charset="-120"/>
                         </a:rPr>
-                        <a:t>+5.170 €</a:t>
+                        <a:t>+11.170 €</a:t>
                       </a:r>
                       <a:endParaRPr lang="en-US" sz="1250" dirty="0">
                         <a:latin typeface="Arial" charset="0"/>
@@ -39550,7 +39347,7 @@
                           <a:ea typeface="Arial" pitchFamily="34" charset="-122"/>
                           <a:cs typeface="Arial" pitchFamily="34" charset="-120"/>
                         </a:rPr>
-                        <a:t>32.341 €</a:t>
+                        <a:t>12.669 €</a:t>
                       </a:r>
                       <a:endParaRPr lang="en-US" sz="1250" dirty="0">
                         <a:latin typeface="Arial" charset="0"/>
@@ -39615,7 +39412,7 @@
                           <a:ea typeface="Arial" pitchFamily="34" charset="-122"/>
                           <a:cs typeface="Arial" pitchFamily="34" charset="-120"/>
                         </a:rPr>
-                        <a:t>33.050 €</a:t>
+                        <a:t>13.378 €</a:t>
                       </a:r>
                       <a:endParaRPr lang="en-US" sz="1250" dirty="0">
                         <a:latin typeface="Arial" charset="0"/>
@@ -43015,7 +42812,7 @@
                           <a:ea typeface="Arial" pitchFamily="34" charset="-122"/>
                           <a:cs typeface="Arial" pitchFamily="34" charset="-120"/>
                         </a:rPr>
-                        <a:t>+3.860 €</a:t>
+                        <a:t>+9.860 €</a:t>
                       </a:r>
                       <a:endParaRPr lang="en-US" sz="1250" dirty="0">
                         <a:latin typeface="Arial" charset="0"/>
@@ -43280,7 +43077,7 @@
                           <a:ea typeface="Arial" pitchFamily="34" charset="-122"/>
                           <a:cs typeface="Arial" pitchFamily="34" charset="-120"/>
                         </a:rPr>
-                        <a:t>+4.295 €</a:t>
+                        <a:t>+10.295 €</a:t>
                       </a:r>
                       <a:endParaRPr lang="en-US" sz="1250" dirty="0">
                         <a:latin typeface="Arial" charset="0"/>
@@ -43545,7 +43342,7 @@
                           <a:ea typeface="Arial" pitchFamily="34" charset="-122"/>
                           <a:cs typeface="Arial" pitchFamily="34" charset="-120"/>
                         </a:rPr>
-                        <a:t>+4.729 €</a:t>
+                        <a:t>+10.729 €</a:t>
                       </a:r>
                       <a:endParaRPr lang="en-US" sz="1250" dirty="0">
                         <a:latin typeface="Arial" charset="0"/>

</xml_diff>

<commit_message>
Nebenkosten werden auf Mieter umgelegt, Hinweise angepasst
Co-Authored-By: Claude Sonnet 5.5 <noreply@anthropic.com>
Claude-Session: https://claude.ai/code/session_01HJGZfxHv7bzYyqdLwg8aFJ
</commit_message>
<xml_diff>
--- a/praesentation/Neue-Mitte-Werlte_Baufeld3_6-Wohnungen_Gastro-EG.pptx
+++ b/praesentation/Neue-Mitte-Werlte_Baufeld3_6-Wohnungen_Gastro-EG.pptx
@@ -18901,7 +18901,7 @@
                 <a:ea typeface="Arial" pitchFamily="34" charset="-122"/>
                 <a:cs typeface="Arial" pitchFamily="34" charset="-120"/>
               </a:rPr>
-              <a:t>Verwaltung, Versicherung, Grundsteuer (ca. 300–500 € im Monat) sind noch nicht enthalten.</a:t>
+              <a:t>Grundsteuer, Gebäudeversicherung und Betriebskosten legt ihr über die Nebenkosten auf die Mieter um. Hausverwaltung und Instandhaltung (nicht umlagefähig) deckt die Rücklage von 10 %.</a:t>
             </a:r>
             <a:endParaRPr lang="en-US" sz="1300" dirty="0"/>
           </a:p>
@@ -28218,7 +28218,7 @@
                 <a:ea typeface="Arial" pitchFamily="34" charset="-122"/>
                 <a:cs typeface="Arial" pitchFamily="34" charset="-120"/>
               </a:rPr>
-              <a:t>Nicht enthalten: Hausverwaltung, Versicherung, Grundsteuer (ca. 300–500 €/Monat)</a:t>
+              <a:t>Nebenkosten (Grundsteuer, Versicherung, Betriebskosten) werden auf die Mieter umgelegt, die Hausverwaltung deckt die Rücklage</a:t>
             </a:r>
             <a:endParaRPr lang="en-US" sz="1500" dirty="0"/>
           </a:p>

</xml_diff>